<commit_message>
Refresh pitch deck and remove former team member
</commit_message>
<xml_diff>
--- a/docs/pitch-deck/carestead-pitch-v2.pptx
+++ b/docs/pitch-deck/carestead-pitch-v2.pptx
@@ -2,28 +2,28 @@
 <file path=ppt/presentation.xml><?xml version="1.0" encoding="utf-8"?>
 <p:presentation xmlns:p="http://schemas.openxmlformats.org/presentationml/2006/main">
   <p:sldMasterIdLst>
-    <p:sldMasterId xmlns:r="http://schemas.openxmlformats.org/officeDocument/2006/relationships" id="2147483648" r:id="R2a4fb4aca8ca467c"/>
+    <p:sldMasterId xmlns:r="http://schemas.openxmlformats.org/officeDocument/2006/relationships" id="2147483648" r:id="R0629ccd56a6b47f3"/>
   </p:sldMasterIdLst>
   <p:notesMasterIdLst>
-    <p:notesMasterId xmlns:r="http://schemas.openxmlformats.org/officeDocument/2006/relationships" r:id="R44da78f91d3342c6"/>
+    <p:notesMasterId xmlns:r="http://schemas.openxmlformats.org/officeDocument/2006/relationships" r:id="Rccc2d089660847b2"/>
   </p:notesMasterIdLst>
   <p:sldIdLst>
-    <p:sldId xmlns:r="http://schemas.openxmlformats.org/officeDocument/2006/relationships" id="256" r:id="R6f2747eafe2e4a6a"/>
-    <p:sldId xmlns:r="http://schemas.openxmlformats.org/officeDocument/2006/relationships" id="257" r:id="R0c8e037a111449c4"/>
-    <p:sldId xmlns:r="http://schemas.openxmlformats.org/officeDocument/2006/relationships" id="258" r:id="Rd800fde8aa3f4157"/>
-    <p:sldId xmlns:r="http://schemas.openxmlformats.org/officeDocument/2006/relationships" id="259" r:id="R5cc13eeee66d48a0"/>
-    <p:sldId xmlns:r="http://schemas.openxmlformats.org/officeDocument/2006/relationships" id="260" r:id="R9c3b5000c7f04f19"/>
-    <p:sldId xmlns:r="http://schemas.openxmlformats.org/officeDocument/2006/relationships" id="261" r:id="R0e8f0b8078a0450a"/>
-    <p:sldId xmlns:r="http://schemas.openxmlformats.org/officeDocument/2006/relationships" id="262" r:id="R6e4aa56936c64517"/>
-    <p:sldId xmlns:r="http://schemas.openxmlformats.org/officeDocument/2006/relationships" id="263" r:id="R8f051da74bac4c7c"/>
-    <p:sldId xmlns:r="http://schemas.openxmlformats.org/officeDocument/2006/relationships" id="264" r:id="R964c5649130b416c"/>
-    <p:sldId xmlns:r="http://schemas.openxmlformats.org/officeDocument/2006/relationships" id="265" r:id="R038c99b9f5ad4c33"/>
-    <p:sldId xmlns:r="http://schemas.openxmlformats.org/officeDocument/2006/relationships" id="266" r:id="Rd0298317194943fd"/>
-    <p:sldId xmlns:r="http://schemas.openxmlformats.org/officeDocument/2006/relationships" id="267" r:id="R013aca78c05b45d0"/>
-    <p:sldId xmlns:r="http://schemas.openxmlformats.org/officeDocument/2006/relationships" id="268" r:id="R66644c7fc5494143"/>
-    <p:sldId xmlns:r="http://schemas.openxmlformats.org/officeDocument/2006/relationships" id="269" r:id="R66d3f754994e451e"/>
-    <p:sldId xmlns:r="http://schemas.openxmlformats.org/officeDocument/2006/relationships" id="270" r:id="R1e6b8f409db24050"/>
-    <p:sldId xmlns:r="http://schemas.openxmlformats.org/officeDocument/2006/relationships" id="271" r:id="R71011a50eda14fa6"/>
+    <p:sldId xmlns:r="http://schemas.openxmlformats.org/officeDocument/2006/relationships" id="256" r:id="R0ba2980647684cbb"/>
+    <p:sldId xmlns:r="http://schemas.openxmlformats.org/officeDocument/2006/relationships" id="257" r:id="R0178cb1664de4aa3"/>
+    <p:sldId xmlns:r="http://schemas.openxmlformats.org/officeDocument/2006/relationships" id="258" r:id="Ref4c19954d594f6c"/>
+    <p:sldId xmlns:r="http://schemas.openxmlformats.org/officeDocument/2006/relationships" id="259" r:id="R87e8cfccd8064391"/>
+    <p:sldId xmlns:r="http://schemas.openxmlformats.org/officeDocument/2006/relationships" id="260" r:id="R01004951d45247e7"/>
+    <p:sldId xmlns:r="http://schemas.openxmlformats.org/officeDocument/2006/relationships" id="261" r:id="R6b6b874256004a8e"/>
+    <p:sldId xmlns:r="http://schemas.openxmlformats.org/officeDocument/2006/relationships" id="262" r:id="R1569fbe1eecd40f2"/>
+    <p:sldId xmlns:r="http://schemas.openxmlformats.org/officeDocument/2006/relationships" id="263" r:id="Rc3737acefd8b44e7"/>
+    <p:sldId xmlns:r="http://schemas.openxmlformats.org/officeDocument/2006/relationships" id="264" r:id="Rcea9e64eb04f4647"/>
+    <p:sldId xmlns:r="http://schemas.openxmlformats.org/officeDocument/2006/relationships" id="265" r:id="Ra6e0c27ac28f459b"/>
+    <p:sldId xmlns:r="http://schemas.openxmlformats.org/officeDocument/2006/relationships" id="266" r:id="Rd77df8c39e514680"/>
+    <p:sldId xmlns:r="http://schemas.openxmlformats.org/officeDocument/2006/relationships" id="267" r:id="R38f8d252159e4ff6"/>
+    <p:sldId xmlns:r="http://schemas.openxmlformats.org/officeDocument/2006/relationships" id="268" r:id="R72ba3e9dd386476d"/>
+    <p:sldId xmlns:r="http://schemas.openxmlformats.org/officeDocument/2006/relationships" id="269" r:id="R13777f91dfbf4089"/>
+    <p:sldId xmlns:r="http://schemas.openxmlformats.org/officeDocument/2006/relationships" id="270" r:id="Rceb5bcbac13845f5"/>
+    <p:sldId xmlns:r="http://schemas.openxmlformats.org/officeDocument/2006/relationships" id="271" r:id="Rb28324b90f484eaa"/>
   </p:sldIdLst>
   <p:sldSz cx="13716000" cy="7715250"/>
   <p:notesSz cx="6858000" cy="9144000"/>
@@ -1575,7 +1575,7 @@
   </p:cSld>
   <p:clrMap bg1="lt1" tx1="dk1" bg2="lt2" tx2="dk2" accent1="accent1" accent2="accent2" accent3="accent3" accent4="accent4" accent5="accent5" accent6="accent6" hlink="hlink" folHlink="folHlink"/>
   <p:sldLayoutIdLst>
-    <p:sldLayoutId xmlns:r="http://schemas.openxmlformats.org/officeDocument/2006/relationships" id="2147483649" r:id="R141e44c37e8d4fc9"/>
+    <p:sldLayoutId xmlns:r="http://schemas.openxmlformats.org/officeDocument/2006/relationships" id="2147483649" r:id="Rbc47bda64246458b"/>
   </p:sldLayoutIdLst>
   <p:txStyles>
     <p:titleStyle>
@@ -2126,7 +2126,7 @@
           <p:cNvPr id="17" name="">
             <a:extLst xmlns:a="http://schemas.openxmlformats.org/drawingml/2006/main">
               <a:ext uri="{FF2B5EF4-FFF2-40B4-BE49-F238E27FC236}">
-                <a16:creationId xmlns:a16="http://schemas.microsoft.com/office/drawing/2014/main" id="{25F03260-1EC5-47B5-907B-AB35ABFE62D8}"/>
+                <a16:creationId xmlns:a16="http://schemas.microsoft.com/office/drawing/2014/main" id="{4D0BDA09-81F0-4F57-AB04-738E3DDF2F2D}"/>
               </a:ext>
             </a:extLst>
           </p:cNvPr>
@@ -2156,7 +2156,7 @@
           <p:cNvPr id="2" name="">
             <a:extLst xmlns:a="http://schemas.openxmlformats.org/drawingml/2006/main">
               <a:ext uri="{FF2B5EF4-FFF2-40B4-BE49-F238E27FC236}">
-                <a16:creationId xmlns:a16="http://schemas.microsoft.com/office/drawing/2014/main" id="{05F5FB7A-22B2-4044-B61A-7C0BF4E33A7C}"/>
+                <a16:creationId xmlns:a16="http://schemas.microsoft.com/office/drawing/2014/main" id="{46542410-2E5B-46F6-BE6D-1CC9D4D653D8}"/>
               </a:ext>
             </a:extLst>
           </p:cNvPr>
@@ -2217,7 +2217,7 @@
           <p:cNvPr id="3" name="">
             <a:extLst xmlns:a="http://schemas.openxmlformats.org/drawingml/2006/main">
               <a:ext uri="{FF2B5EF4-FFF2-40B4-BE49-F238E27FC236}">
-                <a16:creationId xmlns:a16="http://schemas.microsoft.com/office/drawing/2014/main" id="{1AA71DA5-5418-40CA-9296-A0AA2ED9D738}"/>
+                <a16:creationId xmlns:a16="http://schemas.microsoft.com/office/drawing/2014/main" id="{C131AA37-DB3A-4833-87D9-1704215FA34F}"/>
               </a:ext>
             </a:extLst>
           </p:cNvPr>
@@ -2274,7 +2274,7 @@
           <p:cNvPr id="4" name="">
             <a:extLst xmlns:a="http://schemas.openxmlformats.org/drawingml/2006/main">
               <a:ext uri="{FF2B5EF4-FFF2-40B4-BE49-F238E27FC236}">
-                <a16:creationId xmlns:a16="http://schemas.microsoft.com/office/drawing/2014/main" id="{B3E4B2A3-2BF7-4F34-ABD2-F4D03FC60698}"/>
+                <a16:creationId xmlns:a16="http://schemas.microsoft.com/office/drawing/2014/main" id="{A7DA5C0F-956C-48DD-BBDD-847434A3DC79}"/>
               </a:ext>
             </a:extLst>
           </p:cNvPr>
@@ -2331,7 +2331,7 @@
           <p:cNvPr id="5" name="">
             <a:extLst xmlns:a="http://schemas.openxmlformats.org/drawingml/2006/main">
               <a:ext uri="{FF2B5EF4-FFF2-40B4-BE49-F238E27FC236}">
-                <a16:creationId xmlns:a16="http://schemas.microsoft.com/office/drawing/2014/main" id="{EFFDA988-F0D4-4F80-A802-3BACD176666A}"/>
+                <a16:creationId xmlns:a16="http://schemas.microsoft.com/office/drawing/2014/main" id="{49AF7BEF-95A9-4C2A-902C-7B7AE66BEE9F}"/>
               </a:ext>
             </a:extLst>
           </p:cNvPr>
@@ -2388,7 +2388,7 @@
           <p:cNvPr id="6" name="">
             <a:extLst xmlns:a="http://schemas.openxmlformats.org/drawingml/2006/main">
               <a:ext uri="{FF2B5EF4-FFF2-40B4-BE49-F238E27FC236}">
-                <a16:creationId xmlns:a16="http://schemas.microsoft.com/office/drawing/2014/main" id="{8793DF04-8834-48EB-84F5-51B7037DDACB}"/>
+                <a16:creationId xmlns:a16="http://schemas.microsoft.com/office/drawing/2014/main" id="{C7A14BC2-668B-499C-8115-1605C438DC94}"/>
               </a:ext>
             </a:extLst>
           </p:cNvPr>
@@ -2445,7 +2445,7 @@
           <p:cNvPr id="7" name="">
             <a:extLst xmlns:a="http://schemas.openxmlformats.org/drawingml/2006/main">
               <a:ext uri="{FF2B5EF4-FFF2-40B4-BE49-F238E27FC236}">
-                <a16:creationId xmlns:a16="http://schemas.microsoft.com/office/drawing/2014/main" id="{36471B80-03C2-44C3-B3F3-9FEF5BCAF772}"/>
+                <a16:creationId xmlns:a16="http://schemas.microsoft.com/office/drawing/2014/main" id="{6251A6BF-634A-4048-BAE7-8F92B070069B}"/>
               </a:ext>
             </a:extLst>
           </p:cNvPr>
@@ -2502,7 +2502,7 @@
           <p:cNvPr id="8" name="">
             <a:extLst xmlns:a="http://schemas.openxmlformats.org/drawingml/2006/main">
               <a:ext uri="{FF2B5EF4-FFF2-40B4-BE49-F238E27FC236}">
-                <a16:creationId xmlns:a16="http://schemas.microsoft.com/office/drawing/2014/main" id="{EE622AD2-E352-420C-A4C5-EC3715589CBF}"/>
+                <a16:creationId xmlns:a16="http://schemas.microsoft.com/office/drawing/2014/main" id="{E0CFE947-2E38-47A4-8529-4A019C384615}"/>
               </a:ext>
             </a:extLst>
           </p:cNvPr>
@@ -2582,7 +2582,7 @@
           <p:cNvPr id="9" name="">
             <a:extLst xmlns:a="http://schemas.openxmlformats.org/drawingml/2006/main">
               <a:ext uri="{FF2B5EF4-FFF2-40B4-BE49-F238E27FC236}">
-                <a16:creationId xmlns:a16="http://schemas.microsoft.com/office/drawing/2014/main" id="{C01B570E-43B0-435E-8C43-E95250796BA3}"/>
+                <a16:creationId xmlns:a16="http://schemas.microsoft.com/office/drawing/2014/main" id="{87A0E8DB-CC29-493E-A9E5-70BD89EF0C6C}"/>
               </a:ext>
             </a:extLst>
           </p:cNvPr>
@@ -2662,7 +2662,7 @@
           <p:cNvPr id="10" name="">
             <a:extLst xmlns:a="http://schemas.openxmlformats.org/drawingml/2006/main">
               <a:ext uri="{FF2B5EF4-FFF2-40B4-BE49-F238E27FC236}">
-                <a16:creationId xmlns:a16="http://schemas.microsoft.com/office/drawing/2014/main" id="{DF496457-053F-439F-9C50-252126E2C469}"/>
+                <a16:creationId xmlns:a16="http://schemas.microsoft.com/office/drawing/2014/main" id="{FF6AF4B0-123B-48AC-BCC2-06DC5AA9871C}"/>
               </a:ext>
             </a:extLst>
           </p:cNvPr>
@@ -2692,7 +2692,7 @@
           <p:cNvPr id="11" name="">
             <a:extLst xmlns:a="http://schemas.openxmlformats.org/drawingml/2006/main">
               <a:ext uri="{FF2B5EF4-FFF2-40B4-BE49-F238E27FC236}">
-                <a16:creationId xmlns:a16="http://schemas.microsoft.com/office/drawing/2014/main" id="{CF8C3DFD-DA20-423C-9811-53122FFF2592}"/>
+                <a16:creationId xmlns:a16="http://schemas.microsoft.com/office/drawing/2014/main" id="{5FDA8BAA-7882-461D-81BE-3BE1243214C3}"/>
               </a:ext>
             </a:extLst>
           </p:cNvPr>
@@ -2749,7 +2749,7 @@
           <p:cNvPr id="12" name="">
             <a:extLst xmlns:a="http://schemas.openxmlformats.org/drawingml/2006/main">
               <a:ext uri="{FF2B5EF4-FFF2-40B4-BE49-F238E27FC236}">
-                <a16:creationId xmlns:a16="http://schemas.microsoft.com/office/drawing/2014/main" id="{AC2746A7-2F61-4846-ABAB-68ADE2410E0E}"/>
+                <a16:creationId xmlns:a16="http://schemas.microsoft.com/office/drawing/2014/main" id="{99607BEE-2913-4A3C-8097-CC254FABE427}"/>
               </a:ext>
             </a:extLst>
           </p:cNvPr>
@@ -2806,7 +2806,7 @@
           <p:cNvPr id="13" name="">
             <a:extLst xmlns:a="http://schemas.openxmlformats.org/drawingml/2006/main">
               <a:ext uri="{FF2B5EF4-FFF2-40B4-BE49-F238E27FC236}">
-                <a16:creationId xmlns:a16="http://schemas.microsoft.com/office/drawing/2014/main" id="{E014C5C2-E1F1-4737-8E96-45828202D40F}"/>
+                <a16:creationId xmlns:a16="http://schemas.microsoft.com/office/drawing/2014/main" id="{36E1DFC1-3062-4722-9171-01CE3E5B2C67}"/>
               </a:ext>
             </a:extLst>
           </p:cNvPr>
@@ -2863,7 +2863,7 @@
           <p:cNvPr id="14" name="">
             <a:extLst xmlns:a="http://schemas.openxmlformats.org/drawingml/2006/main">
               <a:ext uri="{FF2B5EF4-FFF2-40B4-BE49-F238E27FC236}">
-                <a16:creationId xmlns:a16="http://schemas.microsoft.com/office/drawing/2014/main" id="{7CF2888C-110A-441E-A070-C0E03C51EAF3}"/>
+                <a16:creationId xmlns:a16="http://schemas.microsoft.com/office/drawing/2014/main" id="{90897AE4-CBB3-479D-9CC6-492E85762A9C}"/>
               </a:ext>
             </a:extLst>
           </p:cNvPr>
@@ -2920,7 +2920,7 @@
           <p:cNvPr id="15" name="">
             <a:extLst xmlns:a="http://schemas.openxmlformats.org/drawingml/2006/main">
               <a:ext uri="{FF2B5EF4-FFF2-40B4-BE49-F238E27FC236}">
-                <a16:creationId xmlns:a16="http://schemas.microsoft.com/office/drawing/2014/main" id="{5C8A5554-CE15-4B09-A771-8C1F16DA249B}"/>
+                <a16:creationId xmlns:a16="http://schemas.microsoft.com/office/drawing/2014/main" id="{83BF45A1-0B72-4559-B35D-73FD82FAF3D8}"/>
               </a:ext>
             </a:extLst>
           </p:cNvPr>
@@ -2977,7 +2977,7 @@
           <p:cNvPr id="16" name="">
             <a:extLst xmlns:a="http://schemas.openxmlformats.org/drawingml/2006/main">
               <a:ext uri="{FF2B5EF4-FFF2-40B4-BE49-F238E27FC236}">
-                <a16:creationId xmlns:a16="http://schemas.microsoft.com/office/drawing/2014/main" id="{53BAAD18-A6CA-4B8C-B405-C59D071C20C8}"/>
+                <a16:creationId xmlns:a16="http://schemas.microsoft.com/office/drawing/2014/main" id="{14B5E30A-AD61-415A-8553-7EB7355E307E}"/>
               </a:ext>
             </a:extLst>
           </p:cNvPr>
@@ -3024,7 +3024,7 @@
                 <a:ea typeface="Avenir Next"/>
                 <a:cs typeface="Avenir Next"/>
               </a:rPr>
-              <a:t>Frincy Clement · Maneetta Antony · Tejaswini Venkata Raju · Shrijan Chipalu</a:t>
+              <a:t>Frincy Clement · Maneetta Antony · Tejaswini Venkata Raju</a:t>
             </a:r>
           </a:p>
         </p:txBody>
@@ -3032,7 +3032,7 @@
     </p:spTree>
     <p:extLst>
       <p:ext uri="{BB962C8B-B14F-4D97-AF65-F5344CB8AC3E}">
-        <p14:creationId xmlns:p14="http://schemas.microsoft.com/office/powerpoint/2010/main" val="173270335"/>
+        <p14:creationId xmlns:p14="http://schemas.microsoft.com/office/powerpoint/2010/main" val="236391304"/>
       </p:ext>
     </p:extLst>
   </p:cSld>
@@ -3063,7 +3063,7 @@
           <p:cNvPr id="58" name="">
             <a:extLst xmlns:a="http://schemas.openxmlformats.org/drawingml/2006/main">
               <a:ext uri="{FF2B5EF4-FFF2-40B4-BE49-F238E27FC236}">
-                <a16:creationId xmlns:a16="http://schemas.microsoft.com/office/drawing/2014/main" id="{81460101-0264-4634-84D8-D935C52156F8}"/>
+                <a16:creationId xmlns:a16="http://schemas.microsoft.com/office/drawing/2014/main" id="{1D954442-6C87-4438-A13D-5E4FF82FD6B0}"/>
               </a:ext>
             </a:extLst>
           </p:cNvPr>
@@ -3093,7 +3093,7 @@
           <p:cNvPr id="2" name="">
             <a:extLst xmlns:a="http://schemas.openxmlformats.org/drawingml/2006/main">
               <a:ext uri="{FF2B5EF4-FFF2-40B4-BE49-F238E27FC236}">
-                <a16:creationId xmlns:a16="http://schemas.microsoft.com/office/drawing/2014/main" id="{570027C4-90AD-43EF-99DE-BB040D164833}"/>
+                <a16:creationId xmlns:a16="http://schemas.microsoft.com/office/drawing/2014/main" id="{258A259E-A092-424A-978E-9637242E6650}"/>
               </a:ext>
             </a:extLst>
           </p:cNvPr>
@@ -3154,7 +3154,7 @@
           <p:cNvPr id="3" name="">
             <a:extLst xmlns:a="http://schemas.openxmlformats.org/drawingml/2006/main">
               <a:ext uri="{FF2B5EF4-FFF2-40B4-BE49-F238E27FC236}">
-                <a16:creationId xmlns:a16="http://schemas.microsoft.com/office/drawing/2014/main" id="{9655CC7B-1CC3-4FE8-B408-59262342B5A8}"/>
+                <a16:creationId xmlns:a16="http://schemas.microsoft.com/office/drawing/2014/main" id="{7842C93C-4854-4795-ADD9-82396712BDC7}"/>
               </a:ext>
             </a:extLst>
           </p:cNvPr>
@@ -3211,7 +3211,7 @@
           <p:cNvPr id="4" name="">
             <a:extLst xmlns:a="http://schemas.openxmlformats.org/drawingml/2006/main">
               <a:ext uri="{FF2B5EF4-FFF2-40B4-BE49-F238E27FC236}">
-                <a16:creationId xmlns:a16="http://schemas.microsoft.com/office/drawing/2014/main" id="{973C3E9F-1C7F-4265-A678-B053F6D4AA38}"/>
+                <a16:creationId xmlns:a16="http://schemas.microsoft.com/office/drawing/2014/main" id="{96364328-9D2C-43B3-9FDD-243B0B4F85B0}"/>
               </a:ext>
             </a:extLst>
           </p:cNvPr>
@@ -3268,7 +3268,7 @@
           <p:cNvPr id="5" name="">
             <a:extLst xmlns:a="http://schemas.openxmlformats.org/drawingml/2006/main">
               <a:ext uri="{FF2B5EF4-FFF2-40B4-BE49-F238E27FC236}">
-                <a16:creationId xmlns:a16="http://schemas.microsoft.com/office/drawing/2014/main" id="{866AAAFB-4EA4-41F2-914F-9052743C3D0F}"/>
+                <a16:creationId xmlns:a16="http://schemas.microsoft.com/office/drawing/2014/main" id="{3513526E-1C2E-4B55-B19B-A842E8CFEF37}"/>
               </a:ext>
             </a:extLst>
           </p:cNvPr>
@@ -3325,7 +3325,7 @@
           <p:cNvPr id="6" name="">
             <a:extLst xmlns:a="http://schemas.openxmlformats.org/drawingml/2006/main">
               <a:ext uri="{FF2B5EF4-FFF2-40B4-BE49-F238E27FC236}">
-                <a16:creationId xmlns:a16="http://schemas.microsoft.com/office/drawing/2014/main" id="{A5E89DCD-EB97-42D8-850C-D558869C1293}"/>
+                <a16:creationId xmlns:a16="http://schemas.microsoft.com/office/drawing/2014/main" id="{7D0ED187-0B2A-4041-AE57-A4299F0D6BC3}"/>
               </a:ext>
             </a:extLst>
           </p:cNvPr>
@@ -3382,7 +3382,7 @@
           <p:cNvPr id="7" name="">
             <a:extLst xmlns:a="http://schemas.openxmlformats.org/drawingml/2006/main">
               <a:ext uri="{FF2B5EF4-FFF2-40B4-BE49-F238E27FC236}">
-                <a16:creationId xmlns:a16="http://schemas.microsoft.com/office/drawing/2014/main" id="{C3344B89-2F53-4A78-BF6C-FE8FAFBD56F9}"/>
+                <a16:creationId xmlns:a16="http://schemas.microsoft.com/office/drawing/2014/main" id="{3BA3ECBF-69CD-4324-85AB-20D6270310F4}"/>
               </a:ext>
             </a:extLst>
           </p:cNvPr>
@@ -3439,7 +3439,7 @@
           <p:cNvPr id="8" name="">
             <a:extLst xmlns:a="http://schemas.openxmlformats.org/drawingml/2006/main">
               <a:ext uri="{FF2B5EF4-FFF2-40B4-BE49-F238E27FC236}">
-                <a16:creationId xmlns:a16="http://schemas.microsoft.com/office/drawing/2014/main" id="{E36BE821-ED14-4A7A-98FE-AF566946014B}"/>
+                <a16:creationId xmlns:a16="http://schemas.microsoft.com/office/drawing/2014/main" id="{720A0496-86D1-4FA3-8CDE-08E83C7F16C7}"/>
               </a:ext>
             </a:extLst>
           </p:cNvPr>
@@ -3496,7 +3496,7 @@
           <p:cNvPr id="9" name="">
             <a:extLst xmlns:a="http://schemas.openxmlformats.org/drawingml/2006/main">
               <a:ext uri="{FF2B5EF4-FFF2-40B4-BE49-F238E27FC236}">
-                <a16:creationId xmlns:a16="http://schemas.microsoft.com/office/drawing/2014/main" id="{08F25774-665B-47E6-8BD0-E4979BFA3995}"/>
+                <a16:creationId xmlns:a16="http://schemas.microsoft.com/office/drawing/2014/main" id="{1885F7D7-ADC8-4F95-B1C2-07754EFE0233}"/>
               </a:ext>
             </a:extLst>
           </p:cNvPr>
@@ -3553,7 +3553,7 @@
           <p:cNvPr id="10" name="">
             <a:extLst xmlns:a="http://schemas.openxmlformats.org/drawingml/2006/main">
               <a:ext uri="{FF2B5EF4-FFF2-40B4-BE49-F238E27FC236}">
-                <a16:creationId xmlns:a16="http://schemas.microsoft.com/office/drawing/2014/main" id="{2F77181F-9B0C-4C2F-9A50-A8E0B4664F05}"/>
+                <a16:creationId xmlns:a16="http://schemas.microsoft.com/office/drawing/2014/main" id="{8953B8D8-AF02-4ED9-8CC9-0E570C4F649E}"/>
               </a:ext>
             </a:extLst>
           </p:cNvPr>
@@ -3587,7 +3587,7 @@
           <p:cNvPr id="11" name="">
             <a:extLst xmlns:a="http://schemas.openxmlformats.org/drawingml/2006/main">
               <a:ext uri="{FF2B5EF4-FFF2-40B4-BE49-F238E27FC236}">
-                <a16:creationId xmlns:a16="http://schemas.microsoft.com/office/drawing/2014/main" id="{C03947FD-CD87-4624-A992-9CF93698BD73}"/>
+                <a16:creationId xmlns:a16="http://schemas.microsoft.com/office/drawing/2014/main" id="{E2551CD3-F282-4A1E-9736-A783DEF3B15A}"/>
               </a:ext>
             </a:extLst>
           </p:cNvPr>
@@ -3644,7 +3644,7 @@
           <p:cNvPr id="12" name="">
             <a:extLst xmlns:a="http://schemas.openxmlformats.org/drawingml/2006/main">
               <a:ext uri="{FF2B5EF4-FFF2-40B4-BE49-F238E27FC236}">
-                <a16:creationId xmlns:a16="http://schemas.microsoft.com/office/drawing/2014/main" id="{34A498F8-6FCC-4A38-8C0E-D791535A30AA}"/>
+                <a16:creationId xmlns:a16="http://schemas.microsoft.com/office/drawing/2014/main" id="{CBDDA188-3678-46AD-A866-63894DCD8540}"/>
               </a:ext>
             </a:extLst>
           </p:cNvPr>
@@ -3678,7 +3678,7 @@
           <p:cNvPr id="13" name="">
             <a:extLst xmlns:a="http://schemas.openxmlformats.org/drawingml/2006/main">
               <a:ext uri="{FF2B5EF4-FFF2-40B4-BE49-F238E27FC236}">
-                <a16:creationId xmlns:a16="http://schemas.microsoft.com/office/drawing/2014/main" id="{CFFFF9BE-B43E-4889-8CE4-12862881996F}"/>
+                <a16:creationId xmlns:a16="http://schemas.microsoft.com/office/drawing/2014/main" id="{C33BC303-D463-4CB8-8712-DDCE2132497D}"/>
               </a:ext>
             </a:extLst>
           </p:cNvPr>
@@ -3735,7 +3735,7 @@
           <p:cNvPr id="14" name="">
             <a:extLst xmlns:a="http://schemas.openxmlformats.org/drawingml/2006/main">
               <a:ext uri="{FF2B5EF4-FFF2-40B4-BE49-F238E27FC236}">
-                <a16:creationId xmlns:a16="http://schemas.microsoft.com/office/drawing/2014/main" id="{75419C9F-4CC0-43D6-A55B-CCD6D6E74266}"/>
+                <a16:creationId xmlns:a16="http://schemas.microsoft.com/office/drawing/2014/main" id="{87D2EF60-557B-4D9B-888A-8AE9936B9B37}"/>
               </a:ext>
             </a:extLst>
           </p:cNvPr>
@@ -3792,7 +3792,7 @@
           <p:cNvPr id="15" name="">
             <a:extLst xmlns:a="http://schemas.openxmlformats.org/drawingml/2006/main">
               <a:ext uri="{FF2B5EF4-FFF2-40B4-BE49-F238E27FC236}">
-                <a16:creationId xmlns:a16="http://schemas.microsoft.com/office/drawing/2014/main" id="{B82C4304-D869-4474-9819-7DBC0634D041}"/>
+                <a16:creationId xmlns:a16="http://schemas.microsoft.com/office/drawing/2014/main" id="{D7F57911-FBF3-4265-A78D-5A0C6DBF6240}"/>
               </a:ext>
             </a:extLst>
           </p:cNvPr>
@@ -3849,7 +3849,7 @@
           <p:cNvPr id="16" name="">
             <a:extLst xmlns:a="http://schemas.openxmlformats.org/drawingml/2006/main">
               <a:ext uri="{FF2B5EF4-FFF2-40B4-BE49-F238E27FC236}">
-                <a16:creationId xmlns:a16="http://schemas.microsoft.com/office/drawing/2014/main" id="{761712CF-F00E-43D1-808D-585D0F18BD1B}"/>
+                <a16:creationId xmlns:a16="http://schemas.microsoft.com/office/drawing/2014/main" id="{AD788FAC-9E7D-42B7-9CED-65256AB2BA07}"/>
               </a:ext>
             </a:extLst>
           </p:cNvPr>
@@ -3883,7 +3883,7 @@
           <p:cNvPr id="17" name="">
             <a:extLst xmlns:a="http://schemas.openxmlformats.org/drawingml/2006/main">
               <a:ext uri="{FF2B5EF4-FFF2-40B4-BE49-F238E27FC236}">
-                <a16:creationId xmlns:a16="http://schemas.microsoft.com/office/drawing/2014/main" id="{AE6548EC-60D2-4E3F-8BF2-87CA04A0A1D4}"/>
+                <a16:creationId xmlns:a16="http://schemas.microsoft.com/office/drawing/2014/main" id="{FAB18DB5-5883-4EEF-8E1E-92FD7ACFE81E}"/>
               </a:ext>
             </a:extLst>
           </p:cNvPr>
@@ -3940,7 +3940,7 @@
           <p:cNvPr id="18" name="">
             <a:extLst xmlns:a="http://schemas.openxmlformats.org/drawingml/2006/main">
               <a:ext uri="{FF2B5EF4-FFF2-40B4-BE49-F238E27FC236}">
-                <a16:creationId xmlns:a16="http://schemas.microsoft.com/office/drawing/2014/main" id="{2E61DCF0-936D-4399-B082-440B3B2513E7}"/>
+                <a16:creationId xmlns:a16="http://schemas.microsoft.com/office/drawing/2014/main" id="{AF5951CA-9F90-4D8A-8D10-C25BCD587735}"/>
               </a:ext>
             </a:extLst>
           </p:cNvPr>
@@ -3974,7 +3974,7 @@
           <p:cNvPr id="19" name="">
             <a:extLst xmlns:a="http://schemas.openxmlformats.org/drawingml/2006/main">
               <a:ext uri="{FF2B5EF4-FFF2-40B4-BE49-F238E27FC236}">
-                <a16:creationId xmlns:a16="http://schemas.microsoft.com/office/drawing/2014/main" id="{55C26F5F-3CB7-4678-9E0F-0DE2ADE48B9A}"/>
+                <a16:creationId xmlns:a16="http://schemas.microsoft.com/office/drawing/2014/main" id="{34B9B51C-603E-4231-8650-AA211A960D92}"/>
               </a:ext>
             </a:extLst>
           </p:cNvPr>
@@ -4031,7 +4031,7 @@
           <p:cNvPr id="20" name="">
             <a:extLst xmlns:a="http://schemas.openxmlformats.org/drawingml/2006/main">
               <a:ext uri="{FF2B5EF4-FFF2-40B4-BE49-F238E27FC236}">
-                <a16:creationId xmlns:a16="http://schemas.microsoft.com/office/drawing/2014/main" id="{2C36DA0B-E7FD-4745-AE4A-6D00900A009F}"/>
+                <a16:creationId xmlns:a16="http://schemas.microsoft.com/office/drawing/2014/main" id="{8C9E1882-4C9B-434C-B555-F3A0B098F6FD}"/>
               </a:ext>
             </a:extLst>
           </p:cNvPr>
@@ -4088,7 +4088,7 @@
           <p:cNvPr id="21" name="">
             <a:extLst xmlns:a="http://schemas.openxmlformats.org/drawingml/2006/main">
               <a:ext uri="{FF2B5EF4-FFF2-40B4-BE49-F238E27FC236}">
-                <a16:creationId xmlns:a16="http://schemas.microsoft.com/office/drawing/2014/main" id="{97DBF69B-5C70-4363-832C-033A8F9EFAB9}"/>
+                <a16:creationId xmlns:a16="http://schemas.microsoft.com/office/drawing/2014/main" id="{C6DCB3B4-8630-481C-AE2F-6FA7BD1FB196}"/>
               </a:ext>
             </a:extLst>
           </p:cNvPr>
@@ -4145,7 +4145,7 @@
           <p:cNvPr id="22" name="">
             <a:extLst xmlns:a="http://schemas.openxmlformats.org/drawingml/2006/main">
               <a:ext uri="{FF2B5EF4-FFF2-40B4-BE49-F238E27FC236}">
-                <a16:creationId xmlns:a16="http://schemas.microsoft.com/office/drawing/2014/main" id="{DBD45488-1CEB-4476-B42B-6E5FAB782F45}"/>
+                <a16:creationId xmlns:a16="http://schemas.microsoft.com/office/drawing/2014/main" id="{4A12B055-D65E-4F44-8890-C2887E01D28E}"/>
               </a:ext>
             </a:extLst>
           </p:cNvPr>
@@ -4179,7 +4179,7 @@
           <p:cNvPr id="23" name="">
             <a:extLst xmlns:a="http://schemas.openxmlformats.org/drawingml/2006/main">
               <a:ext uri="{FF2B5EF4-FFF2-40B4-BE49-F238E27FC236}">
-                <a16:creationId xmlns:a16="http://schemas.microsoft.com/office/drawing/2014/main" id="{E91689DF-8945-43E3-BC47-FE1906F98443}"/>
+                <a16:creationId xmlns:a16="http://schemas.microsoft.com/office/drawing/2014/main" id="{62C18590-4D3B-48CF-B4D6-4D22F83C7CF4}"/>
               </a:ext>
             </a:extLst>
           </p:cNvPr>
@@ -4236,7 +4236,7 @@
           <p:cNvPr id="24" name="">
             <a:extLst xmlns:a="http://schemas.openxmlformats.org/drawingml/2006/main">
               <a:ext uri="{FF2B5EF4-FFF2-40B4-BE49-F238E27FC236}">
-                <a16:creationId xmlns:a16="http://schemas.microsoft.com/office/drawing/2014/main" id="{85EBEF67-5EC6-43C9-8760-29737DB876EF}"/>
+                <a16:creationId xmlns:a16="http://schemas.microsoft.com/office/drawing/2014/main" id="{3094B2E7-D63C-4804-BD23-D8B2CFD7DF6D}"/>
               </a:ext>
             </a:extLst>
           </p:cNvPr>
@@ -4270,7 +4270,7 @@
           <p:cNvPr id="25" name="">
             <a:extLst xmlns:a="http://schemas.openxmlformats.org/drawingml/2006/main">
               <a:ext uri="{FF2B5EF4-FFF2-40B4-BE49-F238E27FC236}">
-                <a16:creationId xmlns:a16="http://schemas.microsoft.com/office/drawing/2014/main" id="{1E1EF98F-E19B-4523-9809-C355A0030F7B}"/>
+                <a16:creationId xmlns:a16="http://schemas.microsoft.com/office/drawing/2014/main" id="{4C6E5930-3676-496E-97A5-562AD2D738A2}"/>
               </a:ext>
             </a:extLst>
           </p:cNvPr>
@@ -4327,7 +4327,7 @@
           <p:cNvPr id="26" name="">
             <a:extLst xmlns:a="http://schemas.openxmlformats.org/drawingml/2006/main">
               <a:ext uri="{FF2B5EF4-FFF2-40B4-BE49-F238E27FC236}">
-                <a16:creationId xmlns:a16="http://schemas.microsoft.com/office/drawing/2014/main" id="{404EE421-B4A7-4C5C-9646-5C36A7E3927E}"/>
+                <a16:creationId xmlns:a16="http://schemas.microsoft.com/office/drawing/2014/main" id="{900BC421-3BF6-4AB5-8982-0F12EB9ACF71}"/>
               </a:ext>
             </a:extLst>
           </p:cNvPr>
@@ -4384,7 +4384,7 @@
           <p:cNvPr id="27" name="">
             <a:extLst xmlns:a="http://schemas.openxmlformats.org/drawingml/2006/main">
               <a:ext uri="{FF2B5EF4-FFF2-40B4-BE49-F238E27FC236}">
-                <a16:creationId xmlns:a16="http://schemas.microsoft.com/office/drawing/2014/main" id="{FC211C1B-1941-4A3F-94EF-4894740B26A1}"/>
+                <a16:creationId xmlns:a16="http://schemas.microsoft.com/office/drawing/2014/main" id="{0E3BF78B-E7A9-401F-B1A0-27B6DD02F3A2}"/>
               </a:ext>
             </a:extLst>
           </p:cNvPr>
@@ -4441,7 +4441,7 @@
           <p:cNvPr id="28" name="">
             <a:extLst xmlns:a="http://schemas.openxmlformats.org/drawingml/2006/main">
               <a:ext uri="{FF2B5EF4-FFF2-40B4-BE49-F238E27FC236}">
-                <a16:creationId xmlns:a16="http://schemas.microsoft.com/office/drawing/2014/main" id="{B77C5F15-4012-47F5-8436-8CCFADA71A26}"/>
+                <a16:creationId xmlns:a16="http://schemas.microsoft.com/office/drawing/2014/main" id="{265FD510-A9F4-4D74-BD4C-4BE3F01E7443}"/>
               </a:ext>
             </a:extLst>
           </p:cNvPr>
@@ -4475,7 +4475,7 @@
           <p:cNvPr id="29" name="">
             <a:extLst xmlns:a="http://schemas.openxmlformats.org/drawingml/2006/main">
               <a:ext uri="{FF2B5EF4-FFF2-40B4-BE49-F238E27FC236}">
-                <a16:creationId xmlns:a16="http://schemas.microsoft.com/office/drawing/2014/main" id="{22582CAD-E807-4AC4-9EA6-98594BE8D9B6}"/>
+                <a16:creationId xmlns:a16="http://schemas.microsoft.com/office/drawing/2014/main" id="{82F08EEA-2B8C-4730-B176-180BDA2DEEA6}"/>
               </a:ext>
             </a:extLst>
           </p:cNvPr>
@@ -4532,7 +4532,7 @@
           <p:cNvPr id="30" name="">
             <a:extLst xmlns:a="http://schemas.openxmlformats.org/drawingml/2006/main">
               <a:ext uri="{FF2B5EF4-FFF2-40B4-BE49-F238E27FC236}">
-                <a16:creationId xmlns:a16="http://schemas.microsoft.com/office/drawing/2014/main" id="{E165CB29-716C-47C1-A760-38286EF14E81}"/>
+                <a16:creationId xmlns:a16="http://schemas.microsoft.com/office/drawing/2014/main" id="{62C68EF5-2450-4AFE-9D6F-0C614F121AC6}"/>
               </a:ext>
             </a:extLst>
           </p:cNvPr>
@@ -4566,7 +4566,7 @@
           <p:cNvPr id="31" name="">
             <a:extLst xmlns:a="http://schemas.openxmlformats.org/drawingml/2006/main">
               <a:ext uri="{FF2B5EF4-FFF2-40B4-BE49-F238E27FC236}">
-                <a16:creationId xmlns:a16="http://schemas.microsoft.com/office/drawing/2014/main" id="{FE53B620-9283-4403-BDAF-F7DD0605F747}"/>
+                <a16:creationId xmlns:a16="http://schemas.microsoft.com/office/drawing/2014/main" id="{0DF157DE-1611-4776-B3A6-90E25DE97691}"/>
               </a:ext>
             </a:extLst>
           </p:cNvPr>
@@ -4623,7 +4623,7 @@
           <p:cNvPr id="32" name="">
             <a:extLst xmlns:a="http://schemas.openxmlformats.org/drawingml/2006/main">
               <a:ext uri="{FF2B5EF4-FFF2-40B4-BE49-F238E27FC236}">
-                <a16:creationId xmlns:a16="http://schemas.microsoft.com/office/drawing/2014/main" id="{1956D484-D831-4040-984D-FF27033D8251}"/>
+                <a16:creationId xmlns:a16="http://schemas.microsoft.com/office/drawing/2014/main" id="{26A3D3C3-3D48-4F6E-81E5-C1BDEBB30C29}"/>
               </a:ext>
             </a:extLst>
           </p:cNvPr>
@@ -4680,7 +4680,7 @@
           <p:cNvPr id="33" name="">
             <a:extLst xmlns:a="http://schemas.openxmlformats.org/drawingml/2006/main">
               <a:ext uri="{FF2B5EF4-FFF2-40B4-BE49-F238E27FC236}">
-                <a16:creationId xmlns:a16="http://schemas.microsoft.com/office/drawing/2014/main" id="{D2367210-0AD7-4FC7-B504-166B7E746337}"/>
+                <a16:creationId xmlns:a16="http://schemas.microsoft.com/office/drawing/2014/main" id="{C03BFBED-B2DC-4F06-8AFD-B16C3F5FE4FA}"/>
               </a:ext>
             </a:extLst>
           </p:cNvPr>
@@ -4737,7 +4737,7 @@
           <p:cNvPr id="34" name="">
             <a:extLst xmlns:a="http://schemas.openxmlformats.org/drawingml/2006/main">
               <a:ext uri="{FF2B5EF4-FFF2-40B4-BE49-F238E27FC236}">
-                <a16:creationId xmlns:a16="http://schemas.microsoft.com/office/drawing/2014/main" id="{A5E66908-73F2-405C-85C6-EE26FB12F601}"/>
+                <a16:creationId xmlns:a16="http://schemas.microsoft.com/office/drawing/2014/main" id="{A4A49D93-025F-4917-849A-6AE898D196EF}"/>
               </a:ext>
             </a:extLst>
           </p:cNvPr>
@@ -4771,7 +4771,7 @@
           <p:cNvPr id="35" name="">
             <a:extLst xmlns:a="http://schemas.openxmlformats.org/drawingml/2006/main">
               <a:ext uri="{FF2B5EF4-FFF2-40B4-BE49-F238E27FC236}">
-                <a16:creationId xmlns:a16="http://schemas.microsoft.com/office/drawing/2014/main" id="{2F60DB71-5AB3-40A5-B653-953378500F1D}"/>
+                <a16:creationId xmlns:a16="http://schemas.microsoft.com/office/drawing/2014/main" id="{2F34BC0E-B52C-4F49-B5B2-2BE9165CA911}"/>
               </a:ext>
             </a:extLst>
           </p:cNvPr>
@@ -4828,7 +4828,7 @@
           <p:cNvPr id="36" name="">
             <a:extLst xmlns:a="http://schemas.openxmlformats.org/drawingml/2006/main">
               <a:ext uri="{FF2B5EF4-FFF2-40B4-BE49-F238E27FC236}">
-                <a16:creationId xmlns:a16="http://schemas.microsoft.com/office/drawing/2014/main" id="{6C0B2A63-2D71-4C15-BDD5-278411853E1E}"/>
+                <a16:creationId xmlns:a16="http://schemas.microsoft.com/office/drawing/2014/main" id="{E513B1F4-91CB-4561-A1D5-87FF41F75D3C}"/>
               </a:ext>
             </a:extLst>
           </p:cNvPr>
@@ -4862,7 +4862,7 @@
           <p:cNvPr id="37" name="">
             <a:extLst xmlns:a="http://schemas.openxmlformats.org/drawingml/2006/main">
               <a:ext uri="{FF2B5EF4-FFF2-40B4-BE49-F238E27FC236}">
-                <a16:creationId xmlns:a16="http://schemas.microsoft.com/office/drawing/2014/main" id="{91CEB5EA-358F-4395-B95E-3CDD3E7B683B}"/>
+                <a16:creationId xmlns:a16="http://schemas.microsoft.com/office/drawing/2014/main" id="{EDE98967-EA87-4432-9372-BA52486AB1A1}"/>
               </a:ext>
             </a:extLst>
           </p:cNvPr>
@@ -4919,7 +4919,7 @@
           <p:cNvPr id="38" name="">
             <a:extLst xmlns:a="http://schemas.openxmlformats.org/drawingml/2006/main">
               <a:ext uri="{FF2B5EF4-FFF2-40B4-BE49-F238E27FC236}">
-                <a16:creationId xmlns:a16="http://schemas.microsoft.com/office/drawing/2014/main" id="{980C74F7-5102-411A-8812-4D83ADCFF3CB}"/>
+                <a16:creationId xmlns:a16="http://schemas.microsoft.com/office/drawing/2014/main" id="{2F3A1CB3-B076-4FD7-9A0E-A396F9C18724}"/>
               </a:ext>
             </a:extLst>
           </p:cNvPr>
@@ -4976,7 +4976,7 @@
           <p:cNvPr id="39" name="">
             <a:extLst xmlns:a="http://schemas.openxmlformats.org/drawingml/2006/main">
               <a:ext uri="{FF2B5EF4-FFF2-40B4-BE49-F238E27FC236}">
-                <a16:creationId xmlns:a16="http://schemas.microsoft.com/office/drawing/2014/main" id="{6F8E52B9-29EF-4FE0-9368-EB692B3145B8}"/>
+                <a16:creationId xmlns:a16="http://schemas.microsoft.com/office/drawing/2014/main" id="{C9658CC9-9C43-40DA-A4C9-7C424B5DCD05}"/>
               </a:ext>
             </a:extLst>
           </p:cNvPr>
@@ -5033,7 +5033,7 @@
           <p:cNvPr id="40" name="">
             <a:extLst xmlns:a="http://schemas.openxmlformats.org/drawingml/2006/main">
               <a:ext uri="{FF2B5EF4-FFF2-40B4-BE49-F238E27FC236}">
-                <a16:creationId xmlns:a16="http://schemas.microsoft.com/office/drawing/2014/main" id="{D34F4B23-CA25-4607-B693-D5BB66630053}"/>
+                <a16:creationId xmlns:a16="http://schemas.microsoft.com/office/drawing/2014/main" id="{831393D4-8A43-4926-AF43-1ACCA6F66AB7}"/>
               </a:ext>
             </a:extLst>
           </p:cNvPr>
@@ -5067,7 +5067,7 @@
           <p:cNvPr id="41" name="">
             <a:extLst xmlns:a="http://schemas.openxmlformats.org/drawingml/2006/main">
               <a:ext uri="{FF2B5EF4-FFF2-40B4-BE49-F238E27FC236}">
-                <a16:creationId xmlns:a16="http://schemas.microsoft.com/office/drawing/2014/main" id="{782D1D01-1F3E-4EFE-B824-14787CB31F7A}"/>
+                <a16:creationId xmlns:a16="http://schemas.microsoft.com/office/drawing/2014/main" id="{F5DE3111-72C0-4774-8170-0A072F0699E8}"/>
               </a:ext>
             </a:extLst>
           </p:cNvPr>
@@ -5124,7 +5124,7 @@
           <p:cNvPr id="42" name="">
             <a:extLst xmlns:a="http://schemas.openxmlformats.org/drawingml/2006/main">
               <a:ext uri="{FF2B5EF4-FFF2-40B4-BE49-F238E27FC236}">
-                <a16:creationId xmlns:a16="http://schemas.microsoft.com/office/drawing/2014/main" id="{4EAEE099-80B4-4EC4-A099-CA44F3E72BDC}"/>
+                <a16:creationId xmlns:a16="http://schemas.microsoft.com/office/drawing/2014/main" id="{2A23E9F6-6B12-4D47-A1D7-C2853D150CCF}"/>
               </a:ext>
             </a:extLst>
           </p:cNvPr>
@@ -5158,7 +5158,7 @@
           <p:cNvPr id="43" name="">
             <a:extLst xmlns:a="http://schemas.openxmlformats.org/drawingml/2006/main">
               <a:ext uri="{FF2B5EF4-FFF2-40B4-BE49-F238E27FC236}">
-                <a16:creationId xmlns:a16="http://schemas.microsoft.com/office/drawing/2014/main" id="{25591FC2-9B27-41A2-A6A6-F18FDEEFAFA8}"/>
+                <a16:creationId xmlns:a16="http://schemas.microsoft.com/office/drawing/2014/main" id="{9EEB0D33-02C7-453F-B910-544AFB4E4EB9}"/>
               </a:ext>
             </a:extLst>
           </p:cNvPr>
@@ -5215,7 +5215,7 @@
           <p:cNvPr id="44" name="">
             <a:extLst xmlns:a="http://schemas.openxmlformats.org/drawingml/2006/main">
               <a:ext uri="{FF2B5EF4-FFF2-40B4-BE49-F238E27FC236}">
-                <a16:creationId xmlns:a16="http://schemas.microsoft.com/office/drawing/2014/main" id="{E3AFBAE5-1313-4AA2-BBA4-ED5D943956D2}"/>
+                <a16:creationId xmlns:a16="http://schemas.microsoft.com/office/drawing/2014/main" id="{58E96717-3A3C-4C2E-8571-9A4F3089445F}"/>
               </a:ext>
             </a:extLst>
           </p:cNvPr>
@@ -5272,7 +5272,7 @@
           <p:cNvPr id="45" name="">
             <a:extLst xmlns:a="http://schemas.openxmlformats.org/drawingml/2006/main">
               <a:ext uri="{FF2B5EF4-FFF2-40B4-BE49-F238E27FC236}">
-                <a16:creationId xmlns:a16="http://schemas.microsoft.com/office/drawing/2014/main" id="{EDD5A1B6-211F-4B82-B233-02ED3FD358EF}"/>
+                <a16:creationId xmlns:a16="http://schemas.microsoft.com/office/drawing/2014/main" id="{0DEC617A-28E4-4224-A155-3D86B255D415}"/>
               </a:ext>
             </a:extLst>
           </p:cNvPr>
@@ -5329,7 +5329,7 @@
           <p:cNvPr id="46" name="">
             <a:extLst xmlns:a="http://schemas.openxmlformats.org/drawingml/2006/main">
               <a:ext uri="{FF2B5EF4-FFF2-40B4-BE49-F238E27FC236}">
-                <a16:creationId xmlns:a16="http://schemas.microsoft.com/office/drawing/2014/main" id="{4D0A738C-170A-4257-8FFC-8881B911270D}"/>
+                <a16:creationId xmlns:a16="http://schemas.microsoft.com/office/drawing/2014/main" id="{131983C5-A78D-4D93-8B95-B49A40E88B49}"/>
               </a:ext>
             </a:extLst>
           </p:cNvPr>
@@ -5363,7 +5363,7 @@
           <p:cNvPr id="47" name="">
             <a:extLst xmlns:a="http://schemas.openxmlformats.org/drawingml/2006/main">
               <a:ext uri="{FF2B5EF4-FFF2-40B4-BE49-F238E27FC236}">
-                <a16:creationId xmlns:a16="http://schemas.microsoft.com/office/drawing/2014/main" id="{F9C04E72-53D1-481B-B1BF-89DC8B603495}"/>
+                <a16:creationId xmlns:a16="http://schemas.microsoft.com/office/drawing/2014/main" id="{EA82B442-91C1-47FB-8D75-01CCD076A6CE}"/>
               </a:ext>
             </a:extLst>
           </p:cNvPr>
@@ -5420,7 +5420,7 @@
           <p:cNvPr id="48" name="">
             <a:extLst xmlns:a="http://schemas.openxmlformats.org/drawingml/2006/main">
               <a:ext uri="{FF2B5EF4-FFF2-40B4-BE49-F238E27FC236}">
-                <a16:creationId xmlns:a16="http://schemas.microsoft.com/office/drawing/2014/main" id="{946E69EE-2457-44CB-BE4A-09B7C6523928}"/>
+                <a16:creationId xmlns:a16="http://schemas.microsoft.com/office/drawing/2014/main" id="{78A21183-C983-4019-8A69-29A47CC8F679}"/>
               </a:ext>
             </a:extLst>
           </p:cNvPr>
@@ -5454,7 +5454,7 @@
           <p:cNvPr id="49" name="">
             <a:extLst xmlns:a="http://schemas.openxmlformats.org/drawingml/2006/main">
               <a:ext uri="{FF2B5EF4-FFF2-40B4-BE49-F238E27FC236}">
-                <a16:creationId xmlns:a16="http://schemas.microsoft.com/office/drawing/2014/main" id="{FA1D6A07-C20F-47E9-B6F9-27C8359EC841}"/>
+                <a16:creationId xmlns:a16="http://schemas.microsoft.com/office/drawing/2014/main" id="{C07F0063-9F9D-4928-8315-DEB0F589A37D}"/>
               </a:ext>
             </a:extLst>
           </p:cNvPr>
@@ -5511,7 +5511,7 @@
           <p:cNvPr id="50" name="">
             <a:extLst xmlns:a="http://schemas.openxmlformats.org/drawingml/2006/main">
               <a:ext uri="{FF2B5EF4-FFF2-40B4-BE49-F238E27FC236}">
-                <a16:creationId xmlns:a16="http://schemas.microsoft.com/office/drawing/2014/main" id="{99EE871B-EC95-46EA-AEAF-3A92F27C63F4}"/>
+                <a16:creationId xmlns:a16="http://schemas.microsoft.com/office/drawing/2014/main" id="{D2D7CFBE-159E-423E-9DD8-EEA9485CDC83}"/>
               </a:ext>
             </a:extLst>
           </p:cNvPr>
@@ -5568,7 +5568,7 @@
           <p:cNvPr id="51" name="">
             <a:extLst xmlns:a="http://schemas.openxmlformats.org/drawingml/2006/main">
               <a:ext uri="{FF2B5EF4-FFF2-40B4-BE49-F238E27FC236}">
-                <a16:creationId xmlns:a16="http://schemas.microsoft.com/office/drawing/2014/main" id="{77B2E825-0D82-4F00-AD77-00F3FF540348}"/>
+                <a16:creationId xmlns:a16="http://schemas.microsoft.com/office/drawing/2014/main" id="{3C050D37-AF24-4A8B-8C7D-C90CFAA87FF7}"/>
               </a:ext>
             </a:extLst>
           </p:cNvPr>
@@ -5625,7 +5625,7 @@
           <p:cNvPr id="52" name="">
             <a:extLst xmlns:a="http://schemas.openxmlformats.org/drawingml/2006/main">
               <a:ext uri="{FF2B5EF4-FFF2-40B4-BE49-F238E27FC236}">
-                <a16:creationId xmlns:a16="http://schemas.microsoft.com/office/drawing/2014/main" id="{36653724-CC50-4DCA-B2C1-F6CA04F25E51}"/>
+                <a16:creationId xmlns:a16="http://schemas.microsoft.com/office/drawing/2014/main" id="{3F957206-02AA-4DE1-B1B2-C373A8D567B9}"/>
               </a:ext>
             </a:extLst>
           </p:cNvPr>
@@ -5659,7 +5659,7 @@
           <p:cNvPr id="53" name="">
             <a:extLst xmlns:a="http://schemas.openxmlformats.org/drawingml/2006/main">
               <a:ext uri="{FF2B5EF4-FFF2-40B4-BE49-F238E27FC236}">
-                <a16:creationId xmlns:a16="http://schemas.microsoft.com/office/drawing/2014/main" id="{B431E12B-8910-47C5-96D0-9E3E0E0DC249}"/>
+                <a16:creationId xmlns:a16="http://schemas.microsoft.com/office/drawing/2014/main" id="{1F8EFCB7-8600-4892-ACCA-9819D17AA2E6}"/>
               </a:ext>
             </a:extLst>
           </p:cNvPr>
@@ -5716,7 +5716,7 @@
           <p:cNvPr id="54" name="">
             <a:extLst xmlns:a="http://schemas.openxmlformats.org/drawingml/2006/main">
               <a:ext uri="{FF2B5EF4-FFF2-40B4-BE49-F238E27FC236}">
-                <a16:creationId xmlns:a16="http://schemas.microsoft.com/office/drawing/2014/main" id="{E5D0B093-6256-4A1F-9004-F3D4648CCBAF}"/>
+                <a16:creationId xmlns:a16="http://schemas.microsoft.com/office/drawing/2014/main" id="{0CA8971E-E1B0-4D74-AEB3-7BA483233E42}"/>
               </a:ext>
             </a:extLst>
           </p:cNvPr>
@@ -5750,7 +5750,7 @@
           <p:cNvPr id="55" name="">
             <a:extLst xmlns:a="http://schemas.openxmlformats.org/drawingml/2006/main">
               <a:ext uri="{FF2B5EF4-FFF2-40B4-BE49-F238E27FC236}">
-                <a16:creationId xmlns:a16="http://schemas.microsoft.com/office/drawing/2014/main" id="{9FC06214-6C33-42B0-9447-C32961A55126}"/>
+                <a16:creationId xmlns:a16="http://schemas.microsoft.com/office/drawing/2014/main" id="{D13F91EA-8A27-40EE-82AA-B192AC448536}"/>
               </a:ext>
             </a:extLst>
           </p:cNvPr>
@@ -5807,7 +5807,7 @@
           <p:cNvPr id="56" name="">
             <a:extLst xmlns:a="http://schemas.openxmlformats.org/drawingml/2006/main">
               <a:ext uri="{FF2B5EF4-FFF2-40B4-BE49-F238E27FC236}">
-                <a16:creationId xmlns:a16="http://schemas.microsoft.com/office/drawing/2014/main" id="{418789C9-3778-48A5-A243-4CBCE5C8E0E8}"/>
+                <a16:creationId xmlns:a16="http://schemas.microsoft.com/office/drawing/2014/main" id="{5939A9BD-72F5-46B1-816F-BBF424CFB35B}"/>
               </a:ext>
             </a:extLst>
           </p:cNvPr>
@@ -5864,7 +5864,7 @@
           <p:cNvPr id="57" name="">
             <a:extLst xmlns:a="http://schemas.openxmlformats.org/drawingml/2006/main">
               <a:ext uri="{FF2B5EF4-FFF2-40B4-BE49-F238E27FC236}">
-                <a16:creationId xmlns:a16="http://schemas.microsoft.com/office/drawing/2014/main" id="{D9BBA6D6-2BDF-48DD-8BCD-333558A1C29C}"/>
+                <a16:creationId xmlns:a16="http://schemas.microsoft.com/office/drawing/2014/main" id="{7A47BBCD-B828-4CFF-A5D2-E1C7CE7633F2}"/>
               </a:ext>
             </a:extLst>
           </p:cNvPr>
@@ -5919,7 +5919,7 @@
     </p:spTree>
     <p:extLst>
       <p:ext uri="{BB962C8B-B14F-4D97-AF65-F5344CB8AC3E}">
-        <p14:creationId xmlns:p14="http://schemas.microsoft.com/office/powerpoint/2010/main" val="109350858"/>
+        <p14:creationId xmlns:p14="http://schemas.microsoft.com/office/powerpoint/2010/main" val="195070950"/>
       </p:ext>
     </p:extLst>
   </p:cSld>
@@ -5950,7 +5950,7 @@
           <p:cNvPr id="8" name="">
             <a:extLst xmlns:a="http://schemas.openxmlformats.org/drawingml/2006/main">
               <a:ext uri="{FF2B5EF4-FFF2-40B4-BE49-F238E27FC236}">
-                <a16:creationId xmlns:a16="http://schemas.microsoft.com/office/drawing/2014/main" id="{A4EBD926-E3FF-4F79-B16B-C54C00C0C088}"/>
+                <a16:creationId xmlns:a16="http://schemas.microsoft.com/office/drawing/2014/main" id="{FA1356B6-B392-48FD-9EB2-CA210B25CD89}"/>
               </a:ext>
             </a:extLst>
           </p:cNvPr>
@@ -5980,7 +5980,7 @@
           <p:cNvPr id="2" name="">
             <a:extLst xmlns:a="http://schemas.openxmlformats.org/drawingml/2006/main">
               <a:ext uri="{FF2B5EF4-FFF2-40B4-BE49-F238E27FC236}">
-                <a16:creationId xmlns:a16="http://schemas.microsoft.com/office/drawing/2014/main" id="{55AEB345-F88C-40F6-8334-B1FEC281AA5A}"/>
+                <a16:creationId xmlns:a16="http://schemas.microsoft.com/office/drawing/2014/main" id="{5466BAA6-C181-490F-B41F-F5F2015F47CD}"/>
               </a:ext>
             </a:extLst>
           </p:cNvPr>
@@ -6041,7 +6041,7 @@
           <p:cNvPr id="3" name="">
             <a:extLst xmlns:a="http://schemas.openxmlformats.org/drawingml/2006/main">
               <a:ext uri="{FF2B5EF4-FFF2-40B4-BE49-F238E27FC236}">
-                <a16:creationId xmlns:a16="http://schemas.microsoft.com/office/drawing/2014/main" id="{8EECB082-F864-49A1-9C50-C281161C2B25}"/>
+                <a16:creationId xmlns:a16="http://schemas.microsoft.com/office/drawing/2014/main" id="{C75B1433-DC2E-4F03-BEC5-800C47CAF41B}"/>
               </a:ext>
             </a:extLst>
           </p:cNvPr>
@@ -6098,7 +6098,7 @@
           <p:cNvPr id="4" name="">
             <a:extLst xmlns:a="http://schemas.openxmlformats.org/drawingml/2006/main">
               <a:ext uri="{FF2B5EF4-FFF2-40B4-BE49-F238E27FC236}">
-                <a16:creationId xmlns:a16="http://schemas.microsoft.com/office/drawing/2014/main" id="{8122B078-9ADC-4EE2-BCF6-2FE4296037A2}"/>
+                <a16:creationId xmlns:a16="http://schemas.microsoft.com/office/drawing/2014/main" id="{C7EC9FB1-534F-4364-A222-E5FDA20C009D}"/>
               </a:ext>
             </a:extLst>
           </p:cNvPr>
@@ -6155,7 +6155,7 @@
           <p:cNvPr id="5" name="">
             <a:extLst xmlns:a="http://schemas.openxmlformats.org/drawingml/2006/main">
               <a:ext uri="{FF2B5EF4-FFF2-40B4-BE49-F238E27FC236}">
-                <a16:creationId xmlns:a16="http://schemas.microsoft.com/office/drawing/2014/main" id="{20D5052B-C154-4C35-8911-BC6E00408CB1}"/>
+                <a16:creationId xmlns:a16="http://schemas.microsoft.com/office/drawing/2014/main" id="{EE7D0E2D-CE40-4080-912E-8F8B3F324849}"/>
               </a:ext>
             </a:extLst>
           </p:cNvPr>
@@ -6212,7 +6212,7 @@
           <p:cNvPr id="6" name="">
             <a:extLst xmlns:a="http://schemas.openxmlformats.org/drawingml/2006/main">
               <a:ext uri="{FF2B5EF4-FFF2-40B4-BE49-F238E27FC236}">
-                <a16:creationId xmlns:a16="http://schemas.microsoft.com/office/drawing/2014/main" id="{F2E4F445-6EE7-4727-97AE-BBB5777594DF}"/>
+                <a16:creationId xmlns:a16="http://schemas.microsoft.com/office/drawing/2014/main" id="{A57295F0-155C-4111-98E2-84A8BC52251E}"/>
               </a:ext>
             </a:extLst>
           </p:cNvPr>
@@ -6273,7 +6273,7 @@
           <p:nvPr/>
         </p:nvPicPr>
         <p:blipFill>
-          <a:blip xmlns:r="http://schemas.openxmlformats.org/officeDocument/2006/relationships" xmlns:a="http://schemas.openxmlformats.org/drawingml/2006/main" r:embed="Ref1713eef939492e"/>
+          <a:blip xmlns:r="http://schemas.openxmlformats.org/officeDocument/2006/relationships" xmlns:a="http://schemas.openxmlformats.org/drawingml/2006/main" r:embed="R1ff005b5edf140eb"/>
           <a:stretch xmlns:a="http://schemas.openxmlformats.org/drawingml/2006/main"/>
         </p:blipFill>
         <p:spPr>
@@ -6289,7 +6289,7 @@
     </p:spTree>
     <p:extLst>
       <p:ext uri="{BB962C8B-B14F-4D97-AF65-F5344CB8AC3E}">
-        <p14:creationId xmlns:p14="http://schemas.microsoft.com/office/powerpoint/2010/main" val="1598979871"/>
+        <p14:creationId xmlns:p14="http://schemas.microsoft.com/office/powerpoint/2010/main" val="1704783585"/>
       </p:ext>
     </p:extLst>
   </p:cSld>
@@ -6320,7 +6320,7 @@
           <p:cNvPr id="8" name="">
             <a:extLst xmlns:a="http://schemas.openxmlformats.org/drawingml/2006/main">
               <a:ext uri="{FF2B5EF4-FFF2-40B4-BE49-F238E27FC236}">
-                <a16:creationId xmlns:a16="http://schemas.microsoft.com/office/drawing/2014/main" id="{394CE8BD-5907-45C4-BC78-5B874FA8D2B0}"/>
+                <a16:creationId xmlns:a16="http://schemas.microsoft.com/office/drawing/2014/main" id="{A2672548-E4DB-4780-8309-3848B61385A2}"/>
               </a:ext>
             </a:extLst>
           </p:cNvPr>
@@ -6350,7 +6350,7 @@
           <p:cNvPr id="2" name="">
             <a:extLst xmlns:a="http://schemas.openxmlformats.org/drawingml/2006/main">
               <a:ext uri="{FF2B5EF4-FFF2-40B4-BE49-F238E27FC236}">
-                <a16:creationId xmlns:a16="http://schemas.microsoft.com/office/drawing/2014/main" id="{0D2482C5-0A14-4386-B9FB-9F64EBC8FF67}"/>
+                <a16:creationId xmlns:a16="http://schemas.microsoft.com/office/drawing/2014/main" id="{F00207BA-92CE-4D89-BE0E-281A5B1B8509}"/>
               </a:ext>
             </a:extLst>
           </p:cNvPr>
@@ -6411,7 +6411,7 @@
           <p:cNvPr id="3" name="">
             <a:extLst xmlns:a="http://schemas.openxmlformats.org/drawingml/2006/main">
               <a:ext uri="{FF2B5EF4-FFF2-40B4-BE49-F238E27FC236}">
-                <a16:creationId xmlns:a16="http://schemas.microsoft.com/office/drawing/2014/main" id="{3EF03593-5691-4546-8A47-2C7ADD3F2AF4}"/>
+                <a16:creationId xmlns:a16="http://schemas.microsoft.com/office/drawing/2014/main" id="{037CE1EF-82B3-4C2C-9DC2-FC2040CF528B}"/>
               </a:ext>
             </a:extLst>
           </p:cNvPr>
@@ -6468,7 +6468,7 @@
           <p:cNvPr id="4" name="">
             <a:extLst xmlns:a="http://schemas.openxmlformats.org/drawingml/2006/main">
               <a:ext uri="{FF2B5EF4-FFF2-40B4-BE49-F238E27FC236}">
-                <a16:creationId xmlns:a16="http://schemas.microsoft.com/office/drawing/2014/main" id="{5AE0EB63-144F-41B8-A2BE-39EEF201EB9D}"/>
+                <a16:creationId xmlns:a16="http://schemas.microsoft.com/office/drawing/2014/main" id="{36546271-07A5-4127-A24D-E70A285822FD}"/>
               </a:ext>
             </a:extLst>
           </p:cNvPr>
@@ -6525,7 +6525,7 @@
           <p:cNvPr id="5" name="">
             <a:extLst xmlns:a="http://schemas.openxmlformats.org/drawingml/2006/main">
               <a:ext uri="{FF2B5EF4-FFF2-40B4-BE49-F238E27FC236}">
-                <a16:creationId xmlns:a16="http://schemas.microsoft.com/office/drawing/2014/main" id="{A91BA3A6-2762-4692-9F95-3A05C4BE29D3}"/>
+                <a16:creationId xmlns:a16="http://schemas.microsoft.com/office/drawing/2014/main" id="{9A114DA1-163D-441A-AEEC-EEC803A120E0}"/>
               </a:ext>
             </a:extLst>
           </p:cNvPr>
@@ -6582,7 +6582,7 @@
           <p:cNvPr id="6" name="">
             <a:extLst xmlns:a="http://schemas.openxmlformats.org/drawingml/2006/main">
               <a:ext uri="{FF2B5EF4-FFF2-40B4-BE49-F238E27FC236}">
-                <a16:creationId xmlns:a16="http://schemas.microsoft.com/office/drawing/2014/main" id="{3812BE2B-8069-41F7-9D71-E2F68ACE742C}"/>
+                <a16:creationId xmlns:a16="http://schemas.microsoft.com/office/drawing/2014/main" id="{DEAEDDDA-D279-4B4C-9405-E69EC80BBA56}"/>
               </a:ext>
             </a:extLst>
           </p:cNvPr>
@@ -6643,7 +6643,7 @@
           <p:nvPr/>
         </p:nvPicPr>
         <p:blipFill>
-          <a:blip xmlns:r="http://schemas.openxmlformats.org/officeDocument/2006/relationships" xmlns:a="http://schemas.openxmlformats.org/drawingml/2006/main" r:embed="R14251bb30f514043"/>
+          <a:blip xmlns:r="http://schemas.openxmlformats.org/officeDocument/2006/relationships" xmlns:a="http://schemas.openxmlformats.org/drawingml/2006/main" r:embed="R0b16353a6c224e6d"/>
           <a:stretch xmlns:a="http://schemas.openxmlformats.org/drawingml/2006/main"/>
         </p:blipFill>
         <p:spPr>
@@ -6659,7 +6659,7 @@
     </p:spTree>
     <p:extLst>
       <p:ext uri="{BB962C8B-B14F-4D97-AF65-F5344CB8AC3E}">
-        <p14:creationId xmlns:p14="http://schemas.microsoft.com/office/powerpoint/2010/main" val="670729685"/>
+        <p14:creationId xmlns:p14="http://schemas.microsoft.com/office/powerpoint/2010/main" val="1386175365"/>
       </p:ext>
     </p:extLst>
   </p:cSld>
@@ -6690,7 +6690,7 @@
           <p:cNvPr id="34" name="">
             <a:extLst xmlns:a="http://schemas.openxmlformats.org/drawingml/2006/main">
               <a:ext uri="{FF2B5EF4-FFF2-40B4-BE49-F238E27FC236}">
-                <a16:creationId xmlns:a16="http://schemas.microsoft.com/office/drawing/2014/main" id="{1C011409-CA8B-431A-8E92-BBE34DC7F817}"/>
+                <a16:creationId xmlns:a16="http://schemas.microsoft.com/office/drawing/2014/main" id="{64D88A40-8C44-473F-8C72-63B7EB1F1D02}"/>
               </a:ext>
             </a:extLst>
           </p:cNvPr>
@@ -6720,7 +6720,7 @@
           <p:cNvPr id="2" name="">
             <a:extLst xmlns:a="http://schemas.openxmlformats.org/drawingml/2006/main">
               <a:ext uri="{FF2B5EF4-FFF2-40B4-BE49-F238E27FC236}">
-                <a16:creationId xmlns:a16="http://schemas.microsoft.com/office/drawing/2014/main" id="{849DF72B-F922-423A-B8B6-4BDC8F1F6268}"/>
+                <a16:creationId xmlns:a16="http://schemas.microsoft.com/office/drawing/2014/main" id="{2F33821B-AEA0-4DEB-9CA7-8A9B3D84600E}"/>
               </a:ext>
             </a:extLst>
           </p:cNvPr>
@@ -6781,7 +6781,7 @@
           <p:cNvPr id="3" name="">
             <a:extLst xmlns:a="http://schemas.openxmlformats.org/drawingml/2006/main">
               <a:ext uri="{FF2B5EF4-FFF2-40B4-BE49-F238E27FC236}">
-                <a16:creationId xmlns:a16="http://schemas.microsoft.com/office/drawing/2014/main" id="{2AEC831B-BF9B-4B10-BBF2-51CC9AFFF27F}"/>
+                <a16:creationId xmlns:a16="http://schemas.microsoft.com/office/drawing/2014/main" id="{98B68751-D4EA-47BC-B24E-3D6884F8D736}"/>
               </a:ext>
             </a:extLst>
           </p:cNvPr>
@@ -6838,7 +6838,7 @@
           <p:cNvPr id="4" name="">
             <a:extLst xmlns:a="http://schemas.openxmlformats.org/drawingml/2006/main">
               <a:ext uri="{FF2B5EF4-FFF2-40B4-BE49-F238E27FC236}">
-                <a16:creationId xmlns:a16="http://schemas.microsoft.com/office/drawing/2014/main" id="{637A24E2-B192-46AF-A1B2-6E4E3DCB8D77}"/>
+                <a16:creationId xmlns:a16="http://schemas.microsoft.com/office/drawing/2014/main" id="{1D2F86C2-CC24-4137-947C-387618E5EC7A}"/>
               </a:ext>
             </a:extLst>
           </p:cNvPr>
@@ -6895,7 +6895,7 @@
           <p:cNvPr id="5" name="">
             <a:extLst xmlns:a="http://schemas.openxmlformats.org/drawingml/2006/main">
               <a:ext uri="{FF2B5EF4-FFF2-40B4-BE49-F238E27FC236}">
-                <a16:creationId xmlns:a16="http://schemas.microsoft.com/office/drawing/2014/main" id="{6A0BB4F5-E868-4E44-B50D-3A9C0FB80FAC}"/>
+                <a16:creationId xmlns:a16="http://schemas.microsoft.com/office/drawing/2014/main" id="{C2C5E73B-99AE-495A-9D4A-D3D3B7A39DA5}"/>
               </a:ext>
             </a:extLst>
           </p:cNvPr>
@@ -6952,7 +6952,7 @@
           <p:cNvPr id="6" name="">
             <a:extLst xmlns:a="http://schemas.openxmlformats.org/drawingml/2006/main">
               <a:ext uri="{FF2B5EF4-FFF2-40B4-BE49-F238E27FC236}">
-                <a16:creationId xmlns:a16="http://schemas.microsoft.com/office/drawing/2014/main" id="{AAA41FEC-B343-4750-99D6-EC12796CA214}"/>
+                <a16:creationId xmlns:a16="http://schemas.microsoft.com/office/drawing/2014/main" id="{911C7AE4-B0A6-46F9-9CE0-229718D50467}"/>
               </a:ext>
             </a:extLst>
           </p:cNvPr>
@@ -7009,7 +7009,7 @@
           <p:cNvPr id="7" name="">
             <a:extLst xmlns:a="http://schemas.openxmlformats.org/drawingml/2006/main">
               <a:ext uri="{FF2B5EF4-FFF2-40B4-BE49-F238E27FC236}">
-                <a16:creationId xmlns:a16="http://schemas.microsoft.com/office/drawing/2014/main" id="{78FD43B9-D885-4779-A8A6-15C6DDC8CCC4}"/>
+                <a16:creationId xmlns:a16="http://schemas.microsoft.com/office/drawing/2014/main" id="{9BE78D3F-6E32-4D7F-9DE0-08D6988A33ED}"/>
               </a:ext>
             </a:extLst>
           </p:cNvPr>
@@ -7066,7 +7066,7 @@
           <p:cNvPr id="8" name="">
             <a:extLst xmlns:a="http://schemas.openxmlformats.org/drawingml/2006/main">
               <a:ext uri="{FF2B5EF4-FFF2-40B4-BE49-F238E27FC236}">
-                <a16:creationId xmlns:a16="http://schemas.microsoft.com/office/drawing/2014/main" id="{526DC838-A947-4C3A-B069-BE941BDA3A68}"/>
+                <a16:creationId xmlns:a16="http://schemas.microsoft.com/office/drawing/2014/main" id="{D7FD1B31-CD55-4750-834D-5AD66A5E88C2}"/>
               </a:ext>
             </a:extLst>
           </p:cNvPr>
@@ -7146,7 +7146,7 @@
           <p:cNvPr id="9" name="">
             <a:extLst xmlns:a="http://schemas.openxmlformats.org/drawingml/2006/main">
               <a:ext uri="{FF2B5EF4-FFF2-40B4-BE49-F238E27FC236}">
-                <a16:creationId xmlns:a16="http://schemas.microsoft.com/office/drawing/2014/main" id="{2F314135-6F3F-4928-B3B9-BE16687B5619}"/>
+                <a16:creationId xmlns:a16="http://schemas.microsoft.com/office/drawing/2014/main" id="{968AAE9E-9C69-4236-A286-AAFDBBD68ADF}"/>
               </a:ext>
             </a:extLst>
           </p:cNvPr>
@@ -7180,7 +7180,7 @@
           <p:cNvPr id="10" name="">
             <a:extLst xmlns:a="http://schemas.openxmlformats.org/drawingml/2006/main">
               <a:ext uri="{FF2B5EF4-FFF2-40B4-BE49-F238E27FC236}">
-                <a16:creationId xmlns:a16="http://schemas.microsoft.com/office/drawing/2014/main" id="{6651F983-8F7D-4F07-9A36-90139B4CF8E5}"/>
+                <a16:creationId xmlns:a16="http://schemas.microsoft.com/office/drawing/2014/main" id="{EB9CBB5E-E7FE-42B3-81F3-A66F3517D17D}"/>
               </a:ext>
             </a:extLst>
           </p:cNvPr>
@@ -7237,7 +7237,7 @@
           <p:cNvPr id="11" name="">
             <a:extLst xmlns:a="http://schemas.openxmlformats.org/drawingml/2006/main">
               <a:ext uri="{FF2B5EF4-FFF2-40B4-BE49-F238E27FC236}">
-                <a16:creationId xmlns:a16="http://schemas.microsoft.com/office/drawing/2014/main" id="{878630CB-BF63-4CA5-9B57-83B0880F620F}"/>
+                <a16:creationId xmlns:a16="http://schemas.microsoft.com/office/drawing/2014/main" id="{A4D693EA-8AA8-455E-949D-7CA6627EBE67}"/>
               </a:ext>
             </a:extLst>
           </p:cNvPr>
@@ -7294,7 +7294,7 @@
           <p:cNvPr id="12" name="">
             <a:extLst xmlns:a="http://schemas.openxmlformats.org/drawingml/2006/main">
               <a:ext uri="{FF2B5EF4-FFF2-40B4-BE49-F238E27FC236}">
-                <a16:creationId xmlns:a16="http://schemas.microsoft.com/office/drawing/2014/main" id="{1254CEE1-A5A9-4052-94FA-D4E3B5E703AF}"/>
+                <a16:creationId xmlns:a16="http://schemas.microsoft.com/office/drawing/2014/main" id="{93C14F0A-46A4-4E91-90F3-BB6BEE61E647}"/>
               </a:ext>
             </a:extLst>
           </p:cNvPr>
@@ -7328,7 +7328,7 @@
           <p:cNvPr id="13" name="">
             <a:extLst xmlns:a="http://schemas.openxmlformats.org/drawingml/2006/main">
               <a:ext uri="{FF2B5EF4-FFF2-40B4-BE49-F238E27FC236}">
-                <a16:creationId xmlns:a16="http://schemas.microsoft.com/office/drawing/2014/main" id="{A4C13D7B-DA72-4C64-B467-0E71CD949F68}"/>
+                <a16:creationId xmlns:a16="http://schemas.microsoft.com/office/drawing/2014/main" id="{03413B45-BF4A-488B-BB43-CD7004B4E7DD}"/>
               </a:ext>
             </a:extLst>
           </p:cNvPr>
@@ -7385,7 +7385,7 @@
           <p:cNvPr id="14" name="">
             <a:extLst xmlns:a="http://schemas.openxmlformats.org/drawingml/2006/main">
               <a:ext uri="{FF2B5EF4-FFF2-40B4-BE49-F238E27FC236}">
-                <a16:creationId xmlns:a16="http://schemas.microsoft.com/office/drawing/2014/main" id="{DAFFAB9B-080C-4648-A018-DD35EB6D84ED}"/>
+                <a16:creationId xmlns:a16="http://schemas.microsoft.com/office/drawing/2014/main" id="{8C44723F-32E8-4548-BB4B-65574B0DC4A4}"/>
               </a:ext>
             </a:extLst>
           </p:cNvPr>
@@ -7442,7 +7442,7 @@
           <p:cNvPr id="15" name="">
             <a:extLst xmlns:a="http://schemas.openxmlformats.org/drawingml/2006/main">
               <a:ext uri="{FF2B5EF4-FFF2-40B4-BE49-F238E27FC236}">
-                <a16:creationId xmlns:a16="http://schemas.microsoft.com/office/drawing/2014/main" id="{6785738A-2514-4CCF-AD04-BABACD954165}"/>
+                <a16:creationId xmlns:a16="http://schemas.microsoft.com/office/drawing/2014/main" id="{E4D53283-0F18-4386-81B8-E5C807B83F04}"/>
               </a:ext>
             </a:extLst>
           </p:cNvPr>
@@ -7476,7 +7476,7 @@
           <p:cNvPr id="16" name="">
             <a:extLst xmlns:a="http://schemas.openxmlformats.org/drawingml/2006/main">
               <a:ext uri="{FF2B5EF4-FFF2-40B4-BE49-F238E27FC236}">
-                <a16:creationId xmlns:a16="http://schemas.microsoft.com/office/drawing/2014/main" id="{3953F35C-AB67-4FD6-A728-2528382FD4A6}"/>
+                <a16:creationId xmlns:a16="http://schemas.microsoft.com/office/drawing/2014/main" id="{9AE2D470-11D7-4FAA-B012-BDC25F0492B2}"/>
               </a:ext>
             </a:extLst>
           </p:cNvPr>
@@ -7533,7 +7533,7 @@
           <p:cNvPr id="17" name="">
             <a:extLst xmlns:a="http://schemas.openxmlformats.org/drawingml/2006/main">
               <a:ext uri="{FF2B5EF4-FFF2-40B4-BE49-F238E27FC236}">
-                <a16:creationId xmlns:a16="http://schemas.microsoft.com/office/drawing/2014/main" id="{F8139950-8300-41F8-96EE-DF7373E8A92D}"/>
+                <a16:creationId xmlns:a16="http://schemas.microsoft.com/office/drawing/2014/main" id="{1F25BDD7-9A8C-478B-ACC6-5B9BCA3BE3BE}"/>
               </a:ext>
             </a:extLst>
           </p:cNvPr>
@@ -7590,7 +7590,7 @@
           <p:cNvPr id="18" name="">
             <a:extLst xmlns:a="http://schemas.openxmlformats.org/drawingml/2006/main">
               <a:ext uri="{FF2B5EF4-FFF2-40B4-BE49-F238E27FC236}">
-                <a16:creationId xmlns:a16="http://schemas.microsoft.com/office/drawing/2014/main" id="{EC59FF5B-EC0B-4B58-9932-65207F0F6677}"/>
+                <a16:creationId xmlns:a16="http://schemas.microsoft.com/office/drawing/2014/main" id="{7C592BA9-052F-4ADB-9379-23375F883C52}"/>
               </a:ext>
             </a:extLst>
           </p:cNvPr>
@@ -7624,7 +7624,7 @@
           <p:cNvPr id="19" name="">
             <a:extLst xmlns:a="http://schemas.openxmlformats.org/drawingml/2006/main">
               <a:ext uri="{FF2B5EF4-FFF2-40B4-BE49-F238E27FC236}">
-                <a16:creationId xmlns:a16="http://schemas.microsoft.com/office/drawing/2014/main" id="{96023C19-A702-4B0A-B3FA-FE13A0F4700A}"/>
+                <a16:creationId xmlns:a16="http://schemas.microsoft.com/office/drawing/2014/main" id="{7FE059F8-C342-4299-A3B5-B4DD0D225951}"/>
               </a:ext>
             </a:extLst>
           </p:cNvPr>
@@ -7681,7 +7681,7 @@
           <p:cNvPr id="20" name="">
             <a:extLst xmlns:a="http://schemas.openxmlformats.org/drawingml/2006/main">
               <a:ext uri="{FF2B5EF4-FFF2-40B4-BE49-F238E27FC236}">
-                <a16:creationId xmlns:a16="http://schemas.microsoft.com/office/drawing/2014/main" id="{980F140A-28BA-4F79-99C8-B926FD6E51D9}"/>
+                <a16:creationId xmlns:a16="http://schemas.microsoft.com/office/drawing/2014/main" id="{82ECE57D-EDAD-4318-83D5-41D4736A558D}"/>
               </a:ext>
             </a:extLst>
           </p:cNvPr>
@@ -7715,7 +7715,7 @@
           <p:cNvPr id="21" name="">
             <a:extLst xmlns:a="http://schemas.openxmlformats.org/drawingml/2006/main">
               <a:ext uri="{FF2B5EF4-FFF2-40B4-BE49-F238E27FC236}">
-                <a16:creationId xmlns:a16="http://schemas.microsoft.com/office/drawing/2014/main" id="{1ECFC763-BCCD-4A36-811F-0FD3A49F0F81}"/>
+                <a16:creationId xmlns:a16="http://schemas.microsoft.com/office/drawing/2014/main" id="{79D22467-5F9F-4078-94EF-AA2B0DF34095}"/>
               </a:ext>
             </a:extLst>
           </p:cNvPr>
@@ -7772,7 +7772,7 @@
           <p:cNvPr id="22" name="">
             <a:extLst xmlns:a="http://schemas.openxmlformats.org/drawingml/2006/main">
               <a:ext uri="{FF2B5EF4-FFF2-40B4-BE49-F238E27FC236}">
-                <a16:creationId xmlns:a16="http://schemas.microsoft.com/office/drawing/2014/main" id="{8696BDE5-BC91-4943-AA4F-FC7D60A4CE6A}"/>
+                <a16:creationId xmlns:a16="http://schemas.microsoft.com/office/drawing/2014/main" id="{EC3053AC-E0FC-4F58-A23B-8A8967A6370F}"/>
               </a:ext>
             </a:extLst>
           </p:cNvPr>
@@ -7806,7 +7806,7 @@
           <p:cNvPr id="23" name="">
             <a:extLst xmlns:a="http://schemas.openxmlformats.org/drawingml/2006/main">
               <a:ext uri="{FF2B5EF4-FFF2-40B4-BE49-F238E27FC236}">
-                <a16:creationId xmlns:a16="http://schemas.microsoft.com/office/drawing/2014/main" id="{BBC1F35E-4C95-4F08-BC1C-386D3131A1EB}"/>
+                <a16:creationId xmlns:a16="http://schemas.microsoft.com/office/drawing/2014/main" id="{AE16EFBA-39DD-4EA3-9D27-FB803475D724}"/>
               </a:ext>
             </a:extLst>
           </p:cNvPr>
@@ -7863,7 +7863,7 @@
           <p:cNvPr id="24" name="">
             <a:extLst xmlns:a="http://schemas.openxmlformats.org/drawingml/2006/main">
               <a:ext uri="{FF2B5EF4-FFF2-40B4-BE49-F238E27FC236}">
-                <a16:creationId xmlns:a16="http://schemas.microsoft.com/office/drawing/2014/main" id="{7008B629-A357-4E13-AE1A-048CEE3CD8F9}"/>
+                <a16:creationId xmlns:a16="http://schemas.microsoft.com/office/drawing/2014/main" id="{3047F480-249A-4984-B759-8C74EB608EFC}"/>
               </a:ext>
             </a:extLst>
           </p:cNvPr>
@@ -7897,7 +7897,7 @@
           <p:cNvPr id="25" name="">
             <a:extLst xmlns:a="http://schemas.openxmlformats.org/drawingml/2006/main">
               <a:ext uri="{FF2B5EF4-FFF2-40B4-BE49-F238E27FC236}">
-                <a16:creationId xmlns:a16="http://schemas.microsoft.com/office/drawing/2014/main" id="{B0871132-9A35-4A05-8E08-730EB18E05A5}"/>
+                <a16:creationId xmlns:a16="http://schemas.microsoft.com/office/drawing/2014/main" id="{A5D71EDD-2BCE-4B77-87F1-0D6D132C7885}"/>
               </a:ext>
             </a:extLst>
           </p:cNvPr>
@@ -7954,7 +7954,7 @@
           <p:cNvPr id="26" name="">
             <a:extLst xmlns:a="http://schemas.openxmlformats.org/drawingml/2006/main">
               <a:ext uri="{FF2B5EF4-FFF2-40B4-BE49-F238E27FC236}">
-                <a16:creationId xmlns:a16="http://schemas.microsoft.com/office/drawing/2014/main" id="{F9BFC340-F68D-4E9A-8298-2654E38D3473}"/>
+                <a16:creationId xmlns:a16="http://schemas.microsoft.com/office/drawing/2014/main" id="{3042D6B2-3AEE-42D4-8CD3-B7805BE58A13}"/>
               </a:ext>
             </a:extLst>
           </p:cNvPr>
@@ -7988,7 +7988,7 @@
           <p:cNvPr id="27" name="">
             <a:extLst xmlns:a="http://schemas.openxmlformats.org/drawingml/2006/main">
               <a:ext uri="{FF2B5EF4-FFF2-40B4-BE49-F238E27FC236}">
-                <a16:creationId xmlns:a16="http://schemas.microsoft.com/office/drawing/2014/main" id="{A54BFA23-2567-455A-B756-D4D4C70084FB}"/>
+                <a16:creationId xmlns:a16="http://schemas.microsoft.com/office/drawing/2014/main" id="{E7D5854F-5B6B-4BBE-BFC2-4B5E0C9663CC}"/>
               </a:ext>
             </a:extLst>
           </p:cNvPr>
@@ -8045,7 +8045,7 @@
           <p:cNvPr id="28" name="">
             <a:extLst xmlns:a="http://schemas.openxmlformats.org/drawingml/2006/main">
               <a:ext uri="{FF2B5EF4-FFF2-40B4-BE49-F238E27FC236}">
-                <a16:creationId xmlns:a16="http://schemas.microsoft.com/office/drawing/2014/main" id="{D37659AF-CE8F-4860-8931-315C09BB2C93}"/>
+                <a16:creationId xmlns:a16="http://schemas.microsoft.com/office/drawing/2014/main" id="{AFE624C1-568E-4043-BBBF-A6749A54225A}"/>
               </a:ext>
             </a:extLst>
           </p:cNvPr>
@@ -8079,7 +8079,7 @@
           <p:cNvPr id="29" name="">
             <a:extLst xmlns:a="http://schemas.openxmlformats.org/drawingml/2006/main">
               <a:ext uri="{FF2B5EF4-FFF2-40B4-BE49-F238E27FC236}">
-                <a16:creationId xmlns:a16="http://schemas.microsoft.com/office/drawing/2014/main" id="{B5F99B15-31F5-4DB7-A59D-94A5D2B4EB8D}"/>
+                <a16:creationId xmlns:a16="http://schemas.microsoft.com/office/drawing/2014/main" id="{B1A64DB1-7688-43BA-8F99-440F63938014}"/>
               </a:ext>
             </a:extLst>
           </p:cNvPr>
@@ -8136,7 +8136,7 @@
           <p:cNvPr id="30" name="">
             <a:extLst xmlns:a="http://schemas.openxmlformats.org/drawingml/2006/main">
               <a:ext uri="{FF2B5EF4-FFF2-40B4-BE49-F238E27FC236}">
-                <a16:creationId xmlns:a16="http://schemas.microsoft.com/office/drawing/2014/main" id="{FAB751D2-A45C-4DCB-B693-4263C56BA832}"/>
+                <a16:creationId xmlns:a16="http://schemas.microsoft.com/office/drawing/2014/main" id="{6836A597-2B09-43F1-BF4F-BB47F473E365}"/>
               </a:ext>
             </a:extLst>
           </p:cNvPr>
@@ -8170,7 +8170,7 @@
           <p:cNvPr id="31" name="">
             <a:extLst xmlns:a="http://schemas.openxmlformats.org/drawingml/2006/main">
               <a:ext uri="{FF2B5EF4-FFF2-40B4-BE49-F238E27FC236}">
-                <a16:creationId xmlns:a16="http://schemas.microsoft.com/office/drawing/2014/main" id="{03FF4E5C-3537-47C2-A430-5EE2EA3F0CA1}"/>
+                <a16:creationId xmlns:a16="http://schemas.microsoft.com/office/drawing/2014/main" id="{5C47A2E1-90D1-4D6A-9181-C26A1DC9347D}"/>
               </a:ext>
             </a:extLst>
           </p:cNvPr>
@@ -8227,7 +8227,7 @@
           <p:cNvPr id="32" name="">
             <a:extLst xmlns:a="http://schemas.openxmlformats.org/drawingml/2006/main">
               <a:ext uri="{FF2B5EF4-FFF2-40B4-BE49-F238E27FC236}">
-                <a16:creationId xmlns:a16="http://schemas.microsoft.com/office/drawing/2014/main" id="{765A1529-24B5-4187-88CA-E613D8F98E86}"/>
+                <a16:creationId xmlns:a16="http://schemas.microsoft.com/office/drawing/2014/main" id="{9628AD0D-4460-4A1D-B2C9-0FCB6B90E3E1}"/>
               </a:ext>
             </a:extLst>
           </p:cNvPr>
@@ -8261,7 +8261,7 @@
           <p:cNvPr id="33" name="">
             <a:extLst xmlns:a="http://schemas.openxmlformats.org/drawingml/2006/main">
               <a:ext uri="{FF2B5EF4-FFF2-40B4-BE49-F238E27FC236}">
-                <a16:creationId xmlns:a16="http://schemas.microsoft.com/office/drawing/2014/main" id="{E9DFBF3F-442C-4F0E-8171-7AC7B25A9583}"/>
+                <a16:creationId xmlns:a16="http://schemas.microsoft.com/office/drawing/2014/main" id="{825ADE30-3C95-406E-8C16-E62F0438CCD6}"/>
               </a:ext>
             </a:extLst>
           </p:cNvPr>
@@ -8316,7 +8316,7 @@
     </p:spTree>
     <p:extLst>
       <p:ext uri="{BB962C8B-B14F-4D97-AF65-F5344CB8AC3E}">
-        <p14:creationId xmlns:p14="http://schemas.microsoft.com/office/powerpoint/2010/main" val="2049953028"/>
+        <p14:creationId xmlns:p14="http://schemas.microsoft.com/office/powerpoint/2010/main" val="831958796"/>
       </p:ext>
     </p:extLst>
   </p:cSld>
@@ -8347,7 +8347,7 @@
           <p:cNvPr id="84" name="">
             <a:extLst xmlns:a="http://schemas.openxmlformats.org/drawingml/2006/main">
               <a:ext uri="{FF2B5EF4-FFF2-40B4-BE49-F238E27FC236}">
-                <a16:creationId xmlns:a16="http://schemas.microsoft.com/office/drawing/2014/main" id="{50713F99-9EF5-4D9B-B95F-C32463ADE0D2}"/>
+                <a16:creationId xmlns:a16="http://schemas.microsoft.com/office/drawing/2014/main" id="{9453A3BC-9B1A-4DD2-BA5A-611B37D2DF80}"/>
               </a:ext>
             </a:extLst>
           </p:cNvPr>
@@ -8377,7 +8377,7 @@
           <p:cNvPr id="2" name="">
             <a:extLst xmlns:a="http://schemas.openxmlformats.org/drawingml/2006/main">
               <a:ext uri="{FF2B5EF4-FFF2-40B4-BE49-F238E27FC236}">
-                <a16:creationId xmlns:a16="http://schemas.microsoft.com/office/drawing/2014/main" id="{53B8C58D-5CC2-45F8-BAD5-340723C8D589}"/>
+                <a16:creationId xmlns:a16="http://schemas.microsoft.com/office/drawing/2014/main" id="{D18E8B01-7A13-458F-92C1-513FDE6AFD65}"/>
               </a:ext>
             </a:extLst>
           </p:cNvPr>
@@ -8438,7 +8438,7 @@
           <p:cNvPr id="3" name="">
             <a:extLst xmlns:a="http://schemas.openxmlformats.org/drawingml/2006/main">
               <a:ext uri="{FF2B5EF4-FFF2-40B4-BE49-F238E27FC236}">
-                <a16:creationId xmlns:a16="http://schemas.microsoft.com/office/drawing/2014/main" id="{DB23262D-85DA-4FDE-A7AA-87A16B5A3795}"/>
+                <a16:creationId xmlns:a16="http://schemas.microsoft.com/office/drawing/2014/main" id="{C1F16B67-3B9E-412A-8B6C-AF7BEBC680EF}"/>
               </a:ext>
             </a:extLst>
           </p:cNvPr>
@@ -8495,7 +8495,7 @@
           <p:cNvPr id="4" name="">
             <a:extLst xmlns:a="http://schemas.openxmlformats.org/drawingml/2006/main">
               <a:ext uri="{FF2B5EF4-FFF2-40B4-BE49-F238E27FC236}">
-                <a16:creationId xmlns:a16="http://schemas.microsoft.com/office/drawing/2014/main" id="{AFE12CC4-FE36-4C50-BF29-D4E8D8E8B041}"/>
+                <a16:creationId xmlns:a16="http://schemas.microsoft.com/office/drawing/2014/main" id="{352ED51A-61E9-4D12-8E21-128AF688E63E}"/>
               </a:ext>
             </a:extLst>
           </p:cNvPr>
@@ -8552,7 +8552,7 @@
           <p:cNvPr id="5" name="">
             <a:extLst xmlns:a="http://schemas.openxmlformats.org/drawingml/2006/main">
               <a:ext uri="{FF2B5EF4-FFF2-40B4-BE49-F238E27FC236}">
-                <a16:creationId xmlns:a16="http://schemas.microsoft.com/office/drawing/2014/main" id="{E4384180-D7F6-4EE0-A19B-EE8311EC9F96}"/>
+                <a16:creationId xmlns:a16="http://schemas.microsoft.com/office/drawing/2014/main" id="{82C8B0BA-40EB-41E1-9C3B-C611BBD662FA}"/>
               </a:ext>
             </a:extLst>
           </p:cNvPr>
@@ -8609,7 +8609,7 @@
           <p:cNvPr id="6" name="">
             <a:extLst xmlns:a="http://schemas.openxmlformats.org/drawingml/2006/main">
               <a:ext uri="{FF2B5EF4-FFF2-40B4-BE49-F238E27FC236}">
-                <a16:creationId xmlns:a16="http://schemas.microsoft.com/office/drawing/2014/main" id="{A36CA818-0079-49EB-AB7B-4377579D137E}"/>
+                <a16:creationId xmlns:a16="http://schemas.microsoft.com/office/drawing/2014/main" id="{66BAB8D4-F0BB-450C-9E82-7F01078964B3}"/>
               </a:ext>
             </a:extLst>
           </p:cNvPr>
@@ -8666,7 +8666,7 @@
           <p:cNvPr id="7" name="">
             <a:extLst xmlns:a="http://schemas.openxmlformats.org/drawingml/2006/main">
               <a:ext uri="{FF2B5EF4-FFF2-40B4-BE49-F238E27FC236}">
-                <a16:creationId xmlns:a16="http://schemas.microsoft.com/office/drawing/2014/main" id="{225B13B3-75A6-4DD1-ADE5-8770EB2C0867}"/>
+                <a16:creationId xmlns:a16="http://schemas.microsoft.com/office/drawing/2014/main" id="{2DD8E122-4E2F-410A-A273-E390234EDB13}"/>
               </a:ext>
             </a:extLst>
           </p:cNvPr>
@@ -8723,7 +8723,7 @@
           <p:cNvPr id="8" name="">
             <a:extLst xmlns:a="http://schemas.openxmlformats.org/drawingml/2006/main">
               <a:ext uri="{FF2B5EF4-FFF2-40B4-BE49-F238E27FC236}">
-                <a16:creationId xmlns:a16="http://schemas.microsoft.com/office/drawing/2014/main" id="{6433A37B-08D8-4C5C-A3B9-2EF42A30D296}"/>
+                <a16:creationId xmlns:a16="http://schemas.microsoft.com/office/drawing/2014/main" id="{071F6730-3F76-465F-B5AC-F5BCD4BFEF8C}"/>
               </a:ext>
             </a:extLst>
           </p:cNvPr>
@@ -8780,7 +8780,7 @@
           <p:cNvPr id="9" name="">
             <a:extLst xmlns:a="http://schemas.openxmlformats.org/drawingml/2006/main">
               <a:ext uri="{FF2B5EF4-FFF2-40B4-BE49-F238E27FC236}">
-                <a16:creationId xmlns:a16="http://schemas.microsoft.com/office/drawing/2014/main" id="{6491DE28-BF7F-4479-A367-F456CC6F2BFB}"/>
+                <a16:creationId xmlns:a16="http://schemas.microsoft.com/office/drawing/2014/main" id="{A1BA676E-7AA3-477A-ADF7-903763039294}"/>
               </a:ext>
             </a:extLst>
           </p:cNvPr>
@@ -8837,7 +8837,7 @@
           <p:cNvPr id="10" name="">
             <a:extLst xmlns:a="http://schemas.openxmlformats.org/drawingml/2006/main">
               <a:ext uri="{FF2B5EF4-FFF2-40B4-BE49-F238E27FC236}">
-                <a16:creationId xmlns:a16="http://schemas.microsoft.com/office/drawing/2014/main" id="{49FB7B31-561F-4457-A8FA-FFEC487FF1AF}"/>
+                <a16:creationId xmlns:a16="http://schemas.microsoft.com/office/drawing/2014/main" id="{82873B85-43F8-426E-BE39-31AF584AD179}"/>
               </a:ext>
             </a:extLst>
           </p:cNvPr>
@@ -8871,7 +8871,7 @@
           <p:cNvPr id="11" name="">
             <a:extLst xmlns:a="http://schemas.openxmlformats.org/drawingml/2006/main">
               <a:ext uri="{FF2B5EF4-FFF2-40B4-BE49-F238E27FC236}">
-                <a16:creationId xmlns:a16="http://schemas.microsoft.com/office/drawing/2014/main" id="{C54A142D-3652-4782-980A-D572E063CD6D}"/>
+                <a16:creationId xmlns:a16="http://schemas.microsoft.com/office/drawing/2014/main" id="{E1A86E2E-5E13-4EAE-A93B-9660C634311A}"/>
               </a:ext>
             </a:extLst>
           </p:cNvPr>
@@ -8901,7 +8901,7 @@
           <p:cNvPr id="12" name="">
             <a:extLst xmlns:a="http://schemas.openxmlformats.org/drawingml/2006/main">
               <a:ext uri="{FF2B5EF4-FFF2-40B4-BE49-F238E27FC236}">
-                <a16:creationId xmlns:a16="http://schemas.microsoft.com/office/drawing/2014/main" id="{C09B2DA0-F634-44D0-A876-3F3E43D3AEEE}"/>
+                <a16:creationId xmlns:a16="http://schemas.microsoft.com/office/drawing/2014/main" id="{D2B4CC53-58A3-46AA-A6E3-16812C15EAE0}"/>
               </a:ext>
             </a:extLst>
           </p:cNvPr>
@@ -8958,7 +8958,7 @@
           <p:cNvPr id="13" name="">
             <a:extLst xmlns:a="http://schemas.openxmlformats.org/drawingml/2006/main">
               <a:ext uri="{FF2B5EF4-FFF2-40B4-BE49-F238E27FC236}">
-                <a16:creationId xmlns:a16="http://schemas.microsoft.com/office/drawing/2014/main" id="{8C34E9D1-A3F6-4967-8D40-10BA6B10FB64}"/>
+                <a16:creationId xmlns:a16="http://schemas.microsoft.com/office/drawing/2014/main" id="{FFE3E5B6-8D85-430E-BD04-D206957DD142}"/>
               </a:ext>
             </a:extLst>
           </p:cNvPr>
@@ -9015,7 +9015,7 @@
           <p:cNvPr id="14" name="">
             <a:extLst xmlns:a="http://schemas.openxmlformats.org/drawingml/2006/main">
               <a:ext uri="{FF2B5EF4-FFF2-40B4-BE49-F238E27FC236}">
-                <a16:creationId xmlns:a16="http://schemas.microsoft.com/office/drawing/2014/main" id="{BA82B8B3-A375-4293-AF6D-0EEB00D429FE}"/>
+                <a16:creationId xmlns:a16="http://schemas.microsoft.com/office/drawing/2014/main" id="{3FC3B5B4-52AD-473F-9C52-00D4CD3C0698}"/>
               </a:ext>
             </a:extLst>
           </p:cNvPr>
@@ -9072,7 +9072,7 @@
           <p:cNvPr id="15" name="">
             <a:extLst xmlns:a="http://schemas.openxmlformats.org/drawingml/2006/main">
               <a:ext uri="{FF2B5EF4-FFF2-40B4-BE49-F238E27FC236}">
-                <a16:creationId xmlns:a16="http://schemas.microsoft.com/office/drawing/2014/main" id="{793DF63E-65E8-463B-A0BD-FAD21E99CA4C}"/>
+                <a16:creationId xmlns:a16="http://schemas.microsoft.com/office/drawing/2014/main" id="{792B4BFF-BCC2-41E4-8CE2-1214C7D23013}"/>
               </a:ext>
             </a:extLst>
           </p:cNvPr>
@@ -9129,7 +9129,7 @@
           <p:cNvPr id="16" name="">
             <a:extLst xmlns:a="http://schemas.openxmlformats.org/drawingml/2006/main">
               <a:ext uri="{FF2B5EF4-FFF2-40B4-BE49-F238E27FC236}">
-                <a16:creationId xmlns:a16="http://schemas.microsoft.com/office/drawing/2014/main" id="{DAF1FD6A-7A52-47BA-A035-BB001FB6588D}"/>
+                <a16:creationId xmlns:a16="http://schemas.microsoft.com/office/drawing/2014/main" id="{6D565D6A-7350-4830-A057-D8EE9B2A08D2}"/>
               </a:ext>
             </a:extLst>
           </p:cNvPr>
@@ -9163,7 +9163,7 @@
           <p:cNvPr id="17" name="">
             <a:extLst xmlns:a="http://schemas.openxmlformats.org/drawingml/2006/main">
               <a:ext uri="{FF2B5EF4-FFF2-40B4-BE49-F238E27FC236}">
-                <a16:creationId xmlns:a16="http://schemas.microsoft.com/office/drawing/2014/main" id="{24CDD05D-3352-4AE0-BEA4-283C1CCA129D}"/>
+                <a16:creationId xmlns:a16="http://schemas.microsoft.com/office/drawing/2014/main" id="{FDD87745-7EF4-4AF8-A5E1-53D2599E6761}"/>
               </a:ext>
             </a:extLst>
           </p:cNvPr>
@@ -9193,7 +9193,7 @@
           <p:cNvPr id="18" name="">
             <a:extLst xmlns:a="http://schemas.openxmlformats.org/drawingml/2006/main">
               <a:ext uri="{FF2B5EF4-FFF2-40B4-BE49-F238E27FC236}">
-                <a16:creationId xmlns:a16="http://schemas.microsoft.com/office/drawing/2014/main" id="{7B46ECC2-C661-493B-9CAA-B0EDED644383}"/>
+                <a16:creationId xmlns:a16="http://schemas.microsoft.com/office/drawing/2014/main" id="{86E20C0D-081B-4353-A593-B4F878D41C6F}"/>
               </a:ext>
             </a:extLst>
           </p:cNvPr>
@@ -9250,7 +9250,7 @@
           <p:cNvPr id="19" name="">
             <a:extLst xmlns:a="http://schemas.openxmlformats.org/drawingml/2006/main">
               <a:ext uri="{FF2B5EF4-FFF2-40B4-BE49-F238E27FC236}">
-                <a16:creationId xmlns:a16="http://schemas.microsoft.com/office/drawing/2014/main" id="{D195196E-3F28-4C8B-9E1F-4D44B0B7B615}"/>
+                <a16:creationId xmlns:a16="http://schemas.microsoft.com/office/drawing/2014/main" id="{9342CA68-E0FD-42DB-B2C3-D597469647E2}"/>
               </a:ext>
             </a:extLst>
           </p:cNvPr>
@@ -9307,7 +9307,7 @@
           <p:cNvPr id="20" name="">
             <a:extLst xmlns:a="http://schemas.openxmlformats.org/drawingml/2006/main">
               <a:ext uri="{FF2B5EF4-FFF2-40B4-BE49-F238E27FC236}">
-                <a16:creationId xmlns:a16="http://schemas.microsoft.com/office/drawing/2014/main" id="{AC209545-910A-4B70-97B7-4C963A2A87AE}"/>
+                <a16:creationId xmlns:a16="http://schemas.microsoft.com/office/drawing/2014/main" id="{EBF88BD0-4726-4058-BDE9-965C99685E5A}"/>
               </a:ext>
             </a:extLst>
           </p:cNvPr>
@@ -9364,7 +9364,7 @@
           <p:cNvPr id="21" name="">
             <a:extLst xmlns:a="http://schemas.openxmlformats.org/drawingml/2006/main">
               <a:ext uri="{FF2B5EF4-FFF2-40B4-BE49-F238E27FC236}">
-                <a16:creationId xmlns:a16="http://schemas.microsoft.com/office/drawing/2014/main" id="{B818ABF0-B49D-4C0C-84A1-314868B3E2AB}"/>
+                <a16:creationId xmlns:a16="http://schemas.microsoft.com/office/drawing/2014/main" id="{D7CA7D36-C33E-4652-86C6-BFDCD66EA722}"/>
               </a:ext>
             </a:extLst>
           </p:cNvPr>
@@ -9421,7 +9421,7 @@
           <p:cNvPr id="22" name="">
             <a:extLst xmlns:a="http://schemas.openxmlformats.org/drawingml/2006/main">
               <a:ext uri="{FF2B5EF4-FFF2-40B4-BE49-F238E27FC236}">
-                <a16:creationId xmlns:a16="http://schemas.microsoft.com/office/drawing/2014/main" id="{4E079A89-E02E-484A-862D-A1EADBF62990}"/>
+                <a16:creationId xmlns:a16="http://schemas.microsoft.com/office/drawing/2014/main" id="{D9EE0D0D-5F10-479E-BBF9-E36C0BB6F205}"/>
               </a:ext>
             </a:extLst>
           </p:cNvPr>
@@ -9455,7 +9455,7 @@
           <p:cNvPr id="23" name="">
             <a:extLst xmlns:a="http://schemas.openxmlformats.org/drawingml/2006/main">
               <a:ext uri="{FF2B5EF4-FFF2-40B4-BE49-F238E27FC236}">
-                <a16:creationId xmlns:a16="http://schemas.microsoft.com/office/drawing/2014/main" id="{408DFB5D-6F02-49B2-8E0C-121211487054}"/>
+                <a16:creationId xmlns:a16="http://schemas.microsoft.com/office/drawing/2014/main" id="{EAEEC177-F69E-4426-9B9D-AEF82D067850}"/>
               </a:ext>
             </a:extLst>
           </p:cNvPr>
@@ -9485,7 +9485,7 @@
           <p:cNvPr id="24" name="">
             <a:extLst xmlns:a="http://schemas.openxmlformats.org/drawingml/2006/main">
               <a:ext uri="{FF2B5EF4-FFF2-40B4-BE49-F238E27FC236}">
-                <a16:creationId xmlns:a16="http://schemas.microsoft.com/office/drawing/2014/main" id="{F83D4B6C-EA1B-4032-8014-EDC3B19509F9}"/>
+                <a16:creationId xmlns:a16="http://schemas.microsoft.com/office/drawing/2014/main" id="{2403E385-E2EB-4948-8D18-0DEA42B4D5E3}"/>
               </a:ext>
             </a:extLst>
           </p:cNvPr>
@@ -9542,7 +9542,7 @@
           <p:cNvPr id="25" name="">
             <a:extLst xmlns:a="http://schemas.openxmlformats.org/drawingml/2006/main">
               <a:ext uri="{FF2B5EF4-FFF2-40B4-BE49-F238E27FC236}">
-                <a16:creationId xmlns:a16="http://schemas.microsoft.com/office/drawing/2014/main" id="{0AF3146E-83FF-42A1-B799-6F1E44741206}"/>
+                <a16:creationId xmlns:a16="http://schemas.microsoft.com/office/drawing/2014/main" id="{4F9C1494-DC4E-45CA-9CF8-945E80578B99}"/>
               </a:ext>
             </a:extLst>
           </p:cNvPr>
@@ -9599,7 +9599,7 @@
           <p:cNvPr id="26" name="">
             <a:extLst xmlns:a="http://schemas.openxmlformats.org/drawingml/2006/main">
               <a:ext uri="{FF2B5EF4-FFF2-40B4-BE49-F238E27FC236}">
-                <a16:creationId xmlns:a16="http://schemas.microsoft.com/office/drawing/2014/main" id="{8FDF93A5-C510-4E92-91AD-DD3FE16A4E28}"/>
+                <a16:creationId xmlns:a16="http://schemas.microsoft.com/office/drawing/2014/main" id="{DB8713B6-3BAA-4B62-9560-79E6C8FC1ACD}"/>
               </a:ext>
             </a:extLst>
           </p:cNvPr>
@@ -9656,7 +9656,7 @@
           <p:cNvPr id="27" name="">
             <a:extLst xmlns:a="http://schemas.openxmlformats.org/drawingml/2006/main">
               <a:ext uri="{FF2B5EF4-FFF2-40B4-BE49-F238E27FC236}">
-                <a16:creationId xmlns:a16="http://schemas.microsoft.com/office/drawing/2014/main" id="{F6368729-2164-46D3-8A08-9FB3F424FCCA}"/>
+                <a16:creationId xmlns:a16="http://schemas.microsoft.com/office/drawing/2014/main" id="{A5ADB37F-7B02-4D8E-9942-01B628B3DF4D}"/>
               </a:ext>
             </a:extLst>
           </p:cNvPr>
@@ -9713,7 +9713,7 @@
           <p:cNvPr id="28" name="">
             <a:extLst xmlns:a="http://schemas.openxmlformats.org/drawingml/2006/main">
               <a:ext uri="{FF2B5EF4-FFF2-40B4-BE49-F238E27FC236}">
-                <a16:creationId xmlns:a16="http://schemas.microsoft.com/office/drawing/2014/main" id="{063E74EE-D4CF-4E99-B1A6-8EB7E61547A3}"/>
+                <a16:creationId xmlns:a16="http://schemas.microsoft.com/office/drawing/2014/main" id="{7296C294-E174-42F5-99B6-1D1FE20FB0EE}"/>
               </a:ext>
             </a:extLst>
           </p:cNvPr>
@@ -9747,7 +9747,7 @@
           <p:cNvPr id="29" name="">
             <a:extLst xmlns:a="http://schemas.openxmlformats.org/drawingml/2006/main">
               <a:ext uri="{FF2B5EF4-FFF2-40B4-BE49-F238E27FC236}">
-                <a16:creationId xmlns:a16="http://schemas.microsoft.com/office/drawing/2014/main" id="{F9886A48-E9BA-4E65-BA4A-E6AC54875D80}"/>
+                <a16:creationId xmlns:a16="http://schemas.microsoft.com/office/drawing/2014/main" id="{2816074E-B4C7-4E7F-8938-B44DB25BF216}"/>
               </a:ext>
             </a:extLst>
           </p:cNvPr>
@@ -9777,7 +9777,7 @@
           <p:cNvPr id="30" name="">
             <a:extLst xmlns:a="http://schemas.openxmlformats.org/drawingml/2006/main">
               <a:ext uri="{FF2B5EF4-FFF2-40B4-BE49-F238E27FC236}">
-                <a16:creationId xmlns:a16="http://schemas.microsoft.com/office/drawing/2014/main" id="{AD6D1092-3897-4E70-823B-37B6B72AD507}"/>
+                <a16:creationId xmlns:a16="http://schemas.microsoft.com/office/drawing/2014/main" id="{901DC309-1800-4687-BFC4-37872460B7CB}"/>
               </a:ext>
             </a:extLst>
           </p:cNvPr>
@@ -9834,7 +9834,7 @@
           <p:cNvPr id="31" name="">
             <a:extLst xmlns:a="http://schemas.openxmlformats.org/drawingml/2006/main">
               <a:ext uri="{FF2B5EF4-FFF2-40B4-BE49-F238E27FC236}">
-                <a16:creationId xmlns:a16="http://schemas.microsoft.com/office/drawing/2014/main" id="{76CBDD49-16C7-4DC0-ABFC-C2DDA57489AC}"/>
+                <a16:creationId xmlns:a16="http://schemas.microsoft.com/office/drawing/2014/main" id="{D1AE6EE3-1176-43AA-B902-1DDC155E9847}"/>
               </a:ext>
             </a:extLst>
           </p:cNvPr>
@@ -9891,7 +9891,7 @@
           <p:cNvPr id="32" name="">
             <a:extLst xmlns:a="http://schemas.openxmlformats.org/drawingml/2006/main">
               <a:ext uri="{FF2B5EF4-FFF2-40B4-BE49-F238E27FC236}">
-                <a16:creationId xmlns:a16="http://schemas.microsoft.com/office/drawing/2014/main" id="{F6CEDF47-456B-4357-84E7-A0BDB85900C0}"/>
+                <a16:creationId xmlns:a16="http://schemas.microsoft.com/office/drawing/2014/main" id="{A7B59029-2F75-408A-BE02-F26F67F34BF0}"/>
               </a:ext>
             </a:extLst>
           </p:cNvPr>
@@ -9948,7 +9948,7 @@
           <p:cNvPr id="33" name="">
             <a:extLst xmlns:a="http://schemas.openxmlformats.org/drawingml/2006/main">
               <a:ext uri="{FF2B5EF4-FFF2-40B4-BE49-F238E27FC236}">
-                <a16:creationId xmlns:a16="http://schemas.microsoft.com/office/drawing/2014/main" id="{E81CADBB-83B6-49B0-9B85-C23948FC4937}"/>
+                <a16:creationId xmlns:a16="http://schemas.microsoft.com/office/drawing/2014/main" id="{4CD4CDF8-5C4A-4718-B09E-0F48F38C893B}"/>
               </a:ext>
             </a:extLst>
           </p:cNvPr>
@@ -10005,7 +10005,7 @@
           <p:cNvPr id="34" name="">
             <a:extLst xmlns:a="http://schemas.openxmlformats.org/drawingml/2006/main">
               <a:ext uri="{FF2B5EF4-FFF2-40B4-BE49-F238E27FC236}">
-                <a16:creationId xmlns:a16="http://schemas.microsoft.com/office/drawing/2014/main" id="{3F44844E-CA66-46EE-AC7F-A762B6C8B7E4}"/>
+                <a16:creationId xmlns:a16="http://schemas.microsoft.com/office/drawing/2014/main" id="{252DB2E3-D002-41E2-B71F-F1DF25F810AB}"/>
               </a:ext>
             </a:extLst>
           </p:cNvPr>
@@ -10039,7 +10039,7 @@
           <p:cNvPr id="35" name="">
             <a:extLst xmlns:a="http://schemas.openxmlformats.org/drawingml/2006/main">
               <a:ext uri="{FF2B5EF4-FFF2-40B4-BE49-F238E27FC236}">
-                <a16:creationId xmlns:a16="http://schemas.microsoft.com/office/drawing/2014/main" id="{812FDEAC-AF85-4DEB-BBAC-191559E7E273}"/>
+                <a16:creationId xmlns:a16="http://schemas.microsoft.com/office/drawing/2014/main" id="{44D1AD5A-65F6-41F8-94AD-DEE18F18FCB2}"/>
               </a:ext>
             </a:extLst>
           </p:cNvPr>
@@ -10069,7 +10069,7 @@
           <p:cNvPr id="36" name="">
             <a:extLst xmlns:a="http://schemas.openxmlformats.org/drawingml/2006/main">
               <a:ext uri="{FF2B5EF4-FFF2-40B4-BE49-F238E27FC236}">
-                <a16:creationId xmlns:a16="http://schemas.microsoft.com/office/drawing/2014/main" id="{5428A44B-AF20-4AA7-A82A-FD48B4286B84}"/>
+                <a16:creationId xmlns:a16="http://schemas.microsoft.com/office/drawing/2014/main" id="{86FA9C53-01B8-4EF5-A7C4-07B3C9C741DA}"/>
               </a:ext>
             </a:extLst>
           </p:cNvPr>
@@ -10126,7 +10126,7 @@
           <p:cNvPr id="37" name="">
             <a:extLst xmlns:a="http://schemas.openxmlformats.org/drawingml/2006/main">
               <a:ext uri="{FF2B5EF4-FFF2-40B4-BE49-F238E27FC236}">
-                <a16:creationId xmlns:a16="http://schemas.microsoft.com/office/drawing/2014/main" id="{153AFC90-8C86-41F5-936F-CC836263211E}"/>
+                <a16:creationId xmlns:a16="http://schemas.microsoft.com/office/drawing/2014/main" id="{C393CDB2-4183-4793-8F9C-474CA106ACF2}"/>
               </a:ext>
             </a:extLst>
           </p:cNvPr>
@@ -10183,7 +10183,7 @@
           <p:cNvPr id="38" name="">
             <a:extLst xmlns:a="http://schemas.openxmlformats.org/drawingml/2006/main">
               <a:ext uri="{FF2B5EF4-FFF2-40B4-BE49-F238E27FC236}">
-                <a16:creationId xmlns:a16="http://schemas.microsoft.com/office/drawing/2014/main" id="{008E9985-3222-4157-89DE-009C61BD3D61}"/>
+                <a16:creationId xmlns:a16="http://schemas.microsoft.com/office/drawing/2014/main" id="{5CC1C410-71A1-4BD4-8997-B025F8A17082}"/>
               </a:ext>
             </a:extLst>
           </p:cNvPr>
@@ -10240,7 +10240,7 @@
           <p:cNvPr id="39" name="">
             <a:extLst xmlns:a="http://schemas.openxmlformats.org/drawingml/2006/main">
               <a:ext uri="{FF2B5EF4-FFF2-40B4-BE49-F238E27FC236}">
-                <a16:creationId xmlns:a16="http://schemas.microsoft.com/office/drawing/2014/main" id="{2D6A4176-B149-4E9D-8A2B-9B5DA12F1BB9}"/>
+                <a16:creationId xmlns:a16="http://schemas.microsoft.com/office/drawing/2014/main" id="{B93D4BEA-AC7E-44E9-A18B-B77245254B52}"/>
               </a:ext>
             </a:extLst>
           </p:cNvPr>
@@ -10297,7 +10297,7 @@
           <p:cNvPr id="40" name="">
             <a:extLst xmlns:a="http://schemas.openxmlformats.org/drawingml/2006/main">
               <a:ext uri="{FF2B5EF4-FFF2-40B4-BE49-F238E27FC236}">
-                <a16:creationId xmlns:a16="http://schemas.microsoft.com/office/drawing/2014/main" id="{148A4366-57CC-4CDA-835F-4DCEBD57318E}"/>
+                <a16:creationId xmlns:a16="http://schemas.microsoft.com/office/drawing/2014/main" id="{F2D9FF8F-5BA5-4CA9-B18F-B6F4E8304485}"/>
               </a:ext>
             </a:extLst>
           </p:cNvPr>
@@ -10331,7 +10331,7 @@
           <p:cNvPr id="41" name="">
             <a:extLst xmlns:a="http://schemas.openxmlformats.org/drawingml/2006/main">
               <a:ext uri="{FF2B5EF4-FFF2-40B4-BE49-F238E27FC236}">
-                <a16:creationId xmlns:a16="http://schemas.microsoft.com/office/drawing/2014/main" id="{28778D5D-9193-4BD2-AB37-F967D9CF0542}"/>
+                <a16:creationId xmlns:a16="http://schemas.microsoft.com/office/drawing/2014/main" id="{3FD3358A-1621-4AF5-B0A8-15CE6DCB3EDE}"/>
               </a:ext>
             </a:extLst>
           </p:cNvPr>
@@ -10361,7 +10361,7 @@
           <p:cNvPr id="42" name="">
             <a:extLst xmlns:a="http://schemas.openxmlformats.org/drawingml/2006/main">
               <a:ext uri="{FF2B5EF4-FFF2-40B4-BE49-F238E27FC236}">
-                <a16:creationId xmlns:a16="http://schemas.microsoft.com/office/drawing/2014/main" id="{94FC623C-6C08-4E00-93DD-219615C4809A}"/>
+                <a16:creationId xmlns:a16="http://schemas.microsoft.com/office/drawing/2014/main" id="{1E5CAD84-2BC8-4DF1-8BE6-313426C7A9CA}"/>
               </a:ext>
             </a:extLst>
           </p:cNvPr>
@@ -10418,7 +10418,7 @@
           <p:cNvPr id="43" name="">
             <a:extLst xmlns:a="http://schemas.openxmlformats.org/drawingml/2006/main">
               <a:ext uri="{FF2B5EF4-FFF2-40B4-BE49-F238E27FC236}">
-                <a16:creationId xmlns:a16="http://schemas.microsoft.com/office/drawing/2014/main" id="{ADD39919-53B2-46AA-8BAF-65CEFC467F7D}"/>
+                <a16:creationId xmlns:a16="http://schemas.microsoft.com/office/drawing/2014/main" id="{321DF4E9-53AD-490C-8225-973806DD1682}"/>
               </a:ext>
             </a:extLst>
           </p:cNvPr>
@@ -10475,7 +10475,7 @@
           <p:cNvPr id="44" name="">
             <a:extLst xmlns:a="http://schemas.openxmlformats.org/drawingml/2006/main">
               <a:ext uri="{FF2B5EF4-FFF2-40B4-BE49-F238E27FC236}">
-                <a16:creationId xmlns:a16="http://schemas.microsoft.com/office/drawing/2014/main" id="{8F3D855E-56A7-4828-8466-5047CD435BD9}"/>
+                <a16:creationId xmlns:a16="http://schemas.microsoft.com/office/drawing/2014/main" id="{323FB0C7-2E26-4E80-A0A6-729294642C42}"/>
               </a:ext>
             </a:extLst>
           </p:cNvPr>
@@ -10532,7 +10532,7 @@
           <p:cNvPr id="45" name="">
             <a:extLst xmlns:a="http://schemas.openxmlformats.org/drawingml/2006/main">
               <a:ext uri="{FF2B5EF4-FFF2-40B4-BE49-F238E27FC236}">
-                <a16:creationId xmlns:a16="http://schemas.microsoft.com/office/drawing/2014/main" id="{67A864F3-DA8F-40B9-9742-2FE28456151B}"/>
+                <a16:creationId xmlns:a16="http://schemas.microsoft.com/office/drawing/2014/main" id="{205F786B-E543-474F-AC7D-835D053C83CC}"/>
               </a:ext>
             </a:extLst>
           </p:cNvPr>
@@ -10589,7 +10589,7 @@
           <p:cNvPr id="46" name="">
             <a:extLst xmlns:a="http://schemas.openxmlformats.org/drawingml/2006/main">
               <a:ext uri="{FF2B5EF4-FFF2-40B4-BE49-F238E27FC236}">
-                <a16:creationId xmlns:a16="http://schemas.microsoft.com/office/drawing/2014/main" id="{41B9A9B8-51D6-40B2-9663-33B081FDC66F}"/>
+                <a16:creationId xmlns:a16="http://schemas.microsoft.com/office/drawing/2014/main" id="{FFAE91E3-AB72-4B7A-89F0-8603F00A5A23}"/>
               </a:ext>
             </a:extLst>
           </p:cNvPr>
@@ -10623,7 +10623,7 @@
           <p:cNvPr id="47" name="">
             <a:extLst xmlns:a="http://schemas.openxmlformats.org/drawingml/2006/main">
               <a:ext uri="{FF2B5EF4-FFF2-40B4-BE49-F238E27FC236}">
-                <a16:creationId xmlns:a16="http://schemas.microsoft.com/office/drawing/2014/main" id="{8ED30641-6257-49B1-8545-F6543B66F43E}"/>
+                <a16:creationId xmlns:a16="http://schemas.microsoft.com/office/drawing/2014/main" id="{5900E81B-27F8-4600-BF79-2B1D019A0017}"/>
               </a:ext>
             </a:extLst>
           </p:cNvPr>
@@ -10680,7 +10680,7 @@
           <p:cNvPr id="48" name="">
             <a:extLst xmlns:a="http://schemas.openxmlformats.org/drawingml/2006/main">
               <a:ext uri="{FF2B5EF4-FFF2-40B4-BE49-F238E27FC236}">
-                <a16:creationId xmlns:a16="http://schemas.microsoft.com/office/drawing/2014/main" id="{62B85B55-46FD-4998-99E5-6C6440B88B08}"/>
+                <a16:creationId xmlns:a16="http://schemas.microsoft.com/office/drawing/2014/main" id="{7A73E8FD-C061-4C80-8712-BEC03495E6B8}"/>
               </a:ext>
             </a:extLst>
           </p:cNvPr>
@@ -10737,7 +10737,7 @@
           <p:cNvPr id="49" name="">
             <a:extLst xmlns:a="http://schemas.openxmlformats.org/drawingml/2006/main">
               <a:ext uri="{FF2B5EF4-FFF2-40B4-BE49-F238E27FC236}">
-                <a16:creationId xmlns:a16="http://schemas.microsoft.com/office/drawing/2014/main" id="{39983553-7751-4C67-B278-99F612760838}"/>
+                <a16:creationId xmlns:a16="http://schemas.microsoft.com/office/drawing/2014/main" id="{48188BCE-FC74-4725-A45F-CCDA34111282}"/>
               </a:ext>
             </a:extLst>
           </p:cNvPr>
@@ -10771,7 +10771,7 @@
           <p:cNvPr id="50" name="">
             <a:extLst xmlns:a="http://schemas.openxmlformats.org/drawingml/2006/main">
               <a:ext uri="{FF2B5EF4-FFF2-40B4-BE49-F238E27FC236}">
-                <a16:creationId xmlns:a16="http://schemas.microsoft.com/office/drawing/2014/main" id="{224BD7B3-B159-469E-849D-970DF1527DCA}"/>
+                <a16:creationId xmlns:a16="http://schemas.microsoft.com/office/drawing/2014/main" id="{B738B489-9D80-41F4-870D-9B9A146E31D5}"/>
               </a:ext>
             </a:extLst>
           </p:cNvPr>
@@ -10828,7 +10828,7 @@
           <p:cNvPr id="51" name="">
             <a:extLst xmlns:a="http://schemas.openxmlformats.org/drawingml/2006/main">
               <a:ext uri="{FF2B5EF4-FFF2-40B4-BE49-F238E27FC236}">
-                <a16:creationId xmlns:a16="http://schemas.microsoft.com/office/drawing/2014/main" id="{927232F7-72F0-4F29-B132-489C3873D9CD}"/>
+                <a16:creationId xmlns:a16="http://schemas.microsoft.com/office/drawing/2014/main" id="{21333133-F5ED-4171-8732-69BC0B7628EF}"/>
               </a:ext>
             </a:extLst>
           </p:cNvPr>
@@ -10885,7 +10885,7 @@
           <p:cNvPr id="52" name="">
             <a:extLst xmlns:a="http://schemas.openxmlformats.org/drawingml/2006/main">
               <a:ext uri="{FF2B5EF4-FFF2-40B4-BE49-F238E27FC236}">
-                <a16:creationId xmlns:a16="http://schemas.microsoft.com/office/drawing/2014/main" id="{E9B1F625-C206-4BBF-9F49-D08173D52A98}"/>
+                <a16:creationId xmlns:a16="http://schemas.microsoft.com/office/drawing/2014/main" id="{F1B4FCE1-FF50-4993-A6CB-C8773A8FD922}"/>
               </a:ext>
             </a:extLst>
           </p:cNvPr>
@@ -10919,7 +10919,7 @@
           <p:cNvPr id="53" name="">
             <a:extLst xmlns:a="http://schemas.openxmlformats.org/drawingml/2006/main">
               <a:ext uri="{FF2B5EF4-FFF2-40B4-BE49-F238E27FC236}">
-                <a16:creationId xmlns:a16="http://schemas.microsoft.com/office/drawing/2014/main" id="{6FC3F1B1-C16F-4F26-A5E2-A4B7990AA1C2}"/>
+                <a16:creationId xmlns:a16="http://schemas.microsoft.com/office/drawing/2014/main" id="{93AB5455-FB4E-4FA8-8DE5-76548A2353B2}"/>
               </a:ext>
             </a:extLst>
           </p:cNvPr>
@@ -10976,7 +10976,7 @@
           <p:cNvPr id="54" name="">
             <a:extLst xmlns:a="http://schemas.openxmlformats.org/drawingml/2006/main">
               <a:ext uri="{FF2B5EF4-FFF2-40B4-BE49-F238E27FC236}">
-                <a16:creationId xmlns:a16="http://schemas.microsoft.com/office/drawing/2014/main" id="{A8FD193B-ED8F-4B32-BD18-8ED4858B9F8E}"/>
+                <a16:creationId xmlns:a16="http://schemas.microsoft.com/office/drawing/2014/main" id="{8F10CB23-6BFC-4B44-AD06-45B21C08CDF7}"/>
               </a:ext>
             </a:extLst>
           </p:cNvPr>
@@ -11033,7 +11033,7 @@
           <p:cNvPr id="55" name="">
             <a:extLst xmlns:a="http://schemas.openxmlformats.org/drawingml/2006/main">
               <a:ext uri="{FF2B5EF4-FFF2-40B4-BE49-F238E27FC236}">
-                <a16:creationId xmlns:a16="http://schemas.microsoft.com/office/drawing/2014/main" id="{1C96FAB7-C18D-45C5-A910-29BB593FEDDC}"/>
+                <a16:creationId xmlns:a16="http://schemas.microsoft.com/office/drawing/2014/main" id="{8AC0ADE2-D698-4701-B862-C66B4B6CB295}"/>
               </a:ext>
             </a:extLst>
           </p:cNvPr>
@@ -11067,7 +11067,7 @@
           <p:cNvPr id="56" name="">
             <a:extLst xmlns:a="http://schemas.openxmlformats.org/drawingml/2006/main">
               <a:ext uri="{FF2B5EF4-FFF2-40B4-BE49-F238E27FC236}">
-                <a16:creationId xmlns:a16="http://schemas.microsoft.com/office/drawing/2014/main" id="{D2786707-D739-4980-A214-FB1F9AB43D64}"/>
+                <a16:creationId xmlns:a16="http://schemas.microsoft.com/office/drawing/2014/main" id="{273CE501-5971-465E-8312-826AC6417C92}"/>
               </a:ext>
             </a:extLst>
           </p:cNvPr>
@@ -11124,7 +11124,7 @@
           <p:cNvPr id="57" name="">
             <a:extLst xmlns:a="http://schemas.openxmlformats.org/drawingml/2006/main">
               <a:ext uri="{FF2B5EF4-FFF2-40B4-BE49-F238E27FC236}">
-                <a16:creationId xmlns:a16="http://schemas.microsoft.com/office/drawing/2014/main" id="{AEA6CA97-186B-4502-AF14-278425BB3755}"/>
+                <a16:creationId xmlns:a16="http://schemas.microsoft.com/office/drawing/2014/main" id="{B64C776C-9DD4-47D6-9827-DD30F87A68DB}"/>
               </a:ext>
             </a:extLst>
           </p:cNvPr>
@@ -11181,7 +11181,7 @@
           <p:cNvPr id="58" name="">
             <a:extLst xmlns:a="http://schemas.openxmlformats.org/drawingml/2006/main">
               <a:ext uri="{FF2B5EF4-FFF2-40B4-BE49-F238E27FC236}">
-                <a16:creationId xmlns:a16="http://schemas.microsoft.com/office/drawing/2014/main" id="{05464056-E963-41EF-9AC5-B43374B442FF}"/>
+                <a16:creationId xmlns:a16="http://schemas.microsoft.com/office/drawing/2014/main" id="{8A62ECF0-EDCE-40A1-A9E8-FE5EEF2EF5E9}"/>
               </a:ext>
             </a:extLst>
           </p:cNvPr>
@@ -11215,7 +11215,7 @@
           <p:cNvPr id="59" name="">
             <a:extLst xmlns:a="http://schemas.openxmlformats.org/drawingml/2006/main">
               <a:ext uri="{FF2B5EF4-FFF2-40B4-BE49-F238E27FC236}">
-                <a16:creationId xmlns:a16="http://schemas.microsoft.com/office/drawing/2014/main" id="{60FD6E56-E7D7-4614-A58A-E2B209A3FF8A}"/>
+                <a16:creationId xmlns:a16="http://schemas.microsoft.com/office/drawing/2014/main" id="{28573681-2B1E-4BD0-8FCE-23661B6FCF33}"/>
               </a:ext>
             </a:extLst>
           </p:cNvPr>
@@ -11272,7 +11272,7 @@
           <p:cNvPr id="60" name="">
             <a:extLst xmlns:a="http://schemas.openxmlformats.org/drawingml/2006/main">
               <a:ext uri="{FF2B5EF4-FFF2-40B4-BE49-F238E27FC236}">
-                <a16:creationId xmlns:a16="http://schemas.microsoft.com/office/drawing/2014/main" id="{62596E83-A0E9-4DF8-830E-249AE80A02F6}"/>
+                <a16:creationId xmlns:a16="http://schemas.microsoft.com/office/drawing/2014/main" id="{87FC9257-7AD7-4058-ADC3-9BBACFCB9CC4}"/>
               </a:ext>
             </a:extLst>
           </p:cNvPr>
@@ -11329,7 +11329,7 @@
           <p:cNvPr id="61" name="">
             <a:extLst xmlns:a="http://schemas.openxmlformats.org/drawingml/2006/main">
               <a:ext uri="{FF2B5EF4-FFF2-40B4-BE49-F238E27FC236}">
-                <a16:creationId xmlns:a16="http://schemas.microsoft.com/office/drawing/2014/main" id="{938BE4EA-AB4B-4A59-9943-7826C394FCDA}"/>
+                <a16:creationId xmlns:a16="http://schemas.microsoft.com/office/drawing/2014/main" id="{02110CE6-5585-4D9A-8710-9214F2F1A240}"/>
               </a:ext>
             </a:extLst>
           </p:cNvPr>
@@ -11363,7 +11363,7 @@
           <p:cNvPr id="62" name="">
             <a:extLst xmlns:a="http://schemas.openxmlformats.org/drawingml/2006/main">
               <a:ext uri="{FF2B5EF4-FFF2-40B4-BE49-F238E27FC236}">
-                <a16:creationId xmlns:a16="http://schemas.microsoft.com/office/drawing/2014/main" id="{C8D4205A-0A3A-4DB1-83ED-1B0970C68F7B}"/>
+                <a16:creationId xmlns:a16="http://schemas.microsoft.com/office/drawing/2014/main" id="{1DA41C1B-4181-4C10-87DF-94618D421E33}"/>
               </a:ext>
             </a:extLst>
           </p:cNvPr>
@@ -11420,7 +11420,7 @@
           <p:cNvPr id="63" name="">
             <a:extLst xmlns:a="http://schemas.openxmlformats.org/drawingml/2006/main">
               <a:ext uri="{FF2B5EF4-FFF2-40B4-BE49-F238E27FC236}">
-                <a16:creationId xmlns:a16="http://schemas.microsoft.com/office/drawing/2014/main" id="{E28054A5-6761-413A-8201-2C731A79E6DD}"/>
+                <a16:creationId xmlns:a16="http://schemas.microsoft.com/office/drawing/2014/main" id="{A9C4A61F-9D2A-4061-853C-1E216A2FB509}"/>
               </a:ext>
             </a:extLst>
           </p:cNvPr>
@@ -11477,7 +11477,7 @@
           <p:cNvPr id="64" name="">
             <a:extLst xmlns:a="http://schemas.openxmlformats.org/drawingml/2006/main">
               <a:ext uri="{FF2B5EF4-FFF2-40B4-BE49-F238E27FC236}">
-                <a16:creationId xmlns:a16="http://schemas.microsoft.com/office/drawing/2014/main" id="{B498708F-D05D-4FFF-A4F0-8C7B400AE21C}"/>
+                <a16:creationId xmlns:a16="http://schemas.microsoft.com/office/drawing/2014/main" id="{5703FDEC-B5BC-4103-9EB3-1BF878ECC249}"/>
               </a:ext>
             </a:extLst>
           </p:cNvPr>
@@ -11511,7 +11511,7 @@
           <p:cNvPr id="65" name="">
             <a:extLst xmlns:a="http://schemas.openxmlformats.org/drawingml/2006/main">
               <a:ext uri="{FF2B5EF4-FFF2-40B4-BE49-F238E27FC236}">
-                <a16:creationId xmlns:a16="http://schemas.microsoft.com/office/drawing/2014/main" id="{E5BCB549-D072-4D90-95D9-6C85EEC208F1}"/>
+                <a16:creationId xmlns:a16="http://schemas.microsoft.com/office/drawing/2014/main" id="{57270669-07EA-4703-9817-C3104E43C8E2}"/>
               </a:ext>
             </a:extLst>
           </p:cNvPr>
@@ -11568,7 +11568,7 @@
           <p:cNvPr id="66" name="">
             <a:extLst xmlns:a="http://schemas.openxmlformats.org/drawingml/2006/main">
               <a:ext uri="{FF2B5EF4-FFF2-40B4-BE49-F238E27FC236}">
-                <a16:creationId xmlns:a16="http://schemas.microsoft.com/office/drawing/2014/main" id="{53A822D8-5E0A-4F15-8928-6CE4BEE8FCEB}"/>
+                <a16:creationId xmlns:a16="http://schemas.microsoft.com/office/drawing/2014/main" id="{1DAE8425-BF8A-489A-83E8-8D4C95FD95B9}"/>
               </a:ext>
             </a:extLst>
           </p:cNvPr>
@@ -11625,7 +11625,7 @@
           <p:cNvPr id="67" name="">
             <a:extLst xmlns:a="http://schemas.openxmlformats.org/drawingml/2006/main">
               <a:ext uri="{FF2B5EF4-FFF2-40B4-BE49-F238E27FC236}">
-                <a16:creationId xmlns:a16="http://schemas.microsoft.com/office/drawing/2014/main" id="{3EB11C55-E05F-4498-B96E-681410078DEE}"/>
+                <a16:creationId xmlns:a16="http://schemas.microsoft.com/office/drawing/2014/main" id="{A5ACB1A8-CFC0-47F4-A637-FB0AE80970DB}"/>
               </a:ext>
             </a:extLst>
           </p:cNvPr>
@@ -11659,7 +11659,7 @@
           <p:cNvPr id="68" name="">
             <a:extLst xmlns:a="http://schemas.openxmlformats.org/drawingml/2006/main">
               <a:ext uri="{FF2B5EF4-FFF2-40B4-BE49-F238E27FC236}">
-                <a16:creationId xmlns:a16="http://schemas.microsoft.com/office/drawing/2014/main" id="{1646059C-0D86-461C-A046-269A5D8D1B16}"/>
+                <a16:creationId xmlns:a16="http://schemas.microsoft.com/office/drawing/2014/main" id="{3A425D6E-5C89-4D6B-8627-0A809A2FB53A}"/>
               </a:ext>
             </a:extLst>
           </p:cNvPr>
@@ -11716,7 +11716,7 @@
           <p:cNvPr id="69" name="">
             <a:extLst xmlns:a="http://schemas.openxmlformats.org/drawingml/2006/main">
               <a:ext uri="{FF2B5EF4-FFF2-40B4-BE49-F238E27FC236}">
-                <a16:creationId xmlns:a16="http://schemas.microsoft.com/office/drawing/2014/main" id="{3C957494-1BB0-466A-B48B-E80706498453}"/>
+                <a16:creationId xmlns:a16="http://schemas.microsoft.com/office/drawing/2014/main" id="{43A28D23-69A6-4CA2-9354-A67E5207499D}"/>
               </a:ext>
             </a:extLst>
           </p:cNvPr>
@@ -11773,7 +11773,7 @@
           <p:cNvPr id="70" name="">
             <a:extLst xmlns:a="http://schemas.openxmlformats.org/drawingml/2006/main">
               <a:ext uri="{FF2B5EF4-FFF2-40B4-BE49-F238E27FC236}">
-                <a16:creationId xmlns:a16="http://schemas.microsoft.com/office/drawing/2014/main" id="{3FCD9B71-D1DB-45E7-8D38-19D26FEDF99A}"/>
+                <a16:creationId xmlns:a16="http://schemas.microsoft.com/office/drawing/2014/main" id="{6A74B551-5146-44EE-BFC2-F436386DE26A}"/>
               </a:ext>
             </a:extLst>
           </p:cNvPr>
@@ -11805,7 +11805,7 @@
           <p:cNvPr id="71" name="">
             <a:extLst xmlns:a="http://schemas.openxmlformats.org/drawingml/2006/main">
               <a:ext uri="{FF2B5EF4-FFF2-40B4-BE49-F238E27FC236}">
-                <a16:creationId xmlns:a16="http://schemas.microsoft.com/office/drawing/2014/main" id="{047AF7AC-8BC2-4321-B004-DE81F672B12C}"/>
+                <a16:creationId xmlns:a16="http://schemas.microsoft.com/office/drawing/2014/main" id="{B872D8D6-E108-4E32-99FD-76A824010645}"/>
               </a:ext>
             </a:extLst>
           </p:cNvPr>
@@ -11862,7 +11862,7 @@
           <p:cNvPr id="72" name="">
             <a:extLst xmlns:a="http://schemas.openxmlformats.org/drawingml/2006/main">
               <a:ext uri="{FF2B5EF4-FFF2-40B4-BE49-F238E27FC236}">
-                <a16:creationId xmlns:a16="http://schemas.microsoft.com/office/drawing/2014/main" id="{83C2E8D7-009F-4AF3-A51B-55A33314C553}"/>
+                <a16:creationId xmlns:a16="http://schemas.microsoft.com/office/drawing/2014/main" id="{BA71EEB4-AE7E-4510-9394-C52C64A7C946}"/>
               </a:ext>
             </a:extLst>
           </p:cNvPr>
@@ -11942,7 +11942,7 @@
           <p:cNvPr id="73" name="">
             <a:extLst xmlns:a="http://schemas.openxmlformats.org/drawingml/2006/main">
               <a:ext uri="{FF2B5EF4-FFF2-40B4-BE49-F238E27FC236}">
-                <a16:creationId xmlns:a16="http://schemas.microsoft.com/office/drawing/2014/main" id="{B90E8E51-0978-4101-9187-A70BD25F7583}"/>
+                <a16:creationId xmlns:a16="http://schemas.microsoft.com/office/drawing/2014/main" id="{26A73CF3-5FDB-45F5-B5D3-8C58A1484F58}"/>
               </a:ext>
             </a:extLst>
           </p:cNvPr>
@@ -11972,7 +11972,7 @@
           <p:cNvPr id="74" name="">
             <a:extLst xmlns:a="http://schemas.openxmlformats.org/drawingml/2006/main">
               <a:ext uri="{FF2B5EF4-FFF2-40B4-BE49-F238E27FC236}">
-                <a16:creationId xmlns:a16="http://schemas.microsoft.com/office/drawing/2014/main" id="{84622283-B5BF-4113-85AC-46A8474D9E02}"/>
+                <a16:creationId xmlns:a16="http://schemas.microsoft.com/office/drawing/2014/main" id="{42A7AF45-7871-4794-869E-3A37CD4ABCF3}"/>
               </a:ext>
             </a:extLst>
           </p:cNvPr>
@@ -12029,7 +12029,7 @@
           <p:cNvPr id="75" name="">
             <a:extLst xmlns:a="http://schemas.openxmlformats.org/drawingml/2006/main">
               <a:ext uri="{FF2B5EF4-FFF2-40B4-BE49-F238E27FC236}">
-                <a16:creationId xmlns:a16="http://schemas.microsoft.com/office/drawing/2014/main" id="{4708D8EB-4F27-418C-97D3-3B3BFF90BE37}"/>
+                <a16:creationId xmlns:a16="http://schemas.microsoft.com/office/drawing/2014/main" id="{0E4104B5-44AB-4C39-9A53-A860C4F8ED45}"/>
               </a:ext>
             </a:extLst>
           </p:cNvPr>
@@ -12086,7 +12086,7 @@
           <p:cNvPr id="76" name="">
             <a:extLst xmlns:a="http://schemas.openxmlformats.org/drawingml/2006/main">
               <a:ext uri="{FF2B5EF4-FFF2-40B4-BE49-F238E27FC236}">
-                <a16:creationId xmlns:a16="http://schemas.microsoft.com/office/drawing/2014/main" id="{B8502BBC-5D68-4472-B472-DE14618E49DB}"/>
+                <a16:creationId xmlns:a16="http://schemas.microsoft.com/office/drawing/2014/main" id="{8D0F7AD6-515D-497A-A413-A6A1E8F7C8C8}"/>
               </a:ext>
             </a:extLst>
           </p:cNvPr>
@@ -12116,7 +12116,7 @@
           <p:cNvPr id="77" name="">
             <a:extLst xmlns:a="http://schemas.openxmlformats.org/drawingml/2006/main">
               <a:ext uri="{FF2B5EF4-FFF2-40B4-BE49-F238E27FC236}">
-                <a16:creationId xmlns:a16="http://schemas.microsoft.com/office/drawing/2014/main" id="{96CE0FD0-8757-45DB-B118-722F2910FCBC}"/>
+                <a16:creationId xmlns:a16="http://schemas.microsoft.com/office/drawing/2014/main" id="{003B7232-1382-49EA-8BF0-988A7AAC8D3A}"/>
               </a:ext>
             </a:extLst>
           </p:cNvPr>
@@ -12173,7 +12173,7 @@
           <p:cNvPr id="78" name="">
             <a:extLst xmlns:a="http://schemas.openxmlformats.org/drawingml/2006/main">
               <a:ext uri="{FF2B5EF4-FFF2-40B4-BE49-F238E27FC236}">
-                <a16:creationId xmlns:a16="http://schemas.microsoft.com/office/drawing/2014/main" id="{A2C9DC4E-965C-4BEE-9ECD-70BB8D5A87E5}"/>
+                <a16:creationId xmlns:a16="http://schemas.microsoft.com/office/drawing/2014/main" id="{0165D6BF-8DF0-4F9A-8A0F-643DFA11483C}"/>
               </a:ext>
             </a:extLst>
           </p:cNvPr>
@@ -12230,7 +12230,7 @@
           <p:cNvPr id="79" name="">
             <a:extLst xmlns:a="http://schemas.openxmlformats.org/drawingml/2006/main">
               <a:ext uri="{FF2B5EF4-FFF2-40B4-BE49-F238E27FC236}">
-                <a16:creationId xmlns:a16="http://schemas.microsoft.com/office/drawing/2014/main" id="{BB794CF0-F563-4A58-B1DB-09F550167FE6}"/>
+                <a16:creationId xmlns:a16="http://schemas.microsoft.com/office/drawing/2014/main" id="{C621D2AC-5C47-46B8-84E4-FEC02A69440A}"/>
               </a:ext>
             </a:extLst>
           </p:cNvPr>
@@ -12260,7 +12260,7 @@
           <p:cNvPr id="80" name="">
             <a:extLst xmlns:a="http://schemas.openxmlformats.org/drawingml/2006/main">
               <a:ext uri="{FF2B5EF4-FFF2-40B4-BE49-F238E27FC236}">
-                <a16:creationId xmlns:a16="http://schemas.microsoft.com/office/drawing/2014/main" id="{A205569C-6D00-4B03-AC37-4FB28F56BB89}"/>
+                <a16:creationId xmlns:a16="http://schemas.microsoft.com/office/drawing/2014/main" id="{E437F160-27B6-4D36-87BF-CA098E81AF38}"/>
               </a:ext>
             </a:extLst>
           </p:cNvPr>
@@ -12317,7 +12317,7 @@
           <p:cNvPr id="81" name="">
             <a:extLst xmlns:a="http://schemas.openxmlformats.org/drawingml/2006/main">
               <a:ext uri="{FF2B5EF4-FFF2-40B4-BE49-F238E27FC236}">
-                <a16:creationId xmlns:a16="http://schemas.microsoft.com/office/drawing/2014/main" id="{836A4FD8-5E3C-4B9B-9B9F-B732D2925EE1}"/>
+                <a16:creationId xmlns:a16="http://schemas.microsoft.com/office/drawing/2014/main" id="{6D6B866E-5741-4675-80E6-99DA9E871E56}"/>
               </a:ext>
             </a:extLst>
           </p:cNvPr>
@@ -12374,7 +12374,7 @@
           <p:cNvPr id="82" name="">
             <a:extLst xmlns:a="http://schemas.openxmlformats.org/drawingml/2006/main">
               <a:ext uri="{FF2B5EF4-FFF2-40B4-BE49-F238E27FC236}">
-                <a16:creationId xmlns:a16="http://schemas.microsoft.com/office/drawing/2014/main" id="{76739972-7D9A-4054-A566-4237F7260529}"/>
+                <a16:creationId xmlns:a16="http://schemas.microsoft.com/office/drawing/2014/main" id="{ADC95201-3784-443B-80DD-998AF1A5C20B}"/>
               </a:ext>
             </a:extLst>
           </p:cNvPr>
@@ -12431,7 +12431,7 @@
           <p:cNvPr id="83" name="">
             <a:extLst xmlns:a="http://schemas.openxmlformats.org/drawingml/2006/main">
               <a:ext uri="{FF2B5EF4-FFF2-40B4-BE49-F238E27FC236}">
-                <a16:creationId xmlns:a16="http://schemas.microsoft.com/office/drawing/2014/main" id="{EA67E676-11CA-49D1-86CF-644EBC4B78A1}"/>
+                <a16:creationId xmlns:a16="http://schemas.microsoft.com/office/drawing/2014/main" id="{A1EDF229-08DE-498F-95CE-1B9957466924}"/>
               </a:ext>
             </a:extLst>
           </p:cNvPr>
@@ -12486,7 +12486,7 @@
     </p:spTree>
     <p:extLst>
       <p:ext uri="{BB962C8B-B14F-4D97-AF65-F5344CB8AC3E}">
-        <p14:creationId xmlns:p14="http://schemas.microsoft.com/office/powerpoint/2010/main" val="906117335"/>
+        <p14:creationId xmlns:p14="http://schemas.microsoft.com/office/powerpoint/2010/main" val="1606841464"/>
       </p:ext>
     </p:extLst>
   </p:cSld>
@@ -12514,10 +12514,10 @@
       </p:grpSpPr>
       <p:sp>
         <p:nvSpPr>
-          <p:cNvPr id="29" name="">
-            <a:extLst xmlns:a="http://schemas.openxmlformats.org/drawingml/2006/main">
-              <a:ext uri="{FF2B5EF4-FFF2-40B4-BE49-F238E27FC236}">
-                <a16:creationId xmlns:a16="http://schemas.microsoft.com/office/drawing/2014/main" id="{68E2C0B3-7D9C-4891-BD67-E9F701411A5A}"/>
+          <p:cNvPr id="26" name="">
+            <a:extLst xmlns:a="http://schemas.openxmlformats.org/drawingml/2006/main">
+              <a:ext uri="{FF2B5EF4-FFF2-40B4-BE49-F238E27FC236}">
+                <a16:creationId xmlns:a16="http://schemas.microsoft.com/office/drawing/2014/main" id="{E00A3D4C-8AE7-46F2-8F08-F521F7622560}"/>
               </a:ext>
             </a:extLst>
           </p:cNvPr>
@@ -12547,7 +12547,7 @@
           <p:cNvPr id="2" name="">
             <a:extLst xmlns:a="http://schemas.openxmlformats.org/drawingml/2006/main">
               <a:ext uri="{FF2B5EF4-FFF2-40B4-BE49-F238E27FC236}">
-                <a16:creationId xmlns:a16="http://schemas.microsoft.com/office/drawing/2014/main" id="{5331CBBF-6E3B-4E77-ADD8-F8945398B07F}"/>
+                <a16:creationId xmlns:a16="http://schemas.microsoft.com/office/drawing/2014/main" id="{F5AD24B9-C53D-42C9-A7CC-D4FE0B83B886}"/>
               </a:ext>
             </a:extLst>
           </p:cNvPr>
@@ -12608,7 +12608,7 @@
           <p:cNvPr id="3" name="">
             <a:extLst xmlns:a="http://schemas.openxmlformats.org/drawingml/2006/main">
               <a:ext uri="{FF2B5EF4-FFF2-40B4-BE49-F238E27FC236}">
-                <a16:creationId xmlns:a16="http://schemas.microsoft.com/office/drawing/2014/main" id="{8A783A0A-7717-4121-B531-F5CDB2E768AC}"/>
+                <a16:creationId xmlns:a16="http://schemas.microsoft.com/office/drawing/2014/main" id="{E6A066C2-6E5E-42CA-AACD-B5B3AB4E8123}"/>
               </a:ext>
             </a:extLst>
           </p:cNvPr>
@@ -12665,7 +12665,7 @@
           <p:cNvPr id="4" name="">
             <a:extLst xmlns:a="http://schemas.openxmlformats.org/drawingml/2006/main">
               <a:ext uri="{FF2B5EF4-FFF2-40B4-BE49-F238E27FC236}">
-                <a16:creationId xmlns:a16="http://schemas.microsoft.com/office/drawing/2014/main" id="{8786547C-468B-4296-8B27-FBDF3568BEC7}"/>
+                <a16:creationId xmlns:a16="http://schemas.microsoft.com/office/drawing/2014/main" id="{4F44551C-6CC0-42C2-9092-5728E7D3575A}"/>
               </a:ext>
             </a:extLst>
           </p:cNvPr>
@@ -12722,7 +12722,7 @@
           <p:cNvPr id="5" name="">
             <a:extLst xmlns:a="http://schemas.openxmlformats.org/drawingml/2006/main">
               <a:ext uri="{FF2B5EF4-FFF2-40B4-BE49-F238E27FC236}">
-                <a16:creationId xmlns:a16="http://schemas.microsoft.com/office/drawing/2014/main" id="{F9CFB3C2-C791-4E33-9168-F70039A23607}"/>
+                <a16:creationId xmlns:a16="http://schemas.microsoft.com/office/drawing/2014/main" id="{E1A9A6EA-4E04-4F8D-B718-E68C48D7BAAC}"/>
               </a:ext>
             </a:extLst>
           </p:cNvPr>
@@ -12779,7 +12779,7 @@
           <p:cNvPr id="6" name="">
             <a:extLst xmlns:a="http://schemas.openxmlformats.org/drawingml/2006/main">
               <a:ext uri="{FF2B5EF4-FFF2-40B4-BE49-F238E27FC236}">
-                <a16:creationId xmlns:a16="http://schemas.microsoft.com/office/drawing/2014/main" id="{F58B3D3D-B32F-4061-ADD1-3433D8DDC1CC}"/>
+                <a16:creationId xmlns:a16="http://schemas.microsoft.com/office/drawing/2014/main" id="{55AC035B-96A3-49D8-9FC5-6D532C31DEFF}"/>
               </a:ext>
             </a:extLst>
           </p:cNvPr>
@@ -12836,7 +12836,7 @@
           <p:cNvPr id="7" name="">
             <a:extLst xmlns:a="http://schemas.openxmlformats.org/drawingml/2006/main">
               <a:ext uri="{FF2B5EF4-FFF2-40B4-BE49-F238E27FC236}">
-                <a16:creationId xmlns:a16="http://schemas.microsoft.com/office/drawing/2014/main" id="{F0E36658-2637-4D01-9D6E-363552508C9B}"/>
+                <a16:creationId xmlns:a16="http://schemas.microsoft.com/office/drawing/2014/main" id="{91FBB300-C590-412A-9E73-150793281F25}"/>
               </a:ext>
             </a:extLst>
           </p:cNvPr>
@@ -12893,7 +12893,7 @@
           <p:cNvPr id="8" name="">
             <a:extLst xmlns:a="http://schemas.openxmlformats.org/drawingml/2006/main">
               <a:ext uri="{FF2B5EF4-FFF2-40B4-BE49-F238E27FC236}">
-                <a16:creationId xmlns:a16="http://schemas.microsoft.com/office/drawing/2014/main" id="{13D470A6-EDE2-4AEB-91D3-D900156B7B9A}"/>
+                <a16:creationId xmlns:a16="http://schemas.microsoft.com/office/drawing/2014/main" id="{D7E5C95A-E48E-4785-A279-C5BCE2110D07}"/>
               </a:ext>
             </a:extLst>
           </p:cNvPr>
@@ -12950,7 +12950,7 @@
           <p:cNvPr id="9" name="">
             <a:extLst xmlns:a="http://schemas.openxmlformats.org/drawingml/2006/main">
               <a:ext uri="{FF2B5EF4-FFF2-40B4-BE49-F238E27FC236}">
-                <a16:creationId xmlns:a16="http://schemas.microsoft.com/office/drawing/2014/main" id="{343998C9-1D24-489C-B486-88232C2782A0}"/>
+                <a16:creationId xmlns:a16="http://schemas.microsoft.com/office/drawing/2014/main" id="{1804A052-344D-4494-B2A9-7ED97753C255}"/>
               </a:ext>
             </a:extLst>
           </p:cNvPr>
@@ -13002,339 +13002,96 @@
           </a:p>
         </p:txBody>
       </p:sp>
-      <p:sp>
-        <p:nvSpPr>
-          <p:cNvPr id="10" name="">
-            <a:extLst xmlns:a="http://schemas.openxmlformats.org/drawingml/2006/main">
-              <a:ext uri="{FF2B5EF4-FFF2-40B4-BE49-F238E27FC236}">
-                <a16:creationId xmlns:a16="http://schemas.microsoft.com/office/drawing/2014/main" id="{18FC8F7A-580F-45AB-B9FF-5B0F71C1C55F}"/>
-              </a:ext>
-            </a:extLst>
-          </p:cNvPr>
-          <p:cNvSpPr>
-            <a:spLocks xmlns:a="http://schemas.openxmlformats.org/drawingml/2006/main" noGrp="1"/>
-          </p:cNvSpPr>
-          <p:nvPr/>
-        </p:nvSpPr>
-        <p:spPr>
-          <a:xfrm xmlns:a="http://schemas.openxmlformats.org/drawingml/2006/main">
-            <a:off x="857250" y="3048000"/>
-            <a:ext cx="2667000" cy="3190875"/>
+      <p:pic>
+        <p:nvPicPr>
+          <p:cNvPr id="35" name=""/>
+          <p:cNvPicPr>
+            <a:picLocks xmlns:a="http://schemas.openxmlformats.org/drawingml/2006/main" noChangeAspect="1"/>
+          </p:cNvPicPr>
+          <p:nvPr/>
+        </p:nvPicPr>
+        <p:blipFill>
+          <a:blip xmlns:r="http://schemas.openxmlformats.org/officeDocument/2006/relationships" xmlns:a="http://schemas.openxmlformats.org/drawingml/2006/main" r:embed="Raaf6c20bd4264252"/>
+          <a:srcRect xmlns:a="http://schemas.openxmlformats.org/drawingml/2006/main" l="0" t="14581" r="0" b="14581"/>
+          <a:stretch xmlns:a="http://schemas.openxmlformats.org/drawingml/2006/main">
+            <a:fillRect l="0" t="0" r="0" b="0"/>
+          </a:stretch>
+        </p:blipFill>
+        <p:spPr>
+          <a:xfrm xmlns:a="http://schemas.openxmlformats.org/drawingml/2006/main">
+            <a:off x="904875" y="2857500"/>
+            <a:ext cx="2571750" cy="3857625"/>
           </a:xfrm>
           <a:prstGeom xmlns:a="http://schemas.openxmlformats.org/drawingml/2006/main" prst="roundRect">
             <a:avLst>
-              <a:gd name="adj" fmla="val 12857"/>
+              <a:gd name="adj" fmla="val 4444"/>
             </a:avLst>
           </a:prstGeom>
-          <a:solidFill xmlns:a="http://schemas.openxmlformats.org/drawingml/2006/main">
-            <a:srgbClr val="123F49"/>
-          </a:solidFill>
-          <a:ln xmlns:a="http://schemas.openxmlformats.org/drawingml/2006/main" w="0">
-            <a:noFill/>
-          </a:ln>
-        </p:spPr>
-      </p:sp>
+        </p:spPr>
+      </p:pic>
       <p:sp>
         <p:nvSpPr>
           <p:cNvPr id="11" name="">
             <a:extLst xmlns:a="http://schemas.openxmlformats.org/drawingml/2006/main">
               <a:ext uri="{FF2B5EF4-FFF2-40B4-BE49-F238E27FC236}">
-                <a16:creationId xmlns:a16="http://schemas.microsoft.com/office/drawing/2014/main" id="{E187EE35-45B3-4CCD-A3B6-4FF1B748C8DE}"/>
-              </a:ext>
-            </a:extLst>
-          </p:cNvPr>
-          <p:cNvSpPr>
-            <a:spLocks xmlns:a="http://schemas.openxmlformats.org/drawingml/2006/main" noGrp="1"/>
-          </p:cNvSpPr>
-          <p:nvPr/>
-        </p:nvSpPr>
-        <p:spPr>
-          <a:xfrm xmlns:a="http://schemas.openxmlformats.org/drawingml/2006/main">
-            <a:off x="1009650" y="3238500"/>
-            <a:ext cx="2362200" cy="2714625"/>
-          </a:xfrm>
-          <a:prstGeom xmlns:a="http://schemas.openxmlformats.org/drawingml/2006/main" prst="roundRect">
-            <a:avLst>
-              <a:gd name="adj" fmla="val 9677"/>
-            </a:avLst>
-          </a:prstGeom>
-          <a:solidFill xmlns:a="http://schemas.openxmlformats.org/drawingml/2006/main">
-            <a:srgbClr val="FFFFFF"/>
-          </a:solidFill>
-          <a:ln xmlns:a="http://schemas.openxmlformats.org/drawingml/2006/main" w="0">
-            <a:noFill/>
-          </a:ln>
-        </p:spPr>
+                <a16:creationId xmlns:a16="http://schemas.microsoft.com/office/drawing/2014/main" id="{A8944AEB-4C26-4339-8F7F-AE3AC1C90939}"/>
+              </a:ext>
+            </a:extLst>
+          </p:cNvPr>
+          <p:cNvSpPr>
+            <a:spLocks xmlns:a="http://schemas.openxmlformats.org/drawingml/2006/main" noGrp="1"/>
+          </p:cNvSpPr>
+          <p:nvPr/>
+        </p:nvSpPr>
+        <p:spPr>
+          <a:xfrm xmlns:a="http://schemas.openxmlformats.org/drawingml/2006/main">
+            <a:off x="762000" y="6819900"/>
+            <a:ext cx="2857500" cy="209550"/>
+          </a:xfrm>
+          <a:prstGeom xmlns:a="http://schemas.openxmlformats.org/drawingml/2006/main" prst="rect">
+            <a:avLst/>
+          </a:prstGeom>
+          <a:noFill xmlns:a="http://schemas.openxmlformats.org/drawingml/2006/main"/>
+          <a:ln xmlns:a="http://schemas.openxmlformats.org/drawingml/2006/main" w="0">
+            <a:noFill/>
+          </a:ln>
+        </p:spPr>
+        <p:txBody>
+          <a:bodyPr xmlns:a="http://schemas.openxmlformats.org/drawingml/2006/main" anchor="t">
+            <a:normAutofit fontScale="86111"/>
+          </a:bodyPr>
+          <a:lstStyle xmlns:a="http://schemas.openxmlformats.org/drawingml/2006/main"/>
+          <a:p xmlns:a="http://schemas.openxmlformats.org/drawingml/2006/main">
+            <a:pPr algn="ctr">
+              <a:defRPr sz="900" b="0" i="0">
+                <a:solidFill>
+                  <a:srgbClr val="536870"/>
+                </a:solidFill>
+                <a:latin typeface="Avenir Next"/>
+                <a:ea typeface="Avenir Next"/>
+                <a:cs typeface="Avenir Next"/>
+              </a:defRPr>
+            </a:pPr>
+            <a:r>
+              <a:rPr sz="900" b="0" i="0">
+                <a:solidFill>
+                  <a:srgbClr val="536870"/>
+                </a:solidFill>
+                <a:latin typeface="Avenir Next"/>
+                <a:ea typeface="Avenir Next"/>
+                <a:cs typeface="Avenir Next"/>
+              </a:rPr>
+              <a:t>Current iOS simulator view</a:t>
+            </a:r>
+          </a:p>
+        </p:txBody>
       </p:sp>
       <p:sp>
         <p:nvSpPr>
           <p:cNvPr id="12" name="">
             <a:extLst xmlns:a="http://schemas.openxmlformats.org/drawingml/2006/main">
               <a:ext uri="{FF2B5EF4-FFF2-40B4-BE49-F238E27FC236}">
-                <a16:creationId xmlns:a16="http://schemas.microsoft.com/office/drawing/2014/main" id="{00562840-1C0C-4EFA-9C17-8ACF204207E4}"/>
-              </a:ext>
-            </a:extLst>
-          </p:cNvPr>
-          <p:cNvSpPr>
-            <a:spLocks xmlns:a="http://schemas.openxmlformats.org/drawingml/2006/main" noGrp="1"/>
-          </p:cNvSpPr>
-          <p:nvPr/>
-        </p:nvSpPr>
-        <p:spPr>
-          <a:xfrm xmlns:a="http://schemas.openxmlformats.org/drawingml/2006/main">
-            <a:off x="1257300" y="3476625"/>
-            <a:ext cx="1857375" cy="333375"/>
-          </a:xfrm>
-          <a:prstGeom xmlns:a="http://schemas.openxmlformats.org/drawingml/2006/main" prst="rect">
-            <a:avLst/>
-          </a:prstGeom>
-          <a:noFill xmlns:a="http://schemas.openxmlformats.org/drawingml/2006/main"/>
-          <a:ln xmlns:a="http://schemas.openxmlformats.org/drawingml/2006/main" w="0">
-            <a:noFill/>
-          </a:ln>
-        </p:spPr>
-        <p:txBody>
-          <a:bodyPr xmlns:a="http://schemas.openxmlformats.org/drawingml/2006/main" anchor="t">
-            <a:normAutofit fontScale="96212"/>
-          </a:bodyPr>
-          <a:lstStyle xmlns:a="http://schemas.openxmlformats.org/drawingml/2006/main"/>
-          <a:p xmlns:a="http://schemas.openxmlformats.org/drawingml/2006/main">
-            <a:pPr algn="ctr">
-              <a:defRPr sz="1650" b="1" i="0">
-                <a:solidFill>
-                  <a:srgbClr val="087F8C"/>
-                </a:solidFill>
-                <a:latin typeface="Avenir Next"/>
-                <a:ea typeface="Avenir Next"/>
-                <a:cs typeface="Avenir Next"/>
-              </a:defRPr>
-            </a:pPr>
-            <a:r>
-              <a:rPr sz="1650" b="1" i="0">
-                <a:solidFill>
-                  <a:srgbClr val="087F8C"/>
-                </a:solidFill>
-                <a:latin typeface="Avenir Next"/>
-                <a:ea typeface="Avenir Next"/>
-                <a:cs typeface="Avenir Next"/>
-              </a:rPr>
-              <a:t>+ Carestead</a:t>
-            </a:r>
-          </a:p>
-        </p:txBody>
-      </p:sp>
-      <p:sp>
-        <p:nvSpPr>
-          <p:cNvPr id="13" name="">
-            <a:extLst xmlns:a="http://schemas.openxmlformats.org/drawingml/2006/main">
-              <a:ext uri="{FF2B5EF4-FFF2-40B4-BE49-F238E27FC236}">
-                <a16:creationId xmlns:a16="http://schemas.microsoft.com/office/drawing/2014/main" id="{C9E19F4A-DDB0-4206-BB21-18CC6BF5E071}"/>
-              </a:ext>
-            </a:extLst>
-          </p:cNvPr>
-          <p:cNvSpPr>
-            <a:spLocks xmlns:a="http://schemas.openxmlformats.org/drawingml/2006/main" noGrp="1"/>
-          </p:cNvSpPr>
-          <p:nvPr/>
-        </p:nvSpPr>
-        <p:spPr>
-          <a:xfrm xmlns:a="http://schemas.openxmlformats.org/drawingml/2006/main">
-            <a:off x="1257300" y="4048125"/>
-            <a:ext cx="1857375" cy="1428750"/>
-          </a:xfrm>
-          <a:prstGeom xmlns:a="http://schemas.openxmlformats.org/drawingml/2006/main" prst="rect">
-            <a:avLst/>
-          </a:prstGeom>
-          <a:noFill xmlns:a="http://schemas.openxmlformats.org/drawingml/2006/main"/>
-          <a:ln xmlns:a="http://schemas.openxmlformats.org/drawingml/2006/main" w="0">
-            <a:noFill/>
-          </a:ln>
-        </p:spPr>
-        <p:txBody>
-          <a:bodyPr xmlns:a="http://schemas.openxmlformats.org/drawingml/2006/main" anchor="ctr">
-            <a:normAutofit fontScale="100000"/>
-          </a:bodyPr>
-          <a:lstStyle xmlns:a="http://schemas.openxmlformats.org/drawingml/2006/main"/>
-          <a:p xmlns:a="http://schemas.openxmlformats.org/drawingml/2006/main">
-            <a:pPr algn="ctr">
-              <a:defRPr sz="1650" b="1" i="0">
-                <a:solidFill>
-                  <a:srgbClr val="123F49"/>
-                </a:solidFill>
-                <a:latin typeface="Avenir Next"/>
-                <a:ea typeface="Avenir Next"/>
-                <a:cs typeface="Avenir Next"/>
-              </a:defRPr>
-            </a:pPr>
-            <a:r>
-              <a:rPr sz="1650" b="1" i="0">
-                <a:solidFill>
-                  <a:srgbClr val="123F49"/>
-                </a:solidFill>
-                <a:latin typeface="Avenir Next"/>
-                <a:ea typeface="Avenir Next"/>
-                <a:cs typeface="Avenir Next"/>
-              </a:rPr>
-              <a:t>Plan</a:t>
-            </a:r>
-          </a:p>
-          <a:p xmlns:a="http://schemas.openxmlformats.org/drawingml/2006/main">
-            <a:pPr algn="ctr">
-              <a:defRPr sz="1650" b="1" i="0">
-                <a:solidFill>
-                  <a:srgbClr val="123F49"/>
-                </a:solidFill>
-                <a:latin typeface="Avenir Next"/>
-                <a:ea typeface="Avenir Next"/>
-                <a:cs typeface="Avenir Next"/>
-              </a:defRPr>
-            </a:pPr>
-            <a:r>
-              <a:rPr sz="1650" b="1" i="0">
-                <a:solidFill>
-                  <a:srgbClr val="123F49"/>
-                </a:solidFill>
-                <a:latin typeface="Avenir Next"/>
-                <a:ea typeface="Avenir Next"/>
-                <a:cs typeface="Avenir Next"/>
-              </a:rPr>
-              <a:t>Chat + voice</a:t>
-            </a:r>
-          </a:p>
-          <a:p xmlns:a="http://schemas.openxmlformats.org/drawingml/2006/main">
-            <a:pPr algn="ctr">
-              <a:defRPr sz="1650" b="1" i="0">
-                <a:solidFill>
-                  <a:srgbClr val="123F49"/>
-                </a:solidFill>
-                <a:latin typeface="Avenir Next"/>
-                <a:ea typeface="Avenir Next"/>
-                <a:cs typeface="Avenir Next"/>
-              </a:defRPr>
-            </a:pPr>
-            <a:r>
-              <a:rPr sz="1650" b="1" i="0">
-                <a:solidFill>
-                  <a:srgbClr val="123F49"/>
-                </a:solidFill>
-                <a:latin typeface="Avenir Next"/>
-                <a:ea typeface="Avenir Next"/>
-                <a:cs typeface="Avenir Next"/>
-              </a:rPr>
-              <a:t>Calendar</a:t>
-            </a:r>
-          </a:p>
-          <a:p xmlns:a="http://schemas.openxmlformats.org/drawingml/2006/main">
-            <a:pPr algn="ctr">
-              <a:defRPr sz="1650" b="1" i="0">
-                <a:solidFill>
-                  <a:srgbClr val="123F49"/>
-                </a:solidFill>
-                <a:latin typeface="Avenir Next"/>
-                <a:ea typeface="Avenir Next"/>
-                <a:cs typeface="Avenir Next"/>
-              </a:defRPr>
-            </a:pPr>
-            <a:r>
-              <a:rPr sz="1650" b="1" i="0">
-                <a:solidFill>
-                  <a:srgbClr val="123F49"/>
-                </a:solidFill>
-                <a:latin typeface="Avenir Next"/>
-                <a:ea typeface="Avenir Next"/>
-                <a:cs typeface="Avenir Next"/>
-              </a:rPr>
-              <a:t>Handover</a:t>
-            </a:r>
-          </a:p>
-          <a:p xmlns:a="http://schemas.openxmlformats.org/drawingml/2006/main">
-            <a:pPr algn="ctr">
-              <a:defRPr sz="1650" b="1" i="0">
-                <a:solidFill>
-                  <a:srgbClr val="123F49"/>
-                </a:solidFill>
-                <a:latin typeface="Avenir Next"/>
-                <a:ea typeface="Avenir Next"/>
-                <a:cs typeface="Avenir Next"/>
-              </a:defRPr>
-            </a:pPr>
-            <a:r>
-              <a:rPr sz="1650" b="1" i="0">
-                <a:solidFill>
-                  <a:srgbClr val="123F49"/>
-                </a:solidFill>
-                <a:latin typeface="Avenir Next"/>
-                <a:ea typeface="Avenir Next"/>
-                <a:cs typeface="Avenir Next"/>
-              </a:rPr>
-              <a:t>Approvals</a:t>
-            </a:r>
-          </a:p>
-        </p:txBody>
-      </p:sp>
-      <p:sp>
-        <p:nvSpPr>
-          <p:cNvPr id="14" name="">
-            <a:extLst xmlns:a="http://schemas.openxmlformats.org/drawingml/2006/main">
-              <a:ext uri="{FF2B5EF4-FFF2-40B4-BE49-F238E27FC236}">
-                <a16:creationId xmlns:a16="http://schemas.microsoft.com/office/drawing/2014/main" id="{3465AC94-E1B2-4233-BC72-DDBC48DD7793}"/>
-              </a:ext>
-            </a:extLst>
-          </p:cNvPr>
-          <p:cNvSpPr>
-            <a:spLocks xmlns:a="http://schemas.openxmlformats.org/drawingml/2006/main" noGrp="1"/>
-          </p:cNvSpPr>
-          <p:nvPr/>
-        </p:nvSpPr>
-        <p:spPr>
-          <a:xfrm xmlns:a="http://schemas.openxmlformats.org/drawingml/2006/main">
-            <a:off x="1285875" y="5543550"/>
-            <a:ext cx="1809750" cy="228600"/>
-          </a:xfrm>
-          <a:prstGeom xmlns:a="http://schemas.openxmlformats.org/drawingml/2006/main" prst="rect">
-            <a:avLst/>
-          </a:prstGeom>
-          <a:noFill xmlns:a="http://schemas.openxmlformats.org/drawingml/2006/main"/>
-          <a:ln xmlns:a="http://schemas.openxmlformats.org/drawingml/2006/main" w="0">
-            <a:noFill/>
-          </a:ln>
-        </p:spPr>
-        <p:txBody>
-          <a:bodyPr xmlns:a="http://schemas.openxmlformats.org/drawingml/2006/main" anchor="t">
-            <a:normAutofit fontScale="85714"/>
-          </a:bodyPr>
-          <a:lstStyle xmlns:a="http://schemas.openxmlformats.org/drawingml/2006/main"/>
-          <a:p xmlns:a="http://schemas.openxmlformats.org/drawingml/2006/main">
-            <a:pPr algn="ctr">
-              <a:defRPr sz="1050" b="0" i="0">
-                <a:solidFill>
-                  <a:srgbClr val="536870"/>
-                </a:solidFill>
-                <a:latin typeface="Avenir Next"/>
-                <a:ea typeface="Avenir Next"/>
-                <a:cs typeface="Avenir Next"/>
-              </a:defRPr>
-            </a:pPr>
-            <a:r>
-              <a:rPr sz="1050" b="0" i="0">
-                <a:solidFill>
-                  <a:srgbClr val="536870"/>
-                </a:solidFill>
-                <a:latin typeface="Avenir Next"/>
-                <a:ea typeface="Avenir Next"/>
-                <a:cs typeface="Avenir Next"/>
-              </a:rPr>
-              <a:t>iOS pilot</a:t>
-            </a:r>
-          </a:p>
-        </p:txBody>
-      </p:sp>
-      <p:sp>
-        <p:nvSpPr>
-          <p:cNvPr id="15" name="">
-            <a:extLst xmlns:a="http://schemas.openxmlformats.org/drawingml/2006/main">
-              <a:ext uri="{FF2B5EF4-FFF2-40B4-BE49-F238E27FC236}">
-                <a16:creationId xmlns:a16="http://schemas.microsoft.com/office/drawing/2014/main" id="{006BE5A9-1431-4E87-AA69-2B5E7272CE5C}"/>
+                <a16:creationId xmlns:a16="http://schemas.microsoft.com/office/drawing/2014/main" id="{4B222D47-D911-47B9-8519-672FAC42A3C5}"/>
               </a:ext>
             </a:extLst>
           </p:cNvPr>
@@ -13388,10 +13145,10 @@
       </p:sp>
       <p:sp>
         <p:nvSpPr>
-          <p:cNvPr id="16" name="">
-            <a:extLst xmlns:a="http://schemas.openxmlformats.org/drawingml/2006/main">
-              <a:ext uri="{FF2B5EF4-FFF2-40B4-BE49-F238E27FC236}">
-                <a16:creationId xmlns:a16="http://schemas.microsoft.com/office/drawing/2014/main" id="{F2101B8E-EE68-4BDE-A1F8-8B99FBF9CEAC}"/>
+          <p:cNvPr id="13" name="">
+            <a:extLst xmlns:a="http://schemas.openxmlformats.org/drawingml/2006/main">
+              <a:ext uri="{FF2B5EF4-FFF2-40B4-BE49-F238E27FC236}">
+                <a16:creationId xmlns:a16="http://schemas.microsoft.com/office/drawing/2014/main" id="{82F45FB4-1547-4623-A516-64754300D807}"/>
               </a:ext>
             </a:extLst>
           </p:cNvPr>
@@ -13422,10 +13179,10 @@
       </p:sp>
       <p:sp>
         <p:nvSpPr>
-          <p:cNvPr id="17" name="">
-            <a:extLst xmlns:a="http://schemas.openxmlformats.org/drawingml/2006/main">
-              <a:ext uri="{FF2B5EF4-FFF2-40B4-BE49-F238E27FC236}">
-                <a16:creationId xmlns:a16="http://schemas.microsoft.com/office/drawing/2014/main" id="{C61742A9-CF89-4B87-88EB-AFE3FB55C066}"/>
+          <p:cNvPr id="14" name="">
+            <a:extLst xmlns:a="http://schemas.openxmlformats.org/drawingml/2006/main">
+              <a:ext uri="{FF2B5EF4-FFF2-40B4-BE49-F238E27FC236}">
+                <a16:creationId xmlns:a16="http://schemas.microsoft.com/office/drawing/2014/main" id="{D7D6019E-DC48-4C55-9F8F-1FCCDDA5B5CA}"/>
               </a:ext>
             </a:extLst>
           </p:cNvPr>
@@ -13479,10 +13236,10 @@
       </p:sp>
       <p:sp>
         <p:nvSpPr>
-          <p:cNvPr id="18" name="">
-            <a:extLst xmlns:a="http://schemas.openxmlformats.org/drawingml/2006/main">
-              <a:ext uri="{FF2B5EF4-FFF2-40B4-BE49-F238E27FC236}">
-                <a16:creationId xmlns:a16="http://schemas.microsoft.com/office/drawing/2014/main" id="{66C457BC-D6B4-4AAF-B0E2-6829E38050E1}"/>
+          <p:cNvPr id="15" name="">
+            <a:extLst xmlns:a="http://schemas.openxmlformats.org/drawingml/2006/main">
+              <a:ext uri="{FF2B5EF4-FFF2-40B4-BE49-F238E27FC236}">
+                <a16:creationId xmlns:a16="http://schemas.microsoft.com/office/drawing/2014/main" id="{4DA626EE-6DB4-4E79-89E9-B3CD494D2D7D}"/>
               </a:ext>
             </a:extLst>
           </p:cNvPr>
@@ -13536,10 +13293,10 @@
       </p:sp>
       <p:sp>
         <p:nvSpPr>
-          <p:cNvPr id="19" name="">
-            <a:extLst xmlns:a="http://schemas.openxmlformats.org/drawingml/2006/main">
-              <a:ext uri="{FF2B5EF4-FFF2-40B4-BE49-F238E27FC236}">
-                <a16:creationId xmlns:a16="http://schemas.microsoft.com/office/drawing/2014/main" id="{C22E09AE-E31D-46EF-B0CD-B29E3B40251F}"/>
+          <p:cNvPr id="16" name="">
+            <a:extLst xmlns:a="http://schemas.openxmlformats.org/drawingml/2006/main">
+              <a:ext uri="{FF2B5EF4-FFF2-40B4-BE49-F238E27FC236}">
+                <a16:creationId xmlns:a16="http://schemas.microsoft.com/office/drawing/2014/main" id="{F50374EA-C60C-46ED-B3DF-922671E85DCF}"/>
               </a:ext>
             </a:extLst>
           </p:cNvPr>
@@ -13570,10 +13327,10 @@
       </p:sp>
       <p:sp>
         <p:nvSpPr>
-          <p:cNvPr id="20" name="">
-            <a:extLst xmlns:a="http://schemas.openxmlformats.org/drawingml/2006/main">
-              <a:ext uri="{FF2B5EF4-FFF2-40B4-BE49-F238E27FC236}">
-                <a16:creationId xmlns:a16="http://schemas.microsoft.com/office/drawing/2014/main" id="{F956C265-F3F4-4B52-B6A3-E5F53D391D45}"/>
+          <p:cNvPr id="17" name="">
+            <a:extLst xmlns:a="http://schemas.openxmlformats.org/drawingml/2006/main">
+              <a:ext uri="{FF2B5EF4-FFF2-40B4-BE49-F238E27FC236}">
+                <a16:creationId xmlns:a16="http://schemas.microsoft.com/office/drawing/2014/main" id="{5E096470-CFF9-4240-B23D-A2E8D39FF298}"/>
               </a:ext>
             </a:extLst>
           </p:cNvPr>
@@ -13627,10 +13384,10 @@
       </p:sp>
       <p:sp>
         <p:nvSpPr>
-          <p:cNvPr id="21" name="">
-            <a:extLst xmlns:a="http://schemas.openxmlformats.org/drawingml/2006/main">
-              <a:ext uri="{FF2B5EF4-FFF2-40B4-BE49-F238E27FC236}">
-                <a16:creationId xmlns:a16="http://schemas.microsoft.com/office/drawing/2014/main" id="{AE231139-5650-4137-92B9-5670F1B61856}"/>
+          <p:cNvPr id="18" name="">
+            <a:extLst xmlns:a="http://schemas.openxmlformats.org/drawingml/2006/main">
+              <a:ext uri="{FF2B5EF4-FFF2-40B4-BE49-F238E27FC236}">
+                <a16:creationId xmlns:a16="http://schemas.microsoft.com/office/drawing/2014/main" id="{AABD7509-BCA8-4727-895A-FAF4C6788BAD}"/>
               </a:ext>
             </a:extLst>
           </p:cNvPr>
@@ -13684,10 +13441,10 @@
       </p:sp>
       <p:sp>
         <p:nvSpPr>
-          <p:cNvPr id="22" name="">
-            <a:extLst xmlns:a="http://schemas.openxmlformats.org/drawingml/2006/main">
-              <a:ext uri="{FF2B5EF4-FFF2-40B4-BE49-F238E27FC236}">
-                <a16:creationId xmlns:a16="http://schemas.microsoft.com/office/drawing/2014/main" id="{C0297BE6-34E2-4731-8874-A32184599E0A}"/>
+          <p:cNvPr id="19" name="">
+            <a:extLst xmlns:a="http://schemas.openxmlformats.org/drawingml/2006/main">
+              <a:ext uri="{FF2B5EF4-FFF2-40B4-BE49-F238E27FC236}">
+                <a16:creationId xmlns:a16="http://schemas.microsoft.com/office/drawing/2014/main" id="{60B436BB-2522-4FCF-8462-FA40D6586B0A}"/>
               </a:ext>
             </a:extLst>
           </p:cNvPr>
@@ -13718,10 +13475,10 @@
       </p:sp>
       <p:sp>
         <p:nvSpPr>
-          <p:cNvPr id="23" name="">
-            <a:extLst xmlns:a="http://schemas.openxmlformats.org/drawingml/2006/main">
-              <a:ext uri="{FF2B5EF4-FFF2-40B4-BE49-F238E27FC236}">
-                <a16:creationId xmlns:a16="http://schemas.microsoft.com/office/drawing/2014/main" id="{0A7CE2F2-CCB4-4A1D-A5FA-4836FAED8587}"/>
+          <p:cNvPr id="20" name="">
+            <a:extLst xmlns:a="http://schemas.openxmlformats.org/drawingml/2006/main">
+              <a:ext uri="{FF2B5EF4-FFF2-40B4-BE49-F238E27FC236}">
+                <a16:creationId xmlns:a16="http://schemas.microsoft.com/office/drawing/2014/main" id="{7E875639-9B76-456C-8FE3-9DFDF51BBCF7}"/>
               </a:ext>
             </a:extLst>
           </p:cNvPr>
@@ -13775,10 +13532,10 @@
       </p:sp>
       <p:sp>
         <p:nvSpPr>
-          <p:cNvPr id="24" name="">
-            <a:extLst xmlns:a="http://schemas.openxmlformats.org/drawingml/2006/main">
-              <a:ext uri="{FF2B5EF4-FFF2-40B4-BE49-F238E27FC236}">
-                <a16:creationId xmlns:a16="http://schemas.microsoft.com/office/drawing/2014/main" id="{E9B591C5-AACD-4B73-8D19-36A637AB103A}"/>
+          <p:cNvPr id="21" name="">
+            <a:extLst xmlns:a="http://schemas.openxmlformats.org/drawingml/2006/main">
+              <a:ext uri="{FF2B5EF4-FFF2-40B4-BE49-F238E27FC236}">
+                <a16:creationId xmlns:a16="http://schemas.microsoft.com/office/drawing/2014/main" id="{B7E9AED5-0CF4-45C8-9230-05784A1EE698}"/>
               </a:ext>
             </a:extLst>
           </p:cNvPr>
@@ -13832,10 +13589,10 @@
       </p:sp>
       <p:sp>
         <p:nvSpPr>
-          <p:cNvPr id="25" name="">
-            <a:extLst xmlns:a="http://schemas.openxmlformats.org/drawingml/2006/main">
-              <a:ext uri="{FF2B5EF4-FFF2-40B4-BE49-F238E27FC236}">
-                <a16:creationId xmlns:a16="http://schemas.microsoft.com/office/drawing/2014/main" id="{3D08E0B6-15F2-46B5-9A20-6D5E89A5ACCF}"/>
+          <p:cNvPr id="22" name="">
+            <a:extLst xmlns:a="http://schemas.openxmlformats.org/drawingml/2006/main">
+              <a:ext uri="{FF2B5EF4-FFF2-40B4-BE49-F238E27FC236}">
+                <a16:creationId xmlns:a16="http://schemas.microsoft.com/office/drawing/2014/main" id="{AAE15382-D6AC-4CC6-A08D-830F2DA881C4}"/>
               </a:ext>
             </a:extLst>
           </p:cNvPr>
@@ -13866,10 +13623,10 @@
       </p:sp>
       <p:sp>
         <p:nvSpPr>
-          <p:cNvPr id="26" name="">
-            <a:extLst xmlns:a="http://schemas.openxmlformats.org/drawingml/2006/main">
-              <a:ext uri="{FF2B5EF4-FFF2-40B4-BE49-F238E27FC236}">
-                <a16:creationId xmlns:a16="http://schemas.microsoft.com/office/drawing/2014/main" id="{747FD94F-6B66-4ABE-810F-275D61763D70}"/>
+          <p:cNvPr id="23" name="">
+            <a:extLst xmlns:a="http://schemas.openxmlformats.org/drawingml/2006/main">
+              <a:ext uri="{FF2B5EF4-FFF2-40B4-BE49-F238E27FC236}">
+                <a16:creationId xmlns:a16="http://schemas.microsoft.com/office/drawing/2014/main" id="{5CE22784-349E-4E99-B792-0C874C421B20}"/>
               </a:ext>
             </a:extLst>
           </p:cNvPr>
@@ -13923,10 +13680,10 @@
       </p:sp>
       <p:sp>
         <p:nvSpPr>
-          <p:cNvPr id="27" name="">
-            <a:extLst xmlns:a="http://schemas.openxmlformats.org/drawingml/2006/main">
-              <a:ext uri="{FF2B5EF4-FFF2-40B4-BE49-F238E27FC236}">
-                <a16:creationId xmlns:a16="http://schemas.microsoft.com/office/drawing/2014/main" id="{AB58D36B-2D3F-49F5-82E0-1796ECDF46B4}"/>
+          <p:cNvPr id="24" name="">
+            <a:extLst xmlns:a="http://schemas.openxmlformats.org/drawingml/2006/main">
+              <a:ext uri="{FF2B5EF4-FFF2-40B4-BE49-F238E27FC236}">
+                <a16:creationId xmlns:a16="http://schemas.microsoft.com/office/drawing/2014/main" id="{BF727058-005A-4DCF-89AC-309E1B5F15EC}"/>
               </a:ext>
             </a:extLst>
           </p:cNvPr>
@@ -13980,10 +13737,10 @@
       </p:sp>
       <p:sp>
         <p:nvSpPr>
-          <p:cNvPr id="28" name="">
-            <a:extLst xmlns:a="http://schemas.openxmlformats.org/drawingml/2006/main">
-              <a:ext uri="{FF2B5EF4-FFF2-40B4-BE49-F238E27FC236}">
-                <a16:creationId xmlns:a16="http://schemas.microsoft.com/office/drawing/2014/main" id="{353B2AB6-CA83-421D-AB57-883415D1E744}"/>
+          <p:cNvPr id="25" name="">
+            <a:extLst xmlns:a="http://schemas.openxmlformats.org/drawingml/2006/main">
+              <a:ext uri="{FF2B5EF4-FFF2-40B4-BE49-F238E27FC236}">
+                <a16:creationId xmlns:a16="http://schemas.microsoft.com/office/drawing/2014/main" id="{5D04EE71-1680-47CB-9F29-E53F56095CEB}"/>
               </a:ext>
             </a:extLst>
           </p:cNvPr>
@@ -14038,7 +13795,7 @@
     </p:spTree>
     <p:extLst>
       <p:ext uri="{BB962C8B-B14F-4D97-AF65-F5344CB8AC3E}">
-        <p14:creationId xmlns:p14="http://schemas.microsoft.com/office/powerpoint/2010/main" val="736910543"/>
+        <p14:creationId xmlns:p14="http://schemas.microsoft.com/office/powerpoint/2010/main" val="690258062"/>
       </p:ext>
     </p:extLst>
   </p:cSld>
@@ -14069,7 +13826,7 @@
           <p:cNvPr id="20" name="">
             <a:extLst xmlns:a="http://schemas.openxmlformats.org/drawingml/2006/main">
               <a:ext uri="{FF2B5EF4-FFF2-40B4-BE49-F238E27FC236}">
-                <a16:creationId xmlns:a16="http://schemas.microsoft.com/office/drawing/2014/main" id="{FE3E1458-CABA-400B-8483-2504302172E8}"/>
+                <a16:creationId xmlns:a16="http://schemas.microsoft.com/office/drawing/2014/main" id="{C06B034C-2146-4028-9D32-32913184F557}"/>
               </a:ext>
             </a:extLst>
           </p:cNvPr>
@@ -14099,7 +13856,7 @@
           <p:cNvPr id="2" name="">
             <a:extLst xmlns:a="http://schemas.openxmlformats.org/drawingml/2006/main">
               <a:ext uri="{FF2B5EF4-FFF2-40B4-BE49-F238E27FC236}">
-                <a16:creationId xmlns:a16="http://schemas.microsoft.com/office/drawing/2014/main" id="{35C869F6-E1D4-4B9F-A246-7B5FE2874F77}"/>
+                <a16:creationId xmlns:a16="http://schemas.microsoft.com/office/drawing/2014/main" id="{FB9D4285-A1DB-4533-854A-86FF24CD89D0}"/>
               </a:ext>
             </a:extLst>
           </p:cNvPr>
@@ -14160,7 +13917,7 @@
           <p:cNvPr id="3" name="">
             <a:extLst xmlns:a="http://schemas.openxmlformats.org/drawingml/2006/main">
               <a:ext uri="{FF2B5EF4-FFF2-40B4-BE49-F238E27FC236}">
-                <a16:creationId xmlns:a16="http://schemas.microsoft.com/office/drawing/2014/main" id="{1CA0E48F-F288-4AE5-9D96-4682E5AD3406}"/>
+                <a16:creationId xmlns:a16="http://schemas.microsoft.com/office/drawing/2014/main" id="{9D6DC7F9-75C2-42D4-AE7A-FED1F00D649D}"/>
               </a:ext>
             </a:extLst>
           </p:cNvPr>
@@ -14217,7 +13974,7 @@
           <p:cNvPr id="4" name="">
             <a:extLst xmlns:a="http://schemas.openxmlformats.org/drawingml/2006/main">
               <a:ext uri="{FF2B5EF4-FFF2-40B4-BE49-F238E27FC236}">
-                <a16:creationId xmlns:a16="http://schemas.microsoft.com/office/drawing/2014/main" id="{0495A44B-2065-4790-AA9D-243B78E3D1D0}"/>
+                <a16:creationId xmlns:a16="http://schemas.microsoft.com/office/drawing/2014/main" id="{D3CBD201-7D86-4D13-9369-8E1D5F5DE969}"/>
               </a:ext>
             </a:extLst>
           </p:cNvPr>
@@ -14274,7 +14031,7 @@
           <p:cNvPr id="5" name="">
             <a:extLst xmlns:a="http://schemas.openxmlformats.org/drawingml/2006/main">
               <a:ext uri="{FF2B5EF4-FFF2-40B4-BE49-F238E27FC236}">
-                <a16:creationId xmlns:a16="http://schemas.microsoft.com/office/drawing/2014/main" id="{44CDF41A-6201-4CC6-9914-14E143D86FF3}"/>
+                <a16:creationId xmlns:a16="http://schemas.microsoft.com/office/drawing/2014/main" id="{FF29ACDE-3701-4FBC-88EC-610D6C9F71E3}"/>
               </a:ext>
             </a:extLst>
           </p:cNvPr>
@@ -14331,7 +14088,7 @@
           <p:cNvPr id="6" name="">
             <a:extLst xmlns:a="http://schemas.openxmlformats.org/drawingml/2006/main">
               <a:ext uri="{FF2B5EF4-FFF2-40B4-BE49-F238E27FC236}">
-                <a16:creationId xmlns:a16="http://schemas.microsoft.com/office/drawing/2014/main" id="{3BA25EA1-58A3-46D8-A7F9-98C2CE4FECBD}"/>
+                <a16:creationId xmlns:a16="http://schemas.microsoft.com/office/drawing/2014/main" id="{864D451B-E994-40D9-9368-AB5FCF9CC478}"/>
               </a:ext>
             </a:extLst>
           </p:cNvPr>
@@ -14388,7 +14145,7 @@
           <p:cNvPr id="7" name="">
             <a:extLst xmlns:a="http://schemas.openxmlformats.org/drawingml/2006/main">
               <a:ext uri="{FF2B5EF4-FFF2-40B4-BE49-F238E27FC236}">
-                <a16:creationId xmlns:a16="http://schemas.microsoft.com/office/drawing/2014/main" id="{4EB0ED06-52C0-4E7B-BA57-6D7EC9CC8442}"/>
+                <a16:creationId xmlns:a16="http://schemas.microsoft.com/office/drawing/2014/main" id="{78D2E0A3-0AEB-4D87-9A26-6B97F8657099}"/>
               </a:ext>
             </a:extLst>
           </p:cNvPr>
@@ -14418,7 +14175,7 @@
           <p:cNvPr id="8" name="">
             <a:extLst xmlns:a="http://schemas.openxmlformats.org/drawingml/2006/main">
               <a:ext uri="{FF2B5EF4-FFF2-40B4-BE49-F238E27FC236}">
-                <a16:creationId xmlns:a16="http://schemas.microsoft.com/office/drawing/2014/main" id="{BCC83831-9D31-4129-AFAD-AA19954196C5}"/>
+                <a16:creationId xmlns:a16="http://schemas.microsoft.com/office/drawing/2014/main" id="{26CCB279-6DDC-4BBB-8BB9-9F5865487C7B}"/>
               </a:ext>
             </a:extLst>
           </p:cNvPr>
@@ -14475,7 +14232,7 @@
           <p:cNvPr id="9" name="">
             <a:extLst xmlns:a="http://schemas.openxmlformats.org/drawingml/2006/main">
               <a:ext uri="{FF2B5EF4-FFF2-40B4-BE49-F238E27FC236}">
-                <a16:creationId xmlns:a16="http://schemas.microsoft.com/office/drawing/2014/main" id="{7E16D3E1-B2F1-47A0-A10D-CA9262ABEB84}"/>
+                <a16:creationId xmlns:a16="http://schemas.microsoft.com/office/drawing/2014/main" id="{39FB195C-0C1D-47E2-BE7A-9099B0A44C9B}"/>
               </a:ext>
             </a:extLst>
           </p:cNvPr>
@@ -14555,7 +14312,7 @@
           <p:cNvPr id="10" name="">
             <a:extLst xmlns:a="http://schemas.openxmlformats.org/drawingml/2006/main">
               <a:ext uri="{FF2B5EF4-FFF2-40B4-BE49-F238E27FC236}">
-                <a16:creationId xmlns:a16="http://schemas.microsoft.com/office/drawing/2014/main" id="{45B1FEA5-754B-44EB-A259-085F4CAFF372}"/>
+                <a16:creationId xmlns:a16="http://schemas.microsoft.com/office/drawing/2014/main" id="{8183649A-86E5-418A-96AF-2E75B17EBC25}"/>
               </a:ext>
             </a:extLst>
           </p:cNvPr>
@@ -14587,7 +14344,7 @@
           <p:cNvPr id="11" name="">
             <a:extLst xmlns:a="http://schemas.openxmlformats.org/drawingml/2006/main">
               <a:ext uri="{FF2B5EF4-FFF2-40B4-BE49-F238E27FC236}">
-                <a16:creationId xmlns:a16="http://schemas.microsoft.com/office/drawing/2014/main" id="{6C9CBDE6-660D-46F5-8BC4-A24D43389D24}"/>
+                <a16:creationId xmlns:a16="http://schemas.microsoft.com/office/drawing/2014/main" id="{35E9257D-2CB5-4AB1-B7D8-E0D4DABDAB5E}"/>
               </a:ext>
             </a:extLst>
           </p:cNvPr>
@@ -14644,7 +14401,7 @@
           <p:cNvPr id="12" name="">
             <a:extLst xmlns:a="http://schemas.openxmlformats.org/drawingml/2006/main">
               <a:ext uri="{FF2B5EF4-FFF2-40B4-BE49-F238E27FC236}">
-                <a16:creationId xmlns:a16="http://schemas.microsoft.com/office/drawing/2014/main" id="{333314BC-C903-4403-BFA7-CCF1AB88B51E}"/>
+                <a16:creationId xmlns:a16="http://schemas.microsoft.com/office/drawing/2014/main" id="{763690A8-F3A5-4317-B913-D665A319406F}"/>
               </a:ext>
             </a:extLst>
           </p:cNvPr>
@@ -14770,7 +14527,7 @@
           <p:cNvPr id="13" name="">
             <a:extLst xmlns:a="http://schemas.openxmlformats.org/drawingml/2006/main">
               <a:ext uri="{FF2B5EF4-FFF2-40B4-BE49-F238E27FC236}">
-                <a16:creationId xmlns:a16="http://schemas.microsoft.com/office/drawing/2014/main" id="{18D7DE38-7F28-4201-B037-DBE62071BB20}"/>
+                <a16:creationId xmlns:a16="http://schemas.microsoft.com/office/drawing/2014/main" id="{8C4136DE-315D-45B6-91DA-0067DA89B7CB}"/>
               </a:ext>
             </a:extLst>
           </p:cNvPr>
@@ -14802,7 +14559,7 @@
           <p:cNvPr id="14" name="">
             <a:extLst xmlns:a="http://schemas.openxmlformats.org/drawingml/2006/main">
               <a:ext uri="{FF2B5EF4-FFF2-40B4-BE49-F238E27FC236}">
-                <a16:creationId xmlns:a16="http://schemas.microsoft.com/office/drawing/2014/main" id="{9352FCD5-90B7-40BA-B14E-00E274B99DEB}"/>
+                <a16:creationId xmlns:a16="http://schemas.microsoft.com/office/drawing/2014/main" id="{1D81B0E5-3269-46A0-B444-5CCFD96D1134}"/>
               </a:ext>
             </a:extLst>
           </p:cNvPr>
@@ -14859,7 +14616,7 @@
           <p:cNvPr id="15" name="">
             <a:extLst xmlns:a="http://schemas.openxmlformats.org/drawingml/2006/main">
               <a:ext uri="{FF2B5EF4-FFF2-40B4-BE49-F238E27FC236}">
-                <a16:creationId xmlns:a16="http://schemas.microsoft.com/office/drawing/2014/main" id="{509D6780-83EB-44D3-970A-57FF5A065178}"/>
+                <a16:creationId xmlns:a16="http://schemas.microsoft.com/office/drawing/2014/main" id="{3F4BBF29-918D-4FC7-ACB5-4CD67963AFD5}"/>
               </a:ext>
             </a:extLst>
           </p:cNvPr>
@@ -14985,7 +14742,7 @@
           <p:cNvPr id="16" name="">
             <a:extLst xmlns:a="http://schemas.openxmlformats.org/drawingml/2006/main">
               <a:ext uri="{FF2B5EF4-FFF2-40B4-BE49-F238E27FC236}">
-                <a16:creationId xmlns:a16="http://schemas.microsoft.com/office/drawing/2014/main" id="{49CA29F2-7C32-4C2D-A347-CD36ADDFE89D}"/>
+                <a16:creationId xmlns:a16="http://schemas.microsoft.com/office/drawing/2014/main" id="{65B4DE3F-FC3F-4A77-8B39-6E24BA757A55}"/>
               </a:ext>
             </a:extLst>
           </p:cNvPr>
@@ -15042,7 +14799,7 @@
           <p:cNvPr id="17" name="">
             <a:extLst xmlns:a="http://schemas.openxmlformats.org/drawingml/2006/main">
               <a:ext uri="{FF2B5EF4-FFF2-40B4-BE49-F238E27FC236}">
-                <a16:creationId xmlns:a16="http://schemas.microsoft.com/office/drawing/2014/main" id="{E88B706A-A3E3-474D-9BE5-24A9C9AFCD2A}"/>
+                <a16:creationId xmlns:a16="http://schemas.microsoft.com/office/drawing/2014/main" id="{D6CABF24-E374-42DC-B8FA-98F1C32EE42A}"/>
               </a:ext>
             </a:extLst>
           </p:cNvPr>
@@ -15099,7 +14856,7 @@
           <p:cNvPr id="18" name="">
             <a:extLst xmlns:a="http://schemas.openxmlformats.org/drawingml/2006/main">
               <a:ext uri="{FF2B5EF4-FFF2-40B4-BE49-F238E27FC236}">
-                <a16:creationId xmlns:a16="http://schemas.microsoft.com/office/drawing/2014/main" id="{4C4FF212-8E74-424D-9A17-E58A8F84E862}"/>
+                <a16:creationId xmlns:a16="http://schemas.microsoft.com/office/drawing/2014/main" id="{ECDA65A9-C300-48EA-ABCD-1F30A37E000B}"/>
               </a:ext>
             </a:extLst>
           </p:cNvPr>
@@ -15131,7 +14888,7 @@
           <p:cNvPr id="19" name="">
             <a:extLst xmlns:a="http://schemas.openxmlformats.org/drawingml/2006/main">
               <a:ext uri="{FF2B5EF4-FFF2-40B4-BE49-F238E27FC236}">
-                <a16:creationId xmlns:a16="http://schemas.microsoft.com/office/drawing/2014/main" id="{7482329C-1A51-4F82-8B58-FEBD3D0DDB2D}"/>
+                <a16:creationId xmlns:a16="http://schemas.microsoft.com/office/drawing/2014/main" id="{D6DC7BC5-0A24-4907-A728-92F590E14C6F}"/>
               </a:ext>
             </a:extLst>
           </p:cNvPr>
@@ -15186,7 +14943,7 @@
     </p:spTree>
     <p:extLst>
       <p:ext uri="{BB962C8B-B14F-4D97-AF65-F5344CB8AC3E}">
-        <p14:creationId xmlns:p14="http://schemas.microsoft.com/office/powerpoint/2010/main" val="1215775863"/>
+        <p14:creationId xmlns:p14="http://schemas.microsoft.com/office/powerpoint/2010/main" val="2119908108"/>
       </p:ext>
     </p:extLst>
   </p:cSld>
@@ -15217,7 +14974,7 @@
           <p:cNvPr id="15" name="">
             <a:extLst xmlns:a="http://schemas.openxmlformats.org/drawingml/2006/main">
               <a:ext uri="{FF2B5EF4-FFF2-40B4-BE49-F238E27FC236}">
-                <a16:creationId xmlns:a16="http://schemas.microsoft.com/office/drawing/2014/main" id="{40946020-3F00-42E4-9D1D-BA51ADC293B3}"/>
+                <a16:creationId xmlns:a16="http://schemas.microsoft.com/office/drawing/2014/main" id="{2D88A45E-2950-410F-9872-8FAB05ACC6F7}"/>
               </a:ext>
             </a:extLst>
           </p:cNvPr>
@@ -15247,7 +15004,7 @@
           <p:cNvPr id="2" name="">
             <a:extLst xmlns:a="http://schemas.openxmlformats.org/drawingml/2006/main">
               <a:ext uri="{FF2B5EF4-FFF2-40B4-BE49-F238E27FC236}">
-                <a16:creationId xmlns:a16="http://schemas.microsoft.com/office/drawing/2014/main" id="{19420EA5-A198-4F1E-932C-8C61274660FA}"/>
+                <a16:creationId xmlns:a16="http://schemas.microsoft.com/office/drawing/2014/main" id="{0B454E62-C442-4932-9659-7FCE315549F1}"/>
               </a:ext>
             </a:extLst>
           </p:cNvPr>
@@ -15308,7 +15065,7 @@
           <p:cNvPr id="3" name="">
             <a:extLst xmlns:a="http://schemas.openxmlformats.org/drawingml/2006/main">
               <a:ext uri="{FF2B5EF4-FFF2-40B4-BE49-F238E27FC236}">
-                <a16:creationId xmlns:a16="http://schemas.microsoft.com/office/drawing/2014/main" id="{7EAEBF57-C187-44CE-BFD4-71030A33F1F5}"/>
+                <a16:creationId xmlns:a16="http://schemas.microsoft.com/office/drawing/2014/main" id="{CCC15A04-2680-49C7-8E49-A9A3E8AF423D}"/>
               </a:ext>
             </a:extLst>
           </p:cNvPr>
@@ -15365,7 +15122,7 @@
           <p:cNvPr id="4" name="">
             <a:extLst xmlns:a="http://schemas.openxmlformats.org/drawingml/2006/main">
               <a:ext uri="{FF2B5EF4-FFF2-40B4-BE49-F238E27FC236}">
-                <a16:creationId xmlns:a16="http://schemas.microsoft.com/office/drawing/2014/main" id="{6F854B92-CDE2-466C-9884-14B6AE7FE2A4}"/>
+                <a16:creationId xmlns:a16="http://schemas.microsoft.com/office/drawing/2014/main" id="{D0A5D509-1B4D-4759-9F13-6C8812DB5F67}"/>
               </a:ext>
             </a:extLst>
           </p:cNvPr>
@@ -15422,7 +15179,7 @@
           <p:cNvPr id="5" name="">
             <a:extLst xmlns:a="http://schemas.openxmlformats.org/drawingml/2006/main">
               <a:ext uri="{FF2B5EF4-FFF2-40B4-BE49-F238E27FC236}">
-                <a16:creationId xmlns:a16="http://schemas.microsoft.com/office/drawing/2014/main" id="{439280CB-C569-49FC-B2B1-D70815CE60D8}"/>
+                <a16:creationId xmlns:a16="http://schemas.microsoft.com/office/drawing/2014/main" id="{00C9C193-4BEA-4632-84FA-89BB05EF09A0}"/>
               </a:ext>
             </a:extLst>
           </p:cNvPr>
@@ -15479,7 +15236,7 @@
           <p:cNvPr id="6" name="">
             <a:extLst xmlns:a="http://schemas.openxmlformats.org/drawingml/2006/main">
               <a:ext uri="{FF2B5EF4-FFF2-40B4-BE49-F238E27FC236}">
-                <a16:creationId xmlns:a16="http://schemas.microsoft.com/office/drawing/2014/main" id="{224CCE6E-16CC-40A0-BEF4-FAC9B2AEB950}"/>
+                <a16:creationId xmlns:a16="http://schemas.microsoft.com/office/drawing/2014/main" id="{0C8594BB-D20F-4151-BAA1-6CD461D48896}"/>
               </a:ext>
             </a:extLst>
           </p:cNvPr>
@@ -15536,7 +15293,7 @@
           <p:cNvPr id="7" name="">
             <a:extLst xmlns:a="http://schemas.openxmlformats.org/drawingml/2006/main">
               <a:ext uri="{FF2B5EF4-FFF2-40B4-BE49-F238E27FC236}">
-                <a16:creationId xmlns:a16="http://schemas.microsoft.com/office/drawing/2014/main" id="{41093285-98A1-446B-A538-FCBF4B380A87}"/>
+                <a16:creationId xmlns:a16="http://schemas.microsoft.com/office/drawing/2014/main" id="{67FC31A6-F2FE-4B03-8090-1A9EB8D33E95}"/>
               </a:ext>
             </a:extLst>
           </p:cNvPr>
@@ -15593,7 +15350,7 @@
           <p:cNvPr id="8" name="">
             <a:extLst xmlns:a="http://schemas.openxmlformats.org/drawingml/2006/main">
               <a:ext uri="{FF2B5EF4-FFF2-40B4-BE49-F238E27FC236}">
-                <a16:creationId xmlns:a16="http://schemas.microsoft.com/office/drawing/2014/main" id="{1A40F1C9-2386-4949-8E35-B7280167DCB6}"/>
+                <a16:creationId xmlns:a16="http://schemas.microsoft.com/office/drawing/2014/main" id="{61D18D9A-174B-45C9-884C-DA524C3538F1}"/>
               </a:ext>
             </a:extLst>
           </p:cNvPr>
@@ -15673,7 +15430,7 @@
           <p:cNvPr id="9" name="">
             <a:extLst xmlns:a="http://schemas.openxmlformats.org/drawingml/2006/main">
               <a:ext uri="{FF2B5EF4-FFF2-40B4-BE49-F238E27FC236}">
-                <a16:creationId xmlns:a16="http://schemas.microsoft.com/office/drawing/2014/main" id="{863D664C-0CBD-47C5-B930-69AC441200C7}"/>
+                <a16:creationId xmlns:a16="http://schemas.microsoft.com/office/drawing/2014/main" id="{C024F3F0-9375-428D-936B-F2B195AD2663}"/>
               </a:ext>
             </a:extLst>
           </p:cNvPr>
@@ -15730,7 +15487,7 @@
           <p:cNvPr id="10" name="">
             <a:extLst xmlns:a="http://schemas.openxmlformats.org/drawingml/2006/main">
               <a:ext uri="{FF2B5EF4-FFF2-40B4-BE49-F238E27FC236}">
-                <a16:creationId xmlns:a16="http://schemas.microsoft.com/office/drawing/2014/main" id="{84B470BA-60F6-4C78-A636-71ABDE46A8D8}"/>
+                <a16:creationId xmlns:a16="http://schemas.microsoft.com/office/drawing/2014/main" id="{7977DE4A-AA1C-43D7-8A43-1B38E8557AF3}"/>
               </a:ext>
             </a:extLst>
           </p:cNvPr>
@@ -15764,7 +15521,7 @@
           <p:cNvPr id="11" name="">
             <a:extLst xmlns:a="http://schemas.openxmlformats.org/drawingml/2006/main">
               <a:ext uri="{FF2B5EF4-FFF2-40B4-BE49-F238E27FC236}">
-                <a16:creationId xmlns:a16="http://schemas.microsoft.com/office/drawing/2014/main" id="{4077F78B-B240-46C3-B25E-553466F53AEC}"/>
+                <a16:creationId xmlns:a16="http://schemas.microsoft.com/office/drawing/2014/main" id="{806E19CF-11F2-47D2-9598-0F15509F4855}"/>
               </a:ext>
             </a:extLst>
           </p:cNvPr>
@@ -15821,7 +15578,7 @@
           <p:cNvPr id="12" name="">
             <a:extLst xmlns:a="http://schemas.openxmlformats.org/drawingml/2006/main">
               <a:ext uri="{FF2B5EF4-FFF2-40B4-BE49-F238E27FC236}">
-                <a16:creationId xmlns:a16="http://schemas.microsoft.com/office/drawing/2014/main" id="{62D5D6BA-A8AC-495B-9F8B-675907A610F2}"/>
+                <a16:creationId xmlns:a16="http://schemas.microsoft.com/office/drawing/2014/main" id="{5829D34D-96E9-4DFC-9CB9-2679D88333C8}"/>
               </a:ext>
             </a:extLst>
           </p:cNvPr>
@@ -15882,10 +15639,10 @@
           <p:nvPr/>
         </p:nvPicPr>
         <p:blipFill>
-          <a:blip xmlns:r="http://schemas.openxmlformats.org/officeDocument/2006/relationships" xmlns:a="http://schemas.openxmlformats.org/drawingml/2006/main" r:embed="Rb673d669c5bd4dc3">
+          <a:blip xmlns:r="http://schemas.openxmlformats.org/officeDocument/2006/relationships" xmlns:a="http://schemas.openxmlformats.org/drawingml/2006/main" r:embed="R76cab0facb4549a5">
             <a:extLst>
               <a:ext uri="{96DAC541-7B7A-43D3-8B79-37D633B846F1}">
-                <asvg:svgBlip xmlns:asvg="http://schemas.microsoft.com/office/drawing/2016/SVG/main" r:embed="Rb61f3f6262d24c35"/>
+                <asvg:svgBlip xmlns:asvg="http://schemas.microsoft.com/office/drawing/2016/SVG/main" r:embed="R45469e08bb9143ca"/>
               </a:ext>
             </a:extLst>
           </a:blip>
@@ -15906,7 +15663,7 @@
           <p:cNvPr id="14" name="">
             <a:extLst xmlns:a="http://schemas.openxmlformats.org/drawingml/2006/main">
               <a:ext uri="{FF2B5EF4-FFF2-40B4-BE49-F238E27FC236}">
-                <a16:creationId xmlns:a16="http://schemas.microsoft.com/office/drawing/2014/main" id="{1F06AE16-1068-40FD-80B7-E675C350158A}"/>
+                <a16:creationId xmlns:a16="http://schemas.microsoft.com/office/drawing/2014/main" id="{99E21466-130D-4476-A195-926FA40E3A47}"/>
               </a:ext>
             </a:extLst>
           </p:cNvPr>
@@ -15961,7 +15718,7 @@
     </p:spTree>
     <p:extLst>
       <p:ext uri="{BB962C8B-B14F-4D97-AF65-F5344CB8AC3E}">
-        <p14:creationId xmlns:p14="http://schemas.microsoft.com/office/powerpoint/2010/main" val="388988370"/>
+        <p14:creationId xmlns:p14="http://schemas.microsoft.com/office/powerpoint/2010/main" val="1056350186"/>
       </p:ext>
     </p:extLst>
   </p:cSld>
@@ -15992,7 +15749,7 @@
           <p:cNvPr id="20" name="">
             <a:extLst xmlns:a="http://schemas.openxmlformats.org/drawingml/2006/main">
               <a:ext uri="{FF2B5EF4-FFF2-40B4-BE49-F238E27FC236}">
-                <a16:creationId xmlns:a16="http://schemas.microsoft.com/office/drawing/2014/main" id="{8146BCA9-FA39-40C8-A1A1-35B5F55D79FE}"/>
+                <a16:creationId xmlns:a16="http://schemas.microsoft.com/office/drawing/2014/main" id="{1A869279-E753-4514-AAD2-993C1AAB5A8D}"/>
               </a:ext>
             </a:extLst>
           </p:cNvPr>
@@ -16022,7 +15779,7 @@
           <p:cNvPr id="2" name="">
             <a:extLst xmlns:a="http://schemas.openxmlformats.org/drawingml/2006/main">
               <a:ext uri="{FF2B5EF4-FFF2-40B4-BE49-F238E27FC236}">
-                <a16:creationId xmlns:a16="http://schemas.microsoft.com/office/drawing/2014/main" id="{DA353D42-3124-40E6-8B56-10FF275A268E}"/>
+                <a16:creationId xmlns:a16="http://schemas.microsoft.com/office/drawing/2014/main" id="{26773FD2-19D5-4B8F-A56D-5278D47BBBE1}"/>
               </a:ext>
             </a:extLst>
           </p:cNvPr>
@@ -16083,7 +15840,7 @@
           <p:cNvPr id="3" name="">
             <a:extLst xmlns:a="http://schemas.openxmlformats.org/drawingml/2006/main">
               <a:ext uri="{FF2B5EF4-FFF2-40B4-BE49-F238E27FC236}">
-                <a16:creationId xmlns:a16="http://schemas.microsoft.com/office/drawing/2014/main" id="{9AF0E718-5F64-47EC-A278-225764124526}"/>
+                <a16:creationId xmlns:a16="http://schemas.microsoft.com/office/drawing/2014/main" id="{5210F487-1DBF-418D-8456-669C9B32172E}"/>
               </a:ext>
             </a:extLst>
           </p:cNvPr>
@@ -16140,7 +15897,7 @@
           <p:cNvPr id="4" name="">
             <a:extLst xmlns:a="http://schemas.openxmlformats.org/drawingml/2006/main">
               <a:ext uri="{FF2B5EF4-FFF2-40B4-BE49-F238E27FC236}">
-                <a16:creationId xmlns:a16="http://schemas.microsoft.com/office/drawing/2014/main" id="{08FCA08D-4B0C-411A-9A44-4469B78B8451}"/>
+                <a16:creationId xmlns:a16="http://schemas.microsoft.com/office/drawing/2014/main" id="{A3397272-6332-4F20-B4E4-34BC6CC06CC8}"/>
               </a:ext>
             </a:extLst>
           </p:cNvPr>
@@ -16197,7 +15954,7 @@
           <p:cNvPr id="5" name="">
             <a:extLst xmlns:a="http://schemas.openxmlformats.org/drawingml/2006/main">
               <a:ext uri="{FF2B5EF4-FFF2-40B4-BE49-F238E27FC236}">
-                <a16:creationId xmlns:a16="http://schemas.microsoft.com/office/drawing/2014/main" id="{423CA5CA-22A8-4CB1-A045-5342FE93ED9D}"/>
+                <a16:creationId xmlns:a16="http://schemas.microsoft.com/office/drawing/2014/main" id="{850F7FBD-3BEE-4990-8BF7-D4E121273368}"/>
               </a:ext>
             </a:extLst>
           </p:cNvPr>
@@ -16254,7 +16011,7 @@
           <p:cNvPr id="6" name="">
             <a:extLst xmlns:a="http://schemas.openxmlformats.org/drawingml/2006/main">
               <a:ext uri="{FF2B5EF4-FFF2-40B4-BE49-F238E27FC236}">
-                <a16:creationId xmlns:a16="http://schemas.microsoft.com/office/drawing/2014/main" id="{D307CF55-9881-4B5D-81C0-DF17D740DA39}"/>
+                <a16:creationId xmlns:a16="http://schemas.microsoft.com/office/drawing/2014/main" id="{C44C6999-76A1-423E-BCB2-74ECDD10872F}"/>
               </a:ext>
             </a:extLst>
           </p:cNvPr>
@@ -16311,7 +16068,7 @@
           <p:cNvPr id="7" name="">
             <a:extLst xmlns:a="http://schemas.openxmlformats.org/drawingml/2006/main">
               <a:ext uri="{FF2B5EF4-FFF2-40B4-BE49-F238E27FC236}">
-                <a16:creationId xmlns:a16="http://schemas.microsoft.com/office/drawing/2014/main" id="{664B09B8-F90D-42B6-8A4B-2D3BD7869A8A}"/>
+                <a16:creationId xmlns:a16="http://schemas.microsoft.com/office/drawing/2014/main" id="{45C82E38-107A-4218-BB55-D02717507C57}"/>
               </a:ext>
             </a:extLst>
           </p:cNvPr>
@@ -16368,7 +16125,7 @@
           <p:cNvPr id="8" name="">
             <a:extLst xmlns:a="http://schemas.openxmlformats.org/drawingml/2006/main">
               <a:ext uri="{FF2B5EF4-FFF2-40B4-BE49-F238E27FC236}">
-                <a16:creationId xmlns:a16="http://schemas.microsoft.com/office/drawing/2014/main" id="{98D21879-FC6C-4B3A-BF6B-552F192C6024}"/>
+                <a16:creationId xmlns:a16="http://schemas.microsoft.com/office/drawing/2014/main" id="{0DDF9AC3-922F-4DCE-8535-DF5199D3B849}"/>
               </a:ext>
             </a:extLst>
           </p:cNvPr>
@@ -16448,7 +16205,7 @@
           <p:cNvPr id="9" name="">
             <a:extLst xmlns:a="http://schemas.openxmlformats.org/drawingml/2006/main">
               <a:ext uri="{FF2B5EF4-FFF2-40B4-BE49-F238E27FC236}">
-                <a16:creationId xmlns:a16="http://schemas.microsoft.com/office/drawing/2014/main" id="{2ADEA891-740F-4EDF-B831-8A243720E974}"/>
+                <a16:creationId xmlns:a16="http://schemas.microsoft.com/office/drawing/2014/main" id="{D1E3C75F-45BC-46E4-9310-217E4AB5ABDF}"/>
               </a:ext>
             </a:extLst>
           </p:cNvPr>
@@ -16482,7 +16239,7 @@
           <p:cNvPr id="10" name="">
             <a:extLst xmlns:a="http://schemas.openxmlformats.org/drawingml/2006/main">
               <a:ext uri="{FF2B5EF4-FFF2-40B4-BE49-F238E27FC236}">
-                <a16:creationId xmlns:a16="http://schemas.microsoft.com/office/drawing/2014/main" id="{970D2B03-1A44-4B5B-8948-3A4B3EEFFC4D}"/>
+                <a16:creationId xmlns:a16="http://schemas.microsoft.com/office/drawing/2014/main" id="{94929E46-1668-44A1-90C4-14EE2A61488E}"/>
               </a:ext>
             </a:extLst>
           </p:cNvPr>
@@ -16539,7 +16296,7 @@
           <p:cNvPr id="11" name="">
             <a:extLst xmlns:a="http://schemas.openxmlformats.org/drawingml/2006/main">
               <a:ext uri="{FF2B5EF4-FFF2-40B4-BE49-F238E27FC236}">
-                <a16:creationId xmlns:a16="http://schemas.microsoft.com/office/drawing/2014/main" id="{B9CB0847-833B-4FBD-A89E-8DC5DC301768}"/>
+                <a16:creationId xmlns:a16="http://schemas.microsoft.com/office/drawing/2014/main" id="{469EAE08-17F4-4BC0-8C30-D7ADB7C48D95}"/>
               </a:ext>
             </a:extLst>
           </p:cNvPr>
@@ -16596,7 +16353,7 @@
           <p:cNvPr id="12" name="">
             <a:extLst xmlns:a="http://schemas.openxmlformats.org/drawingml/2006/main">
               <a:ext uri="{FF2B5EF4-FFF2-40B4-BE49-F238E27FC236}">
-                <a16:creationId xmlns:a16="http://schemas.microsoft.com/office/drawing/2014/main" id="{3DA307BA-1E39-40BA-A0DD-5A1070C95AA4}"/>
+                <a16:creationId xmlns:a16="http://schemas.microsoft.com/office/drawing/2014/main" id="{EBF891E1-064C-49C2-B798-300ED40209D7}"/>
               </a:ext>
             </a:extLst>
           </p:cNvPr>
@@ -16630,7 +16387,7 @@
           <p:cNvPr id="13" name="">
             <a:extLst xmlns:a="http://schemas.openxmlformats.org/drawingml/2006/main">
               <a:ext uri="{FF2B5EF4-FFF2-40B4-BE49-F238E27FC236}">
-                <a16:creationId xmlns:a16="http://schemas.microsoft.com/office/drawing/2014/main" id="{44FDFC29-09F6-420F-B5B7-8D7506E70D58}"/>
+                <a16:creationId xmlns:a16="http://schemas.microsoft.com/office/drawing/2014/main" id="{28BA6561-0750-4B24-8BEC-98077B45F487}"/>
               </a:ext>
             </a:extLst>
           </p:cNvPr>
@@ -16687,7 +16444,7 @@
           <p:cNvPr id="14" name="">
             <a:extLst xmlns:a="http://schemas.openxmlformats.org/drawingml/2006/main">
               <a:ext uri="{FF2B5EF4-FFF2-40B4-BE49-F238E27FC236}">
-                <a16:creationId xmlns:a16="http://schemas.microsoft.com/office/drawing/2014/main" id="{1DC83CC0-2443-4829-AD78-463C0DED1B78}"/>
+                <a16:creationId xmlns:a16="http://schemas.microsoft.com/office/drawing/2014/main" id="{22D462AE-0FBB-4DA4-8789-5428037EF3B5}"/>
               </a:ext>
             </a:extLst>
           </p:cNvPr>
@@ -16744,7 +16501,7 @@
           <p:cNvPr id="15" name="">
             <a:extLst xmlns:a="http://schemas.openxmlformats.org/drawingml/2006/main">
               <a:ext uri="{FF2B5EF4-FFF2-40B4-BE49-F238E27FC236}">
-                <a16:creationId xmlns:a16="http://schemas.microsoft.com/office/drawing/2014/main" id="{8C46C04A-16D2-443D-A2C3-FC76A6225543}"/>
+                <a16:creationId xmlns:a16="http://schemas.microsoft.com/office/drawing/2014/main" id="{D659AC02-D741-43E4-907A-0377031FEBED}"/>
               </a:ext>
             </a:extLst>
           </p:cNvPr>
@@ -16778,7 +16535,7 @@
           <p:cNvPr id="16" name="">
             <a:extLst xmlns:a="http://schemas.openxmlformats.org/drawingml/2006/main">
               <a:ext uri="{FF2B5EF4-FFF2-40B4-BE49-F238E27FC236}">
-                <a16:creationId xmlns:a16="http://schemas.microsoft.com/office/drawing/2014/main" id="{C08D6CFF-2E7B-482C-ADF0-ADED7A0E7635}"/>
+                <a16:creationId xmlns:a16="http://schemas.microsoft.com/office/drawing/2014/main" id="{D1432084-BC6A-4370-AC88-6C21BCC026DA}"/>
               </a:ext>
             </a:extLst>
           </p:cNvPr>
@@ -16835,7 +16592,7 @@
           <p:cNvPr id="17" name="">
             <a:extLst xmlns:a="http://schemas.openxmlformats.org/drawingml/2006/main">
               <a:ext uri="{FF2B5EF4-FFF2-40B4-BE49-F238E27FC236}">
-                <a16:creationId xmlns:a16="http://schemas.microsoft.com/office/drawing/2014/main" id="{CB4AB795-DD7B-4390-9CD5-37AF4C4056B4}"/>
+                <a16:creationId xmlns:a16="http://schemas.microsoft.com/office/drawing/2014/main" id="{0D8C920B-D64A-44BA-A7CA-913E0EB19E7C}"/>
               </a:ext>
             </a:extLst>
           </p:cNvPr>
@@ -16892,7 +16649,7 @@
           <p:cNvPr id="18" name="">
             <a:extLst xmlns:a="http://schemas.openxmlformats.org/drawingml/2006/main">
               <a:ext uri="{FF2B5EF4-FFF2-40B4-BE49-F238E27FC236}">
-                <a16:creationId xmlns:a16="http://schemas.microsoft.com/office/drawing/2014/main" id="{7959342D-1EFB-4E23-97CF-D94D14EF0925}"/>
+                <a16:creationId xmlns:a16="http://schemas.microsoft.com/office/drawing/2014/main" id="{BD59206F-A0FA-4BD8-9A32-B917CF584FC7}"/>
               </a:ext>
             </a:extLst>
           </p:cNvPr>
@@ -16924,7 +16681,7 @@
           <p:cNvPr id="19" name="">
             <a:extLst xmlns:a="http://schemas.openxmlformats.org/drawingml/2006/main">
               <a:ext uri="{FF2B5EF4-FFF2-40B4-BE49-F238E27FC236}">
-                <a16:creationId xmlns:a16="http://schemas.microsoft.com/office/drawing/2014/main" id="{E22C680D-8626-4BCD-BDCB-29ACE0D79539}"/>
+                <a16:creationId xmlns:a16="http://schemas.microsoft.com/office/drawing/2014/main" id="{312E890B-173F-4D32-8D8F-8CBFBDB20B2B}"/>
               </a:ext>
             </a:extLst>
           </p:cNvPr>
@@ -16979,7 +16736,7 @@
     </p:spTree>
     <p:extLst>
       <p:ext uri="{BB962C8B-B14F-4D97-AF65-F5344CB8AC3E}">
-        <p14:creationId xmlns:p14="http://schemas.microsoft.com/office/powerpoint/2010/main" val="849822815"/>
+        <p14:creationId xmlns:p14="http://schemas.microsoft.com/office/powerpoint/2010/main" val="2029751439"/>
       </p:ext>
     </p:extLst>
   </p:cSld>
@@ -17010,7 +16767,7 @@
           <p:cNvPr id="25" name="">
             <a:extLst xmlns:a="http://schemas.openxmlformats.org/drawingml/2006/main">
               <a:ext uri="{FF2B5EF4-FFF2-40B4-BE49-F238E27FC236}">
-                <a16:creationId xmlns:a16="http://schemas.microsoft.com/office/drawing/2014/main" id="{87C76F3D-2D06-4C8C-A57C-A68BDFB9E75F}"/>
+                <a16:creationId xmlns:a16="http://schemas.microsoft.com/office/drawing/2014/main" id="{777EDB60-9A48-461F-BAC1-56B49D3D783D}"/>
               </a:ext>
             </a:extLst>
           </p:cNvPr>
@@ -17040,7 +16797,7 @@
           <p:cNvPr id="2" name="">
             <a:extLst xmlns:a="http://schemas.openxmlformats.org/drawingml/2006/main">
               <a:ext uri="{FF2B5EF4-FFF2-40B4-BE49-F238E27FC236}">
-                <a16:creationId xmlns:a16="http://schemas.microsoft.com/office/drawing/2014/main" id="{B6510766-CBF1-47EA-B7E6-9F566CF69C5A}"/>
+                <a16:creationId xmlns:a16="http://schemas.microsoft.com/office/drawing/2014/main" id="{C32F8947-61F7-47C6-9E99-50EED6F4582C}"/>
               </a:ext>
             </a:extLst>
           </p:cNvPr>
@@ -17101,7 +16858,7 @@
           <p:cNvPr id="3" name="">
             <a:extLst xmlns:a="http://schemas.openxmlformats.org/drawingml/2006/main">
               <a:ext uri="{FF2B5EF4-FFF2-40B4-BE49-F238E27FC236}">
-                <a16:creationId xmlns:a16="http://schemas.microsoft.com/office/drawing/2014/main" id="{63EFD4E1-EA83-4312-A936-ADB4F50CB4CF}"/>
+                <a16:creationId xmlns:a16="http://schemas.microsoft.com/office/drawing/2014/main" id="{0C2E29F8-CE95-491A-9EC6-2F78EE80610D}"/>
               </a:ext>
             </a:extLst>
           </p:cNvPr>
@@ -17158,7 +16915,7 @@
           <p:cNvPr id="4" name="">
             <a:extLst xmlns:a="http://schemas.openxmlformats.org/drawingml/2006/main">
               <a:ext uri="{FF2B5EF4-FFF2-40B4-BE49-F238E27FC236}">
-                <a16:creationId xmlns:a16="http://schemas.microsoft.com/office/drawing/2014/main" id="{92B70C29-A872-464B-A95C-08966C216C25}"/>
+                <a16:creationId xmlns:a16="http://schemas.microsoft.com/office/drawing/2014/main" id="{3FB40DA6-78D8-4BD4-85E8-B0E78ADBD27E}"/>
               </a:ext>
             </a:extLst>
           </p:cNvPr>
@@ -17215,7 +16972,7 @@
           <p:cNvPr id="5" name="">
             <a:extLst xmlns:a="http://schemas.openxmlformats.org/drawingml/2006/main">
               <a:ext uri="{FF2B5EF4-FFF2-40B4-BE49-F238E27FC236}">
-                <a16:creationId xmlns:a16="http://schemas.microsoft.com/office/drawing/2014/main" id="{B179243D-B433-43A7-AF7E-024B66150166}"/>
+                <a16:creationId xmlns:a16="http://schemas.microsoft.com/office/drawing/2014/main" id="{9443B997-BAEC-4C09-B7C5-F7A68CD7FB23}"/>
               </a:ext>
             </a:extLst>
           </p:cNvPr>
@@ -17272,7 +17029,7 @@
           <p:cNvPr id="6" name="">
             <a:extLst xmlns:a="http://schemas.openxmlformats.org/drawingml/2006/main">
               <a:ext uri="{FF2B5EF4-FFF2-40B4-BE49-F238E27FC236}">
-                <a16:creationId xmlns:a16="http://schemas.microsoft.com/office/drawing/2014/main" id="{98378758-3640-4454-9C8D-F315998723B3}"/>
+                <a16:creationId xmlns:a16="http://schemas.microsoft.com/office/drawing/2014/main" id="{9E6C17B8-3D77-4345-8DFB-31728D196FD1}"/>
               </a:ext>
             </a:extLst>
           </p:cNvPr>
@@ -17329,7 +17086,7 @@
           <p:cNvPr id="7" name="">
             <a:extLst xmlns:a="http://schemas.openxmlformats.org/drawingml/2006/main">
               <a:ext uri="{FF2B5EF4-FFF2-40B4-BE49-F238E27FC236}">
-                <a16:creationId xmlns:a16="http://schemas.microsoft.com/office/drawing/2014/main" id="{78592DA2-BEE9-4386-802C-0CFC7C55EFE0}"/>
+                <a16:creationId xmlns:a16="http://schemas.microsoft.com/office/drawing/2014/main" id="{B143A837-AD5B-40E6-AE50-E47844E206CD}"/>
               </a:ext>
             </a:extLst>
           </p:cNvPr>
@@ -17386,7 +17143,7 @@
           <p:cNvPr id="8" name="">
             <a:extLst xmlns:a="http://schemas.openxmlformats.org/drawingml/2006/main">
               <a:ext uri="{FF2B5EF4-FFF2-40B4-BE49-F238E27FC236}">
-                <a16:creationId xmlns:a16="http://schemas.microsoft.com/office/drawing/2014/main" id="{88EFFB8D-466C-4F52-B0FB-6A497E948F1D}"/>
+                <a16:creationId xmlns:a16="http://schemas.microsoft.com/office/drawing/2014/main" id="{BA51B2FA-1DB8-48DA-BB7E-1A15C835FF9B}"/>
               </a:ext>
             </a:extLst>
           </p:cNvPr>
@@ -17443,7 +17200,7 @@
           <p:cNvPr id="9" name="">
             <a:extLst xmlns:a="http://schemas.openxmlformats.org/drawingml/2006/main">
               <a:ext uri="{FF2B5EF4-FFF2-40B4-BE49-F238E27FC236}">
-                <a16:creationId xmlns:a16="http://schemas.microsoft.com/office/drawing/2014/main" id="{5957E3E2-3230-4A38-A419-648736DDD990}"/>
+                <a16:creationId xmlns:a16="http://schemas.microsoft.com/office/drawing/2014/main" id="{910BB220-2808-477C-BB6C-250CBCBC9194}"/>
               </a:ext>
             </a:extLst>
           </p:cNvPr>
@@ -17500,7 +17257,7 @@
           <p:cNvPr id="10" name="">
             <a:extLst xmlns:a="http://schemas.openxmlformats.org/drawingml/2006/main">
               <a:ext uri="{FF2B5EF4-FFF2-40B4-BE49-F238E27FC236}">
-                <a16:creationId xmlns:a16="http://schemas.microsoft.com/office/drawing/2014/main" id="{AEB506AC-90CA-4665-9720-F62A831AA945}"/>
+                <a16:creationId xmlns:a16="http://schemas.microsoft.com/office/drawing/2014/main" id="{16A4C591-91CD-4CA5-9A52-62A79EDF9CF6}"/>
               </a:ext>
             </a:extLst>
           </p:cNvPr>
@@ -17534,7 +17291,7 @@
           <p:cNvPr id="11" name="">
             <a:extLst xmlns:a="http://schemas.openxmlformats.org/drawingml/2006/main">
               <a:ext uri="{FF2B5EF4-FFF2-40B4-BE49-F238E27FC236}">
-                <a16:creationId xmlns:a16="http://schemas.microsoft.com/office/drawing/2014/main" id="{D2DC353D-7A79-4801-A958-62483127081B}"/>
+                <a16:creationId xmlns:a16="http://schemas.microsoft.com/office/drawing/2014/main" id="{03F9E5E2-25EC-40C2-8810-AF17E9F1D306}"/>
               </a:ext>
             </a:extLst>
           </p:cNvPr>
@@ -17591,7 +17348,7 @@
           <p:cNvPr id="12" name="">
             <a:extLst xmlns:a="http://schemas.openxmlformats.org/drawingml/2006/main">
               <a:ext uri="{FF2B5EF4-FFF2-40B4-BE49-F238E27FC236}">
-                <a16:creationId xmlns:a16="http://schemas.microsoft.com/office/drawing/2014/main" id="{7ACBB277-0327-4D12-86F2-6D6236A192F0}"/>
+                <a16:creationId xmlns:a16="http://schemas.microsoft.com/office/drawing/2014/main" id="{B6E9B5EF-41E1-4E37-9A2D-A2760509D34F}"/>
               </a:ext>
             </a:extLst>
           </p:cNvPr>
@@ -17648,7 +17405,7 @@
           <p:cNvPr id="13" name="">
             <a:extLst xmlns:a="http://schemas.openxmlformats.org/drawingml/2006/main">
               <a:ext uri="{FF2B5EF4-FFF2-40B4-BE49-F238E27FC236}">
-                <a16:creationId xmlns:a16="http://schemas.microsoft.com/office/drawing/2014/main" id="{56196C85-C2EE-4B90-BBAC-470E19625A65}"/>
+                <a16:creationId xmlns:a16="http://schemas.microsoft.com/office/drawing/2014/main" id="{63835E06-8FCC-4476-899E-3F5364A8CCAF}"/>
               </a:ext>
             </a:extLst>
           </p:cNvPr>
@@ -17682,7 +17439,7 @@
           <p:cNvPr id="14" name="">
             <a:extLst xmlns:a="http://schemas.openxmlformats.org/drawingml/2006/main">
               <a:ext uri="{FF2B5EF4-FFF2-40B4-BE49-F238E27FC236}">
-                <a16:creationId xmlns:a16="http://schemas.microsoft.com/office/drawing/2014/main" id="{74192929-F17E-40CA-95B7-162138BFA436}"/>
+                <a16:creationId xmlns:a16="http://schemas.microsoft.com/office/drawing/2014/main" id="{B8958031-BDC3-4B32-BB0F-3E4C28AFFBC9}"/>
               </a:ext>
             </a:extLst>
           </p:cNvPr>
@@ -17739,7 +17496,7 @@
           <p:cNvPr id="15" name="">
             <a:extLst xmlns:a="http://schemas.openxmlformats.org/drawingml/2006/main">
               <a:ext uri="{FF2B5EF4-FFF2-40B4-BE49-F238E27FC236}">
-                <a16:creationId xmlns:a16="http://schemas.microsoft.com/office/drawing/2014/main" id="{77F1473C-5668-456C-8216-1065A5BCCF7B}"/>
+                <a16:creationId xmlns:a16="http://schemas.microsoft.com/office/drawing/2014/main" id="{59EDA965-B782-4954-8E1F-B749D025C233}"/>
               </a:ext>
             </a:extLst>
           </p:cNvPr>
@@ -17796,7 +17553,7 @@
           <p:cNvPr id="16" name="">
             <a:extLst xmlns:a="http://schemas.openxmlformats.org/drawingml/2006/main">
               <a:ext uri="{FF2B5EF4-FFF2-40B4-BE49-F238E27FC236}">
-                <a16:creationId xmlns:a16="http://schemas.microsoft.com/office/drawing/2014/main" id="{AC235D78-E928-4288-961B-745960A268D4}"/>
+                <a16:creationId xmlns:a16="http://schemas.microsoft.com/office/drawing/2014/main" id="{7AF2A632-0AA2-4C86-B658-6361DCC94C04}"/>
               </a:ext>
             </a:extLst>
           </p:cNvPr>
@@ -17830,7 +17587,7 @@
           <p:cNvPr id="17" name="">
             <a:extLst xmlns:a="http://schemas.openxmlformats.org/drawingml/2006/main">
               <a:ext uri="{FF2B5EF4-FFF2-40B4-BE49-F238E27FC236}">
-                <a16:creationId xmlns:a16="http://schemas.microsoft.com/office/drawing/2014/main" id="{44A9F7FC-A8F3-41E8-A8BD-388D3458154F}"/>
+                <a16:creationId xmlns:a16="http://schemas.microsoft.com/office/drawing/2014/main" id="{D9CF6E96-7A40-4183-87C0-0BF1C9D6E6C5}"/>
               </a:ext>
             </a:extLst>
           </p:cNvPr>
@@ -17887,7 +17644,7 @@
           <p:cNvPr id="18" name="">
             <a:extLst xmlns:a="http://schemas.openxmlformats.org/drawingml/2006/main">
               <a:ext uri="{FF2B5EF4-FFF2-40B4-BE49-F238E27FC236}">
-                <a16:creationId xmlns:a16="http://schemas.microsoft.com/office/drawing/2014/main" id="{4FCB7E2A-707C-4A2B-99B8-78664EEF0C66}"/>
+                <a16:creationId xmlns:a16="http://schemas.microsoft.com/office/drawing/2014/main" id="{1ACC9304-CD48-4AFC-8613-8DF66770C0AF}"/>
               </a:ext>
             </a:extLst>
           </p:cNvPr>
@@ -17944,7 +17701,7 @@
           <p:cNvPr id="19" name="">
             <a:extLst xmlns:a="http://schemas.openxmlformats.org/drawingml/2006/main">
               <a:ext uri="{FF2B5EF4-FFF2-40B4-BE49-F238E27FC236}">
-                <a16:creationId xmlns:a16="http://schemas.microsoft.com/office/drawing/2014/main" id="{D23E0528-E3B5-498A-BC4A-9C63615315AD}"/>
+                <a16:creationId xmlns:a16="http://schemas.microsoft.com/office/drawing/2014/main" id="{11B8D863-5FF6-4346-8FF0-88DB40F416F9}"/>
               </a:ext>
             </a:extLst>
           </p:cNvPr>
@@ -17978,7 +17735,7 @@
           <p:cNvPr id="20" name="">
             <a:extLst xmlns:a="http://schemas.openxmlformats.org/drawingml/2006/main">
               <a:ext uri="{FF2B5EF4-FFF2-40B4-BE49-F238E27FC236}">
-                <a16:creationId xmlns:a16="http://schemas.microsoft.com/office/drawing/2014/main" id="{AF4C5F46-0AE5-4957-A453-ECB4432F4C5E}"/>
+                <a16:creationId xmlns:a16="http://schemas.microsoft.com/office/drawing/2014/main" id="{B66F1E71-A7CB-4217-9550-1E2C62A7CD8D}"/>
               </a:ext>
             </a:extLst>
           </p:cNvPr>
@@ -18035,7 +17792,7 @@
           <p:cNvPr id="21" name="">
             <a:extLst xmlns:a="http://schemas.openxmlformats.org/drawingml/2006/main">
               <a:ext uri="{FF2B5EF4-FFF2-40B4-BE49-F238E27FC236}">
-                <a16:creationId xmlns:a16="http://schemas.microsoft.com/office/drawing/2014/main" id="{30094405-3952-4ABB-8E02-928CB5638D5D}"/>
+                <a16:creationId xmlns:a16="http://schemas.microsoft.com/office/drawing/2014/main" id="{801C7DE2-95A2-4FDA-A05E-3D848A928E26}"/>
               </a:ext>
             </a:extLst>
           </p:cNvPr>
@@ -18092,7 +17849,7 @@
           <p:cNvPr id="22" name="">
             <a:extLst xmlns:a="http://schemas.openxmlformats.org/drawingml/2006/main">
               <a:ext uri="{FF2B5EF4-FFF2-40B4-BE49-F238E27FC236}">
-                <a16:creationId xmlns:a16="http://schemas.microsoft.com/office/drawing/2014/main" id="{4393B6EA-DF50-47AF-8931-1CE17891B873}"/>
+                <a16:creationId xmlns:a16="http://schemas.microsoft.com/office/drawing/2014/main" id="{D6FB2EFD-E6C8-416C-8378-05196DC37F6B}"/>
               </a:ext>
             </a:extLst>
           </p:cNvPr>
@@ -18130,7 +17887,7 @@
           <p:nvPr/>
         </p:nvPicPr>
         <p:blipFill>
-          <a:blip xmlns:r="http://schemas.openxmlformats.org/officeDocument/2006/relationships" xmlns:a="http://schemas.openxmlformats.org/drawingml/2006/main" r:embed="R52760b0d54254068"/>
+          <a:blip xmlns:r="http://schemas.openxmlformats.org/officeDocument/2006/relationships" xmlns:a="http://schemas.openxmlformats.org/drawingml/2006/main" r:embed="R11eec596dc1f4467"/>
           <a:stretch xmlns:a="http://schemas.openxmlformats.org/drawingml/2006/main"/>
         </p:blipFill>
         <p:spPr>
@@ -18150,7 +17907,7 @@
           <p:cNvPr id="24" name="">
             <a:extLst xmlns:a="http://schemas.openxmlformats.org/drawingml/2006/main">
               <a:ext uri="{FF2B5EF4-FFF2-40B4-BE49-F238E27FC236}">
-                <a16:creationId xmlns:a16="http://schemas.microsoft.com/office/drawing/2014/main" id="{F88F724F-6927-435C-8DFA-05EB3A2E2BD8}"/>
+                <a16:creationId xmlns:a16="http://schemas.microsoft.com/office/drawing/2014/main" id="{484974D7-5DAE-466C-A483-5A766339FFEF}"/>
               </a:ext>
             </a:extLst>
           </p:cNvPr>
@@ -18205,7 +17962,7 @@
     </p:spTree>
     <p:extLst>
       <p:ext uri="{BB962C8B-B14F-4D97-AF65-F5344CB8AC3E}">
-        <p14:creationId xmlns:p14="http://schemas.microsoft.com/office/powerpoint/2010/main" val="1935165100"/>
+        <p14:creationId xmlns:p14="http://schemas.microsoft.com/office/powerpoint/2010/main" val="80710277"/>
       </p:ext>
     </p:extLst>
   </p:cSld>
@@ -18236,7 +17993,7 @@
           <p:cNvPr id="84" name="">
             <a:extLst xmlns:a="http://schemas.openxmlformats.org/drawingml/2006/main">
               <a:ext uri="{FF2B5EF4-FFF2-40B4-BE49-F238E27FC236}">
-                <a16:creationId xmlns:a16="http://schemas.microsoft.com/office/drawing/2014/main" id="{A72FEF98-EC31-482A-80CA-D0C6E924790B}"/>
+                <a16:creationId xmlns:a16="http://schemas.microsoft.com/office/drawing/2014/main" id="{E8B2CCD4-2666-4930-A43C-093748688573}"/>
               </a:ext>
             </a:extLst>
           </p:cNvPr>
@@ -18266,7 +18023,7 @@
           <p:cNvPr id="2" name="">
             <a:extLst xmlns:a="http://schemas.openxmlformats.org/drawingml/2006/main">
               <a:ext uri="{FF2B5EF4-FFF2-40B4-BE49-F238E27FC236}">
-                <a16:creationId xmlns:a16="http://schemas.microsoft.com/office/drawing/2014/main" id="{8D636B2B-D5FB-407D-AB9A-7171D41C93B1}"/>
+                <a16:creationId xmlns:a16="http://schemas.microsoft.com/office/drawing/2014/main" id="{A0FF5E2A-F8F2-4287-8355-15050B56995A}"/>
               </a:ext>
             </a:extLst>
           </p:cNvPr>
@@ -18327,7 +18084,7 @@
           <p:cNvPr id="3" name="">
             <a:extLst xmlns:a="http://schemas.openxmlformats.org/drawingml/2006/main">
               <a:ext uri="{FF2B5EF4-FFF2-40B4-BE49-F238E27FC236}">
-                <a16:creationId xmlns:a16="http://schemas.microsoft.com/office/drawing/2014/main" id="{97E5C6E7-5AC9-413C-B8C7-DE191DC414F6}"/>
+                <a16:creationId xmlns:a16="http://schemas.microsoft.com/office/drawing/2014/main" id="{BE058118-B532-415C-97CC-9D412159756D}"/>
               </a:ext>
             </a:extLst>
           </p:cNvPr>
@@ -18384,7 +18141,7 @@
           <p:cNvPr id="4" name="">
             <a:extLst xmlns:a="http://schemas.openxmlformats.org/drawingml/2006/main">
               <a:ext uri="{FF2B5EF4-FFF2-40B4-BE49-F238E27FC236}">
-                <a16:creationId xmlns:a16="http://schemas.microsoft.com/office/drawing/2014/main" id="{4AE75BF3-16DD-4CF6-80C6-57468F7BB968}"/>
+                <a16:creationId xmlns:a16="http://schemas.microsoft.com/office/drawing/2014/main" id="{B16468AA-578E-42C6-B4C7-9ED3C16A90E0}"/>
               </a:ext>
             </a:extLst>
           </p:cNvPr>
@@ -18441,7 +18198,7 @@
           <p:cNvPr id="5" name="">
             <a:extLst xmlns:a="http://schemas.openxmlformats.org/drawingml/2006/main">
               <a:ext uri="{FF2B5EF4-FFF2-40B4-BE49-F238E27FC236}">
-                <a16:creationId xmlns:a16="http://schemas.microsoft.com/office/drawing/2014/main" id="{28BE170C-71F4-4D54-8477-1A17FD581CB4}"/>
+                <a16:creationId xmlns:a16="http://schemas.microsoft.com/office/drawing/2014/main" id="{B393DD5E-9218-44FF-8B62-F91475B9C7CF}"/>
               </a:ext>
             </a:extLst>
           </p:cNvPr>
@@ -18498,7 +18255,7 @@
           <p:cNvPr id="6" name="">
             <a:extLst xmlns:a="http://schemas.openxmlformats.org/drawingml/2006/main">
               <a:ext uri="{FF2B5EF4-FFF2-40B4-BE49-F238E27FC236}">
-                <a16:creationId xmlns:a16="http://schemas.microsoft.com/office/drawing/2014/main" id="{DC3911A4-49A7-4F63-90DE-6FEF7F76CEA9}"/>
+                <a16:creationId xmlns:a16="http://schemas.microsoft.com/office/drawing/2014/main" id="{4D620906-EEEA-4A1A-8D1D-750276B67402}"/>
               </a:ext>
             </a:extLst>
           </p:cNvPr>
@@ -18555,7 +18312,7 @@
           <p:cNvPr id="7" name="">
             <a:extLst xmlns:a="http://schemas.openxmlformats.org/drawingml/2006/main">
               <a:ext uri="{FF2B5EF4-FFF2-40B4-BE49-F238E27FC236}">
-                <a16:creationId xmlns:a16="http://schemas.microsoft.com/office/drawing/2014/main" id="{24E71297-B3FB-4D66-AC30-2F6802119982}"/>
+                <a16:creationId xmlns:a16="http://schemas.microsoft.com/office/drawing/2014/main" id="{7B10AD26-DAE4-43B8-859B-23AD71DF9C38}"/>
               </a:ext>
             </a:extLst>
           </p:cNvPr>
@@ -18612,7 +18369,7 @@
           <p:cNvPr id="8" name="">
             <a:extLst xmlns:a="http://schemas.openxmlformats.org/drawingml/2006/main">
               <a:ext uri="{FF2B5EF4-FFF2-40B4-BE49-F238E27FC236}">
-                <a16:creationId xmlns:a16="http://schemas.microsoft.com/office/drawing/2014/main" id="{083CF51E-2B24-4876-957C-8E6DF98020BD}"/>
+                <a16:creationId xmlns:a16="http://schemas.microsoft.com/office/drawing/2014/main" id="{31A74342-1D1E-4838-8F7C-B5D91E9968E3}"/>
               </a:ext>
             </a:extLst>
           </p:cNvPr>
@@ -18669,7 +18426,7 @@
           <p:cNvPr id="9" name="">
             <a:extLst xmlns:a="http://schemas.openxmlformats.org/drawingml/2006/main">
               <a:ext uri="{FF2B5EF4-FFF2-40B4-BE49-F238E27FC236}">
-                <a16:creationId xmlns:a16="http://schemas.microsoft.com/office/drawing/2014/main" id="{E262E805-E8CE-4053-8F07-06B74B572EE4}"/>
+                <a16:creationId xmlns:a16="http://schemas.microsoft.com/office/drawing/2014/main" id="{A4ACF0A1-6D3E-4FAF-809D-2D5F056D5808}"/>
               </a:ext>
             </a:extLst>
           </p:cNvPr>
@@ -18726,7 +18483,7 @@
           <p:cNvPr id="10" name="">
             <a:extLst xmlns:a="http://schemas.openxmlformats.org/drawingml/2006/main">
               <a:ext uri="{FF2B5EF4-FFF2-40B4-BE49-F238E27FC236}">
-                <a16:creationId xmlns:a16="http://schemas.microsoft.com/office/drawing/2014/main" id="{CF277423-05F8-4695-BF87-F59858C0F925}"/>
+                <a16:creationId xmlns:a16="http://schemas.microsoft.com/office/drawing/2014/main" id="{18C243CA-2396-4C58-A220-CDC5715CA777}"/>
               </a:ext>
             </a:extLst>
           </p:cNvPr>
@@ -18760,7 +18517,7 @@
           <p:cNvPr id="11" name="">
             <a:extLst xmlns:a="http://schemas.openxmlformats.org/drawingml/2006/main">
               <a:ext uri="{FF2B5EF4-FFF2-40B4-BE49-F238E27FC236}">
-                <a16:creationId xmlns:a16="http://schemas.microsoft.com/office/drawing/2014/main" id="{0672932D-DC3D-4E3C-9376-A7B577CCCE44}"/>
+                <a16:creationId xmlns:a16="http://schemas.microsoft.com/office/drawing/2014/main" id="{23FF4E3B-25A4-490C-9190-F39213394CDB}"/>
               </a:ext>
             </a:extLst>
           </p:cNvPr>
@@ -18792,7 +18549,7 @@
           <p:cNvPr id="12" name="">
             <a:extLst xmlns:a="http://schemas.openxmlformats.org/drawingml/2006/main">
               <a:ext uri="{FF2B5EF4-FFF2-40B4-BE49-F238E27FC236}">
-                <a16:creationId xmlns:a16="http://schemas.microsoft.com/office/drawing/2014/main" id="{9463B2EC-2CF6-4C65-A0E3-F308CEDE0114}"/>
+                <a16:creationId xmlns:a16="http://schemas.microsoft.com/office/drawing/2014/main" id="{DADC2894-EE04-41F6-AD2F-47384D32FE1D}"/>
               </a:ext>
             </a:extLst>
           </p:cNvPr>
@@ -18849,7 +18606,7 @@
           <p:cNvPr id="13" name="">
             <a:extLst xmlns:a="http://schemas.openxmlformats.org/drawingml/2006/main">
               <a:ext uri="{FF2B5EF4-FFF2-40B4-BE49-F238E27FC236}">
-                <a16:creationId xmlns:a16="http://schemas.microsoft.com/office/drawing/2014/main" id="{87AFEEE8-3B9A-493D-9D82-A3C8786535FD}"/>
+                <a16:creationId xmlns:a16="http://schemas.microsoft.com/office/drawing/2014/main" id="{449A2591-4B0C-496D-A73F-859524DDE6A6}"/>
               </a:ext>
             </a:extLst>
           </p:cNvPr>
@@ -18879,7 +18636,7 @@
           <p:cNvPr id="14" name="">
             <a:extLst xmlns:a="http://schemas.openxmlformats.org/drawingml/2006/main">
               <a:ext uri="{FF2B5EF4-FFF2-40B4-BE49-F238E27FC236}">
-                <a16:creationId xmlns:a16="http://schemas.microsoft.com/office/drawing/2014/main" id="{08B1F089-8204-4E30-89E2-D31540166A0D}"/>
+                <a16:creationId xmlns:a16="http://schemas.microsoft.com/office/drawing/2014/main" id="{CDE0C257-CC87-4F4D-9B17-A84F05155960}"/>
               </a:ext>
             </a:extLst>
           </p:cNvPr>
@@ -18936,7 +18693,7 @@
           <p:cNvPr id="15" name="">
             <a:extLst xmlns:a="http://schemas.openxmlformats.org/drawingml/2006/main">
               <a:ext uri="{FF2B5EF4-FFF2-40B4-BE49-F238E27FC236}">
-                <a16:creationId xmlns:a16="http://schemas.microsoft.com/office/drawing/2014/main" id="{21E40A25-12FD-4B0D-8607-164EEBF6C481}"/>
+                <a16:creationId xmlns:a16="http://schemas.microsoft.com/office/drawing/2014/main" id="{39AA49FE-391B-43CC-8D08-B2ADDAC455B6}"/>
               </a:ext>
             </a:extLst>
           </p:cNvPr>
@@ -18993,7 +18750,7 @@
           <p:cNvPr id="16" name="">
             <a:extLst xmlns:a="http://schemas.openxmlformats.org/drawingml/2006/main">
               <a:ext uri="{FF2B5EF4-FFF2-40B4-BE49-F238E27FC236}">
-                <a16:creationId xmlns:a16="http://schemas.microsoft.com/office/drawing/2014/main" id="{23C25D95-E116-4992-9052-90152E8CC38C}"/>
+                <a16:creationId xmlns:a16="http://schemas.microsoft.com/office/drawing/2014/main" id="{683A43C3-188E-4554-AAD1-996AE8BEC764}"/>
               </a:ext>
             </a:extLst>
           </p:cNvPr>
@@ -19023,7 +18780,7 @@
           <p:cNvPr id="17" name="">
             <a:extLst xmlns:a="http://schemas.openxmlformats.org/drawingml/2006/main">
               <a:ext uri="{FF2B5EF4-FFF2-40B4-BE49-F238E27FC236}">
-                <a16:creationId xmlns:a16="http://schemas.microsoft.com/office/drawing/2014/main" id="{43B3B937-DD55-49B0-9581-86F6B18ECCFD}"/>
+                <a16:creationId xmlns:a16="http://schemas.microsoft.com/office/drawing/2014/main" id="{86547290-AE22-452D-B38F-9368BD4B8793}"/>
               </a:ext>
             </a:extLst>
           </p:cNvPr>
@@ -19053,7 +18810,7 @@
           <p:cNvPr id="18" name="">
             <a:extLst xmlns:a="http://schemas.openxmlformats.org/drawingml/2006/main">
               <a:ext uri="{FF2B5EF4-FFF2-40B4-BE49-F238E27FC236}">
-                <a16:creationId xmlns:a16="http://schemas.microsoft.com/office/drawing/2014/main" id="{E75F63D4-5C15-4FBD-93AA-BAC4BEE1A19C}"/>
+                <a16:creationId xmlns:a16="http://schemas.microsoft.com/office/drawing/2014/main" id="{6561E18E-C1D9-4CD0-AD84-9079B46BF122}"/>
               </a:ext>
             </a:extLst>
           </p:cNvPr>
@@ -19110,7 +18867,7 @@
           <p:cNvPr id="19" name="">
             <a:extLst xmlns:a="http://schemas.openxmlformats.org/drawingml/2006/main">
               <a:ext uri="{FF2B5EF4-FFF2-40B4-BE49-F238E27FC236}">
-                <a16:creationId xmlns:a16="http://schemas.microsoft.com/office/drawing/2014/main" id="{265C39E5-E475-4309-B023-DD9979D75FBE}"/>
+                <a16:creationId xmlns:a16="http://schemas.microsoft.com/office/drawing/2014/main" id="{59628E3A-DCF9-433B-9F8B-C6AF4A8C9F3A}"/>
               </a:ext>
             </a:extLst>
           </p:cNvPr>
@@ -19167,7 +18924,7 @@
           <p:cNvPr id="20" name="">
             <a:extLst xmlns:a="http://schemas.openxmlformats.org/drawingml/2006/main">
               <a:ext uri="{FF2B5EF4-FFF2-40B4-BE49-F238E27FC236}">
-                <a16:creationId xmlns:a16="http://schemas.microsoft.com/office/drawing/2014/main" id="{3E542497-F5C3-4C6B-918E-0EDA4E7D5B58}"/>
+                <a16:creationId xmlns:a16="http://schemas.microsoft.com/office/drawing/2014/main" id="{F458CBD3-C74E-408C-B19C-57D4285A5E10}"/>
               </a:ext>
             </a:extLst>
           </p:cNvPr>
@@ -19197,7 +18954,7 @@
           <p:cNvPr id="21" name="">
             <a:extLst xmlns:a="http://schemas.openxmlformats.org/drawingml/2006/main">
               <a:ext uri="{FF2B5EF4-FFF2-40B4-BE49-F238E27FC236}">
-                <a16:creationId xmlns:a16="http://schemas.microsoft.com/office/drawing/2014/main" id="{84FF70DF-C73E-4981-8F7D-1600D13A8D05}"/>
+                <a16:creationId xmlns:a16="http://schemas.microsoft.com/office/drawing/2014/main" id="{81081362-D6EF-4240-8A98-B5304178FFAA}"/>
               </a:ext>
             </a:extLst>
           </p:cNvPr>
@@ -19227,7 +18984,7 @@
           <p:cNvPr id="22" name="">
             <a:extLst xmlns:a="http://schemas.openxmlformats.org/drawingml/2006/main">
               <a:ext uri="{FF2B5EF4-FFF2-40B4-BE49-F238E27FC236}">
-                <a16:creationId xmlns:a16="http://schemas.microsoft.com/office/drawing/2014/main" id="{36BE12A3-61B7-4A00-A7E3-61EABD7C5311}"/>
+                <a16:creationId xmlns:a16="http://schemas.microsoft.com/office/drawing/2014/main" id="{8A81EE89-AACC-4EA8-B13C-CC2157D52376}"/>
               </a:ext>
             </a:extLst>
           </p:cNvPr>
@@ -19284,7 +19041,7 @@
           <p:cNvPr id="23" name="">
             <a:extLst xmlns:a="http://schemas.openxmlformats.org/drawingml/2006/main">
               <a:ext uri="{FF2B5EF4-FFF2-40B4-BE49-F238E27FC236}">
-                <a16:creationId xmlns:a16="http://schemas.microsoft.com/office/drawing/2014/main" id="{9D8706F7-B474-4B6D-9054-1308FDC04EC5}"/>
+                <a16:creationId xmlns:a16="http://schemas.microsoft.com/office/drawing/2014/main" id="{9CDB4531-0337-4911-BFB9-EF2DE7844B16}"/>
               </a:ext>
             </a:extLst>
           </p:cNvPr>
@@ -19341,7 +19098,7 @@
           <p:cNvPr id="24" name="">
             <a:extLst xmlns:a="http://schemas.openxmlformats.org/drawingml/2006/main">
               <a:ext uri="{FF2B5EF4-FFF2-40B4-BE49-F238E27FC236}">
-                <a16:creationId xmlns:a16="http://schemas.microsoft.com/office/drawing/2014/main" id="{BB27F7C3-8136-4643-91E7-8A31C384837D}"/>
+                <a16:creationId xmlns:a16="http://schemas.microsoft.com/office/drawing/2014/main" id="{37962D6E-C96B-4EBA-9456-981BF1848EA5}"/>
               </a:ext>
             </a:extLst>
           </p:cNvPr>
@@ -19371,7 +19128,7 @@
           <p:cNvPr id="25" name="">
             <a:extLst xmlns:a="http://schemas.openxmlformats.org/drawingml/2006/main">
               <a:ext uri="{FF2B5EF4-FFF2-40B4-BE49-F238E27FC236}">
-                <a16:creationId xmlns:a16="http://schemas.microsoft.com/office/drawing/2014/main" id="{FD6207B3-971A-4239-B0AF-E5CACA5C2304}"/>
+                <a16:creationId xmlns:a16="http://schemas.microsoft.com/office/drawing/2014/main" id="{5C9BC7E5-C3B3-449B-8C3B-C54E3FDF923D}"/>
               </a:ext>
             </a:extLst>
           </p:cNvPr>
@@ -19401,7 +19158,7 @@
           <p:cNvPr id="26" name="">
             <a:extLst xmlns:a="http://schemas.openxmlformats.org/drawingml/2006/main">
               <a:ext uri="{FF2B5EF4-FFF2-40B4-BE49-F238E27FC236}">
-                <a16:creationId xmlns:a16="http://schemas.microsoft.com/office/drawing/2014/main" id="{1830D9FF-842D-4CDE-AAE2-67BD6FD89778}"/>
+                <a16:creationId xmlns:a16="http://schemas.microsoft.com/office/drawing/2014/main" id="{C209B651-9CB2-4B7E-85CC-C0BE44DDA387}"/>
               </a:ext>
             </a:extLst>
           </p:cNvPr>
@@ -19458,7 +19215,7 @@
           <p:cNvPr id="27" name="">
             <a:extLst xmlns:a="http://schemas.openxmlformats.org/drawingml/2006/main">
               <a:ext uri="{FF2B5EF4-FFF2-40B4-BE49-F238E27FC236}">
-                <a16:creationId xmlns:a16="http://schemas.microsoft.com/office/drawing/2014/main" id="{113EE1BF-C6AD-4466-8BA9-C9EBEE2B3935}"/>
+                <a16:creationId xmlns:a16="http://schemas.microsoft.com/office/drawing/2014/main" id="{E1C30490-574E-4A05-8D75-903CC586A5CD}"/>
               </a:ext>
             </a:extLst>
           </p:cNvPr>
@@ -19515,7 +19272,7 @@
           <p:cNvPr id="28" name="">
             <a:extLst xmlns:a="http://schemas.openxmlformats.org/drawingml/2006/main">
               <a:ext uri="{FF2B5EF4-FFF2-40B4-BE49-F238E27FC236}">
-                <a16:creationId xmlns:a16="http://schemas.microsoft.com/office/drawing/2014/main" id="{36D0CC69-9371-4857-B9DB-3B2E6F48236E}"/>
+                <a16:creationId xmlns:a16="http://schemas.microsoft.com/office/drawing/2014/main" id="{F9F67A06-7D68-4310-A122-AF88E640D753}"/>
               </a:ext>
             </a:extLst>
           </p:cNvPr>
@@ -19549,7 +19306,7 @@
           <p:cNvPr id="29" name="">
             <a:extLst xmlns:a="http://schemas.openxmlformats.org/drawingml/2006/main">
               <a:ext uri="{FF2B5EF4-FFF2-40B4-BE49-F238E27FC236}">
-                <a16:creationId xmlns:a16="http://schemas.microsoft.com/office/drawing/2014/main" id="{EF076638-832A-464F-8306-72B857502311}"/>
+                <a16:creationId xmlns:a16="http://schemas.microsoft.com/office/drawing/2014/main" id="{74BF545B-97B7-4E87-9375-49EBDEE43B78}"/>
               </a:ext>
             </a:extLst>
           </p:cNvPr>
@@ -19581,7 +19338,7 @@
           <p:cNvPr id="30" name="">
             <a:extLst xmlns:a="http://schemas.openxmlformats.org/drawingml/2006/main">
               <a:ext uri="{FF2B5EF4-FFF2-40B4-BE49-F238E27FC236}">
-                <a16:creationId xmlns:a16="http://schemas.microsoft.com/office/drawing/2014/main" id="{037CE954-40BF-47B3-9925-41081A81A482}"/>
+                <a16:creationId xmlns:a16="http://schemas.microsoft.com/office/drawing/2014/main" id="{3F322001-4A25-4D6D-95DD-5789EE732305}"/>
               </a:ext>
             </a:extLst>
           </p:cNvPr>
@@ -19638,7 +19395,7 @@
           <p:cNvPr id="31" name="">
             <a:extLst xmlns:a="http://schemas.openxmlformats.org/drawingml/2006/main">
               <a:ext uri="{FF2B5EF4-FFF2-40B4-BE49-F238E27FC236}">
-                <a16:creationId xmlns:a16="http://schemas.microsoft.com/office/drawing/2014/main" id="{EAC6423A-5D37-4D2E-B48D-AA4B83F81EE0}"/>
+                <a16:creationId xmlns:a16="http://schemas.microsoft.com/office/drawing/2014/main" id="{44B939A3-299A-47EC-A3D4-B382E57768D0}"/>
               </a:ext>
             </a:extLst>
           </p:cNvPr>
@@ -19668,7 +19425,7 @@
           <p:cNvPr id="32" name="">
             <a:extLst xmlns:a="http://schemas.openxmlformats.org/drawingml/2006/main">
               <a:ext uri="{FF2B5EF4-FFF2-40B4-BE49-F238E27FC236}">
-                <a16:creationId xmlns:a16="http://schemas.microsoft.com/office/drawing/2014/main" id="{BC3435B9-173D-49CB-BA23-87FE0D68C096}"/>
+                <a16:creationId xmlns:a16="http://schemas.microsoft.com/office/drawing/2014/main" id="{6CAA5796-F9B8-430B-9D2E-DE8C87AD1B28}"/>
               </a:ext>
             </a:extLst>
           </p:cNvPr>
@@ -19725,7 +19482,7 @@
           <p:cNvPr id="33" name="">
             <a:extLst xmlns:a="http://schemas.openxmlformats.org/drawingml/2006/main">
               <a:ext uri="{FF2B5EF4-FFF2-40B4-BE49-F238E27FC236}">
-                <a16:creationId xmlns:a16="http://schemas.microsoft.com/office/drawing/2014/main" id="{24F64884-12AE-40CF-96BD-3D2BA8BBB388}"/>
+                <a16:creationId xmlns:a16="http://schemas.microsoft.com/office/drawing/2014/main" id="{F86C0C95-CD95-4140-B932-3ED33FDBCA92}"/>
               </a:ext>
             </a:extLst>
           </p:cNvPr>
@@ -19782,7 +19539,7 @@
           <p:cNvPr id="34" name="">
             <a:extLst xmlns:a="http://schemas.openxmlformats.org/drawingml/2006/main">
               <a:ext uri="{FF2B5EF4-FFF2-40B4-BE49-F238E27FC236}">
-                <a16:creationId xmlns:a16="http://schemas.microsoft.com/office/drawing/2014/main" id="{4C401A60-5CFC-4C9D-AA9E-70A9477BF6CA}"/>
+                <a16:creationId xmlns:a16="http://schemas.microsoft.com/office/drawing/2014/main" id="{6F03EF9A-95AA-4BA6-A110-1C5EC10AE935}"/>
               </a:ext>
             </a:extLst>
           </p:cNvPr>
@@ -19812,7 +19569,7 @@
           <p:cNvPr id="35" name="">
             <a:extLst xmlns:a="http://schemas.openxmlformats.org/drawingml/2006/main">
               <a:ext uri="{FF2B5EF4-FFF2-40B4-BE49-F238E27FC236}">
-                <a16:creationId xmlns:a16="http://schemas.microsoft.com/office/drawing/2014/main" id="{0C60BE9A-276E-448A-8FA2-F9048EE0C606}"/>
+                <a16:creationId xmlns:a16="http://schemas.microsoft.com/office/drawing/2014/main" id="{9777175A-FA70-4BC9-A012-6077E4BDD42E}"/>
               </a:ext>
             </a:extLst>
           </p:cNvPr>
@@ -19842,7 +19599,7 @@
           <p:cNvPr id="36" name="">
             <a:extLst xmlns:a="http://schemas.openxmlformats.org/drawingml/2006/main">
               <a:ext uri="{FF2B5EF4-FFF2-40B4-BE49-F238E27FC236}">
-                <a16:creationId xmlns:a16="http://schemas.microsoft.com/office/drawing/2014/main" id="{F0EEA83B-2F04-4B26-BA2D-1AE6D118E63E}"/>
+                <a16:creationId xmlns:a16="http://schemas.microsoft.com/office/drawing/2014/main" id="{5FA9775C-DF43-4EEF-BE75-940A4A8D558A}"/>
               </a:ext>
             </a:extLst>
           </p:cNvPr>
@@ -19899,7 +19656,7 @@
           <p:cNvPr id="37" name="">
             <a:extLst xmlns:a="http://schemas.openxmlformats.org/drawingml/2006/main">
               <a:ext uri="{FF2B5EF4-FFF2-40B4-BE49-F238E27FC236}">
-                <a16:creationId xmlns:a16="http://schemas.microsoft.com/office/drawing/2014/main" id="{96EEE566-0D57-43C1-98D7-BCCF0E64AB6C}"/>
+                <a16:creationId xmlns:a16="http://schemas.microsoft.com/office/drawing/2014/main" id="{AF181F74-5D5B-44D2-BBC5-D26437867081}"/>
               </a:ext>
             </a:extLst>
           </p:cNvPr>
@@ -19956,7 +19713,7 @@
           <p:cNvPr id="38" name="">
             <a:extLst xmlns:a="http://schemas.openxmlformats.org/drawingml/2006/main">
               <a:ext uri="{FF2B5EF4-FFF2-40B4-BE49-F238E27FC236}">
-                <a16:creationId xmlns:a16="http://schemas.microsoft.com/office/drawing/2014/main" id="{0BCFAAA6-F59B-481A-A229-4E378BFE34A5}"/>
+                <a16:creationId xmlns:a16="http://schemas.microsoft.com/office/drawing/2014/main" id="{BA4024D3-B67F-4541-B091-AC7B4E75D80C}"/>
               </a:ext>
             </a:extLst>
           </p:cNvPr>
@@ -19986,7 +19743,7 @@
           <p:cNvPr id="39" name="">
             <a:extLst xmlns:a="http://schemas.openxmlformats.org/drawingml/2006/main">
               <a:ext uri="{FF2B5EF4-FFF2-40B4-BE49-F238E27FC236}">
-                <a16:creationId xmlns:a16="http://schemas.microsoft.com/office/drawing/2014/main" id="{D44FA3E2-AED4-4247-850E-9DC347718C40}"/>
+                <a16:creationId xmlns:a16="http://schemas.microsoft.com/office/drawing/2014/main" id="{9E7E8574-9AC5-4FB2-B92C-D008130ECA09}"/>
               </a:ext>
             </a:extLst>
           </p:cNvPr>
@@ -20016,7 +19773,7 @@
           <p:cNvPr id="40" name="">
             <a:extLst xmlns:a="http://schemas.openxmlformats.org/drawingml/2006/main">
               <a:ext uri="{FF2B5EF4-FFF2-40B4-BE49-F238E27FC236}">
-                <a16:creationId xmlns:a16="http://schemas.microsoft.com/office/drawing/2014/main" id="{4A0FE0BD-7756-4DDB-BDC4-13C8028EBBD8}"/>
+                <a16:creationId xmlns:a16="http://schemas.microsoft.com/office/drawing/2014/main" id="{55B7F80F-C9C3-4003-99C7-49C6EF632B79}"/>
               </a:ext>
             </a:extLst>
           </p:cNvPr>
@@ -20073,7 +19830,7 @@
           <p:cNvPr id="41" name="">
             <a:extLst xmlns:a="http://schemas.openxmlformats.org/drawingml/2006/main">
               <a:ext uri="{FF2B5EF4-FFF2-40B4-BE49-F238E27FC236}">
-                <a16:creationId xmlns:a16="http://schemas.microsoft.com/office/drawing/2014/main" id="{97ECDC93-BC7E-4D2E-BC40-B1A00BED3C4F}"/>
+                <a16:creationId xmlns:a16="http://schemas.microsoft.com/office/drawing/2014/main" id="{EC394A0B-2ECE-4AEB-B269-2D31B6667FAA}"/>
               </a:ext>
             </a:extLst>
           </p:cNvPr>
@@ -20130,7 +19887,7 @@
           <p:cNvPr id="42" name="">
             <a:extLst xmlns:a="http://schemas.openxmlformats.org/drawingml/2006/main">
               <a:ext uri="{FF2B5EF4-FFF2-40B4-BE49-F238E27FC236}">
-                <a16:creationId xmlns:a16="http://schemas.microsoft.com/office/drawing/2014/main" id="{A975BC29-E365-4B95-8EE5-6D05A5C0C6B4}"/>
+                <a16:creationId xmlns:a16="http://schemas.microsoft.com/office/drawing/2014/main" id="{8DC41317-485B-4F0C-BDAD-BD5DBEBB75D7}"/>
               </a:ext>
             </a:extLst>
           </p:cNvPr>
@@ -20160,7 +19917,7 @@
           <p:cNvPr id="43" name="">
             <a:extLst xmlns:a="http://schemas.openxmlformats.org/drawingml/2006/main">
               <a:ext uri="{FF2B5EF4-FFF2-40B4-BE49-F238E27FC236}">
-                <a16:creationId xmlns:a16="http://schemas.microsoft.com/office/drawing/2014/main" id="{A35B8A8F-C134-44A2-AAFB-D7A841B9E55C}"/>
+                <a16:creationId xmlns:a16="http://schemas.microsoft.com/office/drawing/2014/main" id="{BAEABE23-6F4F-45E2-8352-AD0EF1D8E0C5}"/>
               </a:ext>
             </a:extLst>
           </p:cNvPr>
@@ -20190,7 +19947,7 @@
           <p:cNvPr id="44" name="">
             <a:extLst xmlns:a="http://schemas.openxmlformats.org/drawingml/2006/main">
               <a:ext uri="{FF2B5EF4-FFF2-40B4-BE49-F238E27FC236}">
-                <a16:creationId xmlns:a16="http://schemas.microsoft.com/office/drawing/2014/main" id="{4C0AC794-2E4F-4BFE-99BB-5462E30328D4}"/>
+                <a16:creationId xmlns:a16="http://schemas.microsoft.com/office/drawing/2014/main" id="{E51B01EA-EE74-4B13-88D1-F88E96B13B51}"/>
               </a:ext>
             </a:extLst>
           </p:cNvPr>
@@ -20247,7 +20004,7 @@
           <p:cNvPr id="45" name="">
             <a:extLst xmlns:a="http://schemas.openxmlformats.org/drawingml/2006/main">
               <a:ext uri="{FF2B5EF4-FFF2-40B4-BE49-F238E27FC236}">
-                <a16:creationId xmlns:a16="http://schemas.microsoft.com/office/drawing/2014/main" id="{30B9B0F2-4BA6-4CA5-ADC7-CD8260890FF5}"/>
+                <a16:creationId xmlns:a16="http://schemas.microsoft.com/office/drawing/2014/main" id="{A1161A15-ECE7-48B0-814A-00507E7DF412}"/>
               </a:ext>
             </a:extLst>
           </p:cNvPr>
@@ -20304,7 +20061,7 @@
           <p:cNvPr id="46" name="">
             <a:extLst xmlns:a="http://schemas.openxmlformats.org/drawingml/2006/main">
               <a:ext uri="{FF2B5EF4-FFF2-40B4-BE49-F238E27FC236}">
-                <a16:creationId xmlns:a16="http://schemas.microsoft.com/office/drawing/2014/main" id="{80ADA3C4-17AE-49FB-8197-63AD0C5B6ECB}"/>
+                <a16:creationId xmlns:a16="http://schemas.microsoft.com/office/drawing/2014/main" id="{0EA7C6C8-B0F2-424B-A27E-439BB595AA6E}"/>
               </a:ext>
             </a:extLst>
           </p:cNvPr>
@@ -20338,7 +20095,7 @@
           <p:cNvPr id="47" name="">
             <a:extLst xmlns:a="http://schemas.openxmlformats.org/drawingml/2006/main">
               <a:ext uri="{FF2B5EF4-FFF2-40B4-BE49-F238E27FC236}">
-                <a16:creationId xmlns:a16="http://schemas.microsoft.com/office/drawing/2014/main" id="{B0263A04-FDDC-4FD4-9800-A3F76535473F}"/>
+                <a16:creationId xmlns:a16="http://schemas.microsoft.com/office/drawing/2014/main" id="{E059E019-8053-4CDC-B271-2961E9C47049}"/>
               </a:ext>
             </a:extLst>
           </p:cNvPr>
@@ -20370,7 +20127,7 @@
           <p:cNvPr id="48" name="">
             <a:extLst xmlns:a="http://schemas.openxmlformats.org/drawingml/2006/main">
               <a:ext uri="{FF2B5EF4-FFF2-40B4-BE49-F238E27FC236}">
-                <a16:creationId xmlns:a16="http://schemas.microsoft.com/office/drawing/2014/main" id="{367399CD-C5C6-44B0-B585-0DE34630E5FF}"/>
+                <a16:creationId xmlns:a16="http://schemas.microsoft.com/office/drawing/2014/main" id="{DB3C5F02-7AE3-42C9-B3F5-4767DE067FC0}"/>
               </a:ext>
             </a:extLst>
           </p:cNvPr>
@@ -20427,7 +20184,7 @@
           <p:cNvPr id="49" name="">
             <a:extLst xmlns:a="http://schemas.openxmlformats.org/drawingml/2006/main">
               <a:ext uri="{FF2B5EF4-FFF2-40B4-BE49-F238E27FC236}">
-                <a16:creationId xmlns:a16="http://schemas.microsoft.com/office/drawing/2014/main" id="{6E865DDC-4F24-454A-A6D4-E1800FB4C46B}"/>
+                <a16:creationId xmlns:a16="http://schemas.microsoft.com/office/drawing/2014/main" id="{FFB182C5-84C5-4A34-9866-6D422278245C}"/>
               </a:ext>
             </a:extLst>
           </p:cNvPr>
@@ -20457,7 +20214,7 @@
           <p:cNvPr id="50" name="">
             <a:extLst xmlns:a="http://schemas.openxmlformats.org/drawingml/2006/main">
               <a:ext uri="{FF2B5EF4-FFF2-40B4-BE49-F238E27FC236}">
-                <a16:creationId xmlns:a16="http://schemas.microsoft.com/office/drawing/2014/main" id="{1AC893B6-A8F1-448C-8978-12595A7233BD}"/>
+                <a16:creationId xmlns:a16="http://schemas.microsoft.com/office/drawing/2014/main" id="{DC21220C-DC6D-4785-8BB5-1372739C63EB}"/>
               </a:ext>
             </a:extLst>
           </p:cNvPr>
@@ -20514,7 +20271,7 @@
           <p:cNvPr id="51" name="">
             <a:extLst xmlns:a="http://schemas.openxmlformats.org/drawingml/2006/main">
               <a:ext uri="{FF2B5EF4-FFF2-40B4-BE49-F238E27FC236}">
-                <a16:creationId xmlns:a16="http://schemas.microsoft.com/office/drawing/2014/main" id="{0B5DD81F-DB44-44C0-B09E-3CB8F8C3A0F0}"/>
+                <a16:creationId xmlns:a16="http://schemas.microsoft.com/office/drawing/2014/main" id="{CCFD2D38-FCB5-4942-A7A6-948C144675F9}"/>
               </a:ext>
             </a:extLst>
           </p:cNvPr>
@@ -20571,7 +20328,7 @@
           <p:cNvPr id="52" name="">
             <a:extLst xmlns:a="http://schemas.openxmlformats.org/drawingml/2006/main">
               <a:ext uri="{FF2B5EF4-FFF2-40B4-BE49-F238E27FC236}">
-                <a16:creationId xmlns:a16="http://schemas.microsoft.com/office/drawing/2014/main" id="{2EDB7115-81D9-49F7-9283-614392D8BA2B}"/>
+                <a16:creationId xmlns:a16="http://schemas.microsoft.com/office/drawing/2014/main" id="{F89BF5C2-A4FB-4DFA-A168-9DC26D7D7729}"/>
               </a:ext>
             </a:extLst>
           </p:cNvPr>
@@ -20601,7 +20358,7 @@
           <p:cNvPr id="53" name="">
             <a:extLst xmlns:a="http://schemas.openxmlformats.org/drawingml/2006/main">
               <a:ext uri="{FF2B5EF4-FFF2-40B4-BE49-F238E27FC236}">
-                <a16:creationId xmlns:a16="http://schemas.microsoft.com/office/drawing/2014/main" id="{48EF6381-8746-42E3-98B2-04995CBA6D08}"/>
+                <a16:creationId xmlns:a16="http://schemas.microsoft.com/office/drawing/2014/main" id="{CCAB4E66-87DA-474F-B168-EA4CAC35A2A8}"/>
               </a:ext>
             </a:extLst>
           </p:cNvPr>
@@ -20631,7 +20388,7 @@
           <p:cNvPr id="54" name="">
             <a:extLst xmlns:a="http://schemas.openxmlformats.org/drawingml/2006/main">
               <a:ext uri="{FF2B5EF4-FFF2-40B4-BE49-F238E27FC236}">
-                <a16:creationId xmlns:a16="http://schemas.microsoft.com/office/drawing/2014/main" id="{F6DDBE33-3E31-45AD-AB76-4F2E2020E459}"/>
+                <a16:creationId xmlns:a16="http://schemas.microsoft.com/office/drawing/2014/main" id="{829A4576-FD8D-449E-942C-EC049C8D54DB}"/>
               </a:ext>
             </a:extLst>
           </p:cNvPr>
@@ -20688,7 +20445,7 @@
           <p:cNvPr id="55" name="">
             <a:extLst xmlns:a="http://schemas.openxmlformats.org/drawingml/2006/main">
               <a:ext uri="{FF2B5EF4-FFF2-40B4-BE49-F238E27FC236}">
-                <a16:creationId xmlns:a16="http://schemas.microsoft.com/office/drawing/2014/main" id="{AD560D29-AB97-4B46-9560-0E666D81196D}"/>
+                <a16:creationId xmlns:a16="http://schemas.microsoft.com/office/drawing/2014/main" id="{BEE96A47-E1A5-45DB-99D0-7026CA8C2C11}"/>
               </a:ext>
             </a:extLst>
           </p:cNvPr>
@@ -20745,7 +20502,7 @@
           <p:cNvPr id="56" name="">
             <a:extLst xmlns:a="http://schemas.openxmlformats.org/drawingml/2006/main">
               <a:ext uri="{FF2B5EF4-FFF2-40B4-BE49-F238E27FC236}">
-                <a16:creationId xmlns:a16="http://schemas.microsoft.com/office/drawing/2014/main" id="{16A3A938-4FA2-47AE-BAD7-996AD29FB171}"/>
+                <a16:creationId xmlns:a16="http://schemas.microsoft.com/office/drawing/2014/main" id="{33CCBD67-E085-42EB-AB4B-F24D92B16FC4}"/>
               </a:ext>
             </a:extLst>
           </p:cNvPr>
@@ -20775,7 +20532,7 @@
           <p:cNvPr id="57" name="">
             <a:extLst xmlns:a="http://schemas.openxmlformats.org/drawingml/2006/main">
               <a:ext uri="{FF2B5EF4-FFF2-40B4-BE49-F238E27FC236}">
-                <a16:creationId xmlns:a16="http://schemas.microsoft.com/office/drawing/2014/main" id="{0D893F55-74E8-4DA2-A249-D38A42BF607B}"/>
+                <a16:creationId xmlns:a16="http://schemas.microsoft.com/office/drawing/2014/main" id="{4E46334F-F3EC-4298-9832-4BD4CD352FB1}"/>
               </a:ext>
             </a:extLst>
           </p:cNvPr>
@@ -20805,7 +20562,7 @@
           <p:cNvPr id="58" name="">
             <a:extLst xmlns:a="http://schemas.openxmlformats.org/drawingml/2006/main">
               <a:ext uri="{FF2B5EF4-FFF2-40B4-BE49-F238E27FC236}">
-                <a16:creationId xmlns:a16="http://schemas.microsoft.com/office/drawing/2014/main" id="{56EB5687-5B55-45E1-A500-91BD4E1339B5}"/>
+                <a16:creationId xmlns:a16="http://schemas.microsoft.com/office/drawing/2014/main" id="{6ACB17F6-544C-42FF-8850-C58695D2ECD6}"/>
               </a:ext>
             </a:extLst>
           </p:cNvPr>
@@ -20862,7 +20619,7 @@
           <p:cNvPr id="59" name="">
             <a:extLst xmlns:a="http://schemas.openxmlformats.org/drawingml/2006/main">
               <a:ext uri="{FF2B5EF4-FFF2-40B4-BE49-F238E27FC236}">
-                <a16:creationId xmlns:a16="http://schemas.microsoft.com/office/drawing/2014/main" id="{26C961B2-1DDD-4BEA-BFE8-4C9D9EB18FF4}"/>
+                <a16:creationId xmlns:a16="http://schemas.microsoft.com/office/drawing/2014/main" id="{03E1AAD5-B9D5-4B3E-AF62-326E3FC05389}"/>
               </a:ext>
             </a:extLst>
           </p:cNvPr>
@@ -20919,7 +20676,7 @@
           <p:cNvPr id="60" name="">
             <a:extLst xmlns:a="http://schemas.openxmlformats.org/drawingml/2006/main">
               <a:ext uri="{FF2B5EF4-FFF2-40B4-BE49-F238E27FC236}">
-                <a16:creationId xmlns:a16="http://schemas.microsoft.com/office/drawing/2014/main" id="{F283761A-4459-489E-833F-C079901C10F4}"/>
+                <a16:creationId xmlns:a16="http://schemas.microsoft.com/office/drawing/2014/main" id="{4BD7A600-D956-4AC3-A182-56E4CB801E41}"/>
               </a:ext>
             </a:extLst>
           </p:cNvPr>
@@ -20949,7 +20706,7 @@
           <p:cNvPr id="61" name="">
             <a:extLst xmlns:a="http://schemas.openxmlformats.org/drawingml/2006/main">
               <a:ext uri="{FF2B5EF4-FFF2-40B4-BE49-F238E27FC236}">
-                <a16:creationId xmlns:a16="http://schemas.microsoft.com/office/drawing/2014/main" id="{D8299B27-9EDB-4F9E-9404-0BCD969501D8}"/>
+                <a16:creationId xmlns:a16="http://schemas.microsoft.com/office/drawing/2014/main" id="{75707B38-4E81-4C83-BD4F-78CB1C55932A}"/>
               </a:ext>
             </a:extLst>
           </p:cNvPr>
@@ -20979,7 +20736,7 @@
           <p:cNvPr id="62" name="">
             <a:extLst xmlns:a="http://schemas.openxmlformats.org/drawingml/2006/main">
               <a:ext uri="{FF2B5EF4-FFF2-40B4-BE49-F238E27FC236}">
-                <a16:creationId xmlns:a16="http://schemas.microsoft.com/office/drawing/2014/main" id="{A9E88439-317D-4E3D-9F31-BF91B9F619E6}"/>
+                <a16:creationId xmlns:a16="http://schemas.microsoft.com/office/drawing/2014/main" id="{EAACDC88-30C1-4030-9821-4B02B3E30D14}"/>
               </a:ext>
             </a:extLst>
           </p:cNvPr>
@@ -21036,7 +20793,7 @@
           <p:cNvPr id="63" name="">
             <a:extLst xmlns:a="http://schemas.openxmlformats.org/drawingml/2006/main">
               <a:ext uri="{FF2B5EF4-FFF2-40B4-BE49-F238E27FC236}">
-                <a16:creationId xmlns:a16="http://schemas.microsoft.com/office/drawing/2014/main" id="{54B90D68-C3DE-460A-AFD5-34D60D4328E1}"/>
+                <a16:creationId xmlns:a16="http://schemas.microsoft.com/office/drawing/2014/main" id="{D2D09B8F-1931-4606-9D60-776C5A4EDA79}"/>
               </a:ext>
             </a:extLst>
           </p:cNvPr>
@@ -21093,7 +20850,7 @@
           <p:cNvPr id="64" name="">
             <a:extLst xmlns:a="http://schemas.openxmlformats.org/drawingml/2006/main">
               <a:ext uri="{FF2B5EF4-FFF2-40B4-BE49-F238E27FC236}">
-                <a16:creationId xmlns:a16="http://schemas.microsoft.com/office/drawing/2014/main" id="{9D367B6A-94A5-4163-8E3D-75EAC06BB4D9}"/>
+                <a16:creationId xmlns:a16="http://schemas.microsoft.com/office/drawing/2014/main" id="{C94B8140-18CC-4837-B727-BEEB135B5A5B}"/>
               </a:ext>
             </a:extLst>
           </p:cNvPr>
@@ -21127,7 +20884,7 @@
           <p:cNvPr id="65" name="">
             <a:extLst xmlns:a="http://schemas.openxmlformats.org/drawingml/2006/main">
               <a:ext uri="{FF2B5EF4-FFF2-40B4-BE49-F238E27FC236}">
-                <a16:creationId xmlns:a16="http://schemas.microsoft.com/office/drawing/2014/main" id="{A24CBD81-BC29-4281-BAE5-8F31F2881B29}"/>
+                <a16:creationId xmlns:a16="http://schemas.microsoft.com/office/drawing/2014/main" id="{C37C0A84-C8A2-4994-B035-E1081439601E}"/>
               </a:ext>
             </a:extLst>
           </p:cNvPr>
@@ -21159,7 +20916,7 @@
           <p:cNvPr id="66" name="">
             <a:extLst xmlns:a="http://schemas.openxmlformats.org/drawingml/2006/main">
               <a:ext uri="{FF2B5EF4-FFF2-40B4-BE49-F238E27FC236}">
-                <a16:creationId xmlns:a16="http://schemas.microsoft.com/office/drawing/2014/main" id="{21A4F1A4-EF97-4CA9-9065-297270E24C0C}"/>
+                <a16:creationId xmlns:a16="http://schemas.microsoft.com/office/drawing/2014/main" id="{E4B3CD79-63C5-4A81-B1B5-E322E3ADDDCC}"/>
               </a:ext>
             </a:extLst>
           </p:cNvPr>
@@ -21216,7 +20973,7 @@
           <p:cNvPr id="67" name="">
             <a:extLst xmlns:a="http://schemas.openxmlformats.org/drawingml/2006/main">
               <a:ext uri="{FF2B5EF4-FFF2-40B4-BE49-F238E27FC236}">
-                <a16:creationId xmlns:a16="http://schemas.microsoft.com/office/drawing/2014/main" id="{24DF1322-0159-4ED1-9000-E8434DD335B7}"/>
+                <a16:creationId xmlns:a16="http://schemas.microsoft.com/office/drawing/2014/main" id="{7520CEA0-430B-4CE1-96CE-09F590F2AE97}"/>
               </a:ext>
             </a:extLst>
           </p:cNvPr>
@@ -21246,7 +21003,7 @@
           <p:cNvPr id="68" name="">
             <a:extLst xmlns:a="http://schemas.openxmlformats.org/drawingml/2006/main">
               <a:ext uri="{FF2B5EF4-FFF2-40B4-BE49-F238E27FC236}">
-                <a16:creationId xmlns:a16="http://schemas.microsoft.com/office/drawing/2014/main" id="{84B79A1D-F40D-4F2E-907D-B6160068766A}"/>
+                <a16:creationId xmlns:a16="http://schemas.microsoft.com/office/drawing/2014/main" id="{BE1C2114-C093-47CD-9E80-BFE19517044D}"/>
               </a:ext>
             </a:extLst>
           </p:cNvPr>
@@ -21303,7 +21060,7 @@
           <p:cNvPr id="69" name="">
             <a:extLst xmlns:a="http://schemas.openxmlformats.org/drawingml/2006/main">
               <a:ext uri="{FF2B5EF4-FFF2-40B4-BE49-F238E27FC236}">
-                <a16:creationId xmlns:a16="http://schemas.microsoft.com/office/drawing/2014/main" id="{ED5441CE-37D3-4641-AD83-59964449D6B9}"/>
+                <a16:creationId xmlns:a16="http://schemas.microsoft.com/office/drawing/2014/main" id="{AC5E4B87-8133-45EF-827F-E01000883FFC}"/>
               </a:ext>
             </a:extLst>
           </p:cNvPr>
@@ -21360,7 +21117,7 @@
           <p:cNvPr id="70" name="">
             <a:extLst xmlns:a="http://schemas.openxmlformats.org/drawingml/2006/main">
               <a:ext uri="{FF2B5EF4-FFF2-40B4-BE49-F238E27FC236}">
-                <a16:creationId xmlns:a16="http://schemas.microsoft.com/office/drawing/2014/main" id="{45B4D4FF-9DBA-4020-ADC4-79C4D0014EEA}"/>
+                <a16:creationId xmlns:a16="http://schemas.microsoft.com/office/drawing/2014/main" id="{9C68C744-088B-4EDB-88D0-E48829028F79}"/>
               </a:ext>
             </a:extLst>
           </p:cNvPr>
@@ -21390,7 +21147,7 @@
           <p:cNvPr id="71" name="">
             <a:extLst xmlns:a="http://schemas.openxmlformats.org/drawingml/2006/main">
               <a:ext uri="{FF2B5EF4-FFF2-40B4-BE49-F238E27FC236}">
-                <a16:creationId xmlns:a16="http://schemas.microsoft.com/office/drawing/2014/main" id="{4E231C20-E977-486A-8C68-4E1884409FDC}"/>
+                <a16:creationId xmlns:a16="http://schemas.microsoft.com/office/drawing/2014/main" id="{60CA8A6B-F55A-4B38-8747-824ADDA9D0AE}"/>
               </a:ext>
             </a:extLst>
           </p:cNvPr>
@@ -21420,7 +21177,7 @@
           <p:cNvPr id="72" name="">
             <a:extLst xmlns:a="http://schemas.openxmlformats.org/drawingml/2006/main">
               <a:ext uri="{FF2B5EF4-FFF2-40B4-BE49-F238E27FC236}">
-                <a16:creationId xmlns:a16="http://schemas.microsoft.com/office/drawing/2014/main" id="{3F9415FB-CF78-4E96-8003-EE00AB1F6A05}"/>
+                <a16:creationId xmlns:a16="http://schemas.microsoft.com/office/drawing/2014/main" id="{B877B008-E51A-4D1C-B602-F106EC9B4DF5}"/>
               </a:ext>
             </a:extLst>
           </p:cNvPr>
@@ -21477,7 +21234,7 @@
           <p:cNvPr id="73" name="">
             <a:extLst xmlns:a="http://schemas.openxmlformats.org/drawingml/2006/main">
               <a:ext uri="{FF2B5EF4-FFF2-40B4-BE49-F238E27FC236}">
-                <a16:creationId xmlns:a16="http://schemas.microsoft.com/office/drawing/2014/main" id="{3EB49B3E-D2B8-4279-8D38-F71FDAC6DB6A}"/>
+                <a16:creationId xmlns:a16="http://schemas.microsoft.com/office/drawing/2014/main" id="{8C4D13E8-33CB-43D7-A413-69306C080903}"/>
               </a:ext>
             </a:extLst>
           </p:cNvPr>
@@ -21534,7 +21291,7 @@
           <p:cNvPr id="74" name="">
             <a:extLst xmlns:a="http://schemas.openxmlformats.org/drawingml/2006/main">
               <a:ext uri="{FF2B5EF4-FFF2-40B4-BE49-F238E27FC236}">
-                <a16:creationId xmlns:a16="http://schemas.microsoft.com/office/drawing/2014/main" id="{D28E74D9-4765-4007-B62C-C2D036A72A12}"/>
+                <a16:creationId xmlns:a16="http://schemas.microsoft.com/office/drawing/2014/main" id="{86ECA0E2-F981-481C-B02F-507187F52044}"/>
               </a:ext>
             </a:extLst>
           </p:cNvPr>
@@ -21564,7 +21321,7 @@
           <p:cNvPr id="75" name="">
             <a:extLst xmlns:a="http://schemas.openxmlformats.org/drawingml/2006/main">
               <a:ext uri="{FF2B5EF4-FFF2-40B4-BE49-F238E27FC236}">
-                <a16:creationId xmlns:a16="http://schemas.microsoft.com/office/drawing/2014/main" id="{DCCE759A-C028-4694-8A0F-9D4E766C4F1D}"/>
+                <a16:creationId xmlns:a16="http://schemas.microsoft.com/office/drawing/2014/main" id="{0FF621A0-0ACC-438D-A428-6403A01F4E40}"/>
               </a:ext>
             </a:extLst>
           </p:cNvPr>
@@ -21594,7 +21351,7 @@
           <p:cNvPr id="76" name="">
             <a:extLst xmlns:a="http://schemas.openxmlformats.org/drawingml/2006/main">
               <a:ext uri="{FF2B5EF4-FFF2-40B4-BE49-F238E27FC236}">
-                <a16:creationId xmlns:a16="http://schemas.microsoft.com/office/drawing/2014/main" id="{6D03E954-34D8-4EFC-B995-3227B8414590}"/>
+                <a16:creationId xmlns:a16="http://schemas.microsoft.com/office/drawing/2014/main" id="{67DAC16D-FCAF-4774-87B3-901197F23BD6}"/>
               </a:ext>
             </a:extLst>
           </p:cNvPr>
@@ -21651,7 +21408,7 @@
           <p:cNvPr id="77" name="">
             <a:extLst xmlns:a="http://schemas.openxmlformats.org/drawingml/2006/main">
               <a:ext uri="{FF2B5EF4-FFF2-40B4-BE49-F238E27FC236}">
-                <a16:creationId xmlns:a16="http://schemas.microsoft.com/office/drawing/2014/main" id="{A4875BCB-0BDB-49C7-98C5-C35F717D8861}"/>
+                <a16:creationId xmlns:a16="http://schemas.microsoft.com/office/drawing/2014/main" id="{90C57E00-8628-4330-B660-4E0A37DCDC8E}"/>
               </a:ext>
             </a:extLst>
           </p:cNvPr>
@@ -21708,7 +21465,7 @@
           <p:cNvPr id="78" name="">
             <a:extLst xmlns:a="http://schemas.openxmlformats.org/drawingml/2006/main">
               <a:ext uri="{FF2B5EF4-FFF2-40B4-BE49-F238E27FC236}">
-                <a16:creationId xmlns:a16="http://schemas.microsoft.com/office/drawing/2014/main" id="{7096E27F-7DFA-4491-9955-4E04CBF8B182}"/>
+                <a16:creationId xmlns:a16="http://schemas.microsoft.com/office/drawing/2014/main" id="{6BB134C5-F69A-42F7-B124-8484FE7961C1}"/>
               </a:ext>
             </a:extLst>
           </p:cNvPr>
@@ -21738,7 +21495,7 @@
           <p:cNvPr id="79" name="">
             <a:extLst xmlns:a="http://schemas.openxmlformats.org/drawingml/2006/main">
               <a:ext uri="{FF2B5EF4-FFF2-40B4-BE49-F238E27FC236}">
-                <a16:creationId xmlns:a16="http://schemas.microsoft.com/office/drawing/2014/main" id="{D601B3F5-6675-45E8-A190-EBD309607859}"/>
+                <a16:creationId xmlns:a16="http://schemas.microsoft.com/office/drawing/2014/main" id="{7954DF3D-80E2-488C-93BC-ECF09F3B4527}"/>
               </a:ext>
             </a:extLst>
           </p:cNvPr>
@@ -21768,7 +21525,7 @@
           <p:cNvPr id="80" name="">
             <a:extLst xmlns:a="http://schemas.openxmlformats.org/drawingml/2006/main">
               <a:ext uri="{FF2B5EF4-FFF2-40B4-BE49-F238E27FC236}">
-                <a16:creationId xmlns:a16="http://schemas.microsoft.com/office/drawing/2014/main" id="{5DD5DF4E-1AAE-4CDA-9C54-DCB77E6BCD2A}"/>
+                <a16:creationId xmlns:a16="http://schemas.microsoft.com/office/drawing/2014/main" id="{D03E55C9-0B96-4B49-86BD-C7206A93F1DF}"/>
               </a:ext>
             </a:extLst>
           </p:cNvPr>
@@ -21825,7 +21582,7 @@
           <p:cNvPr id="81" name="">
             <a:extLst xmlns:a="http://schemas.openxmlformats.org/drawingml/2006/main">
               <a:ext uri="{FF2B5EF4-FFF2-40B4-BE49-F238E27FC236}">
-                <a16:creationId xmlns:a16="http://schemas.microsoft.com/office/drawing/2014/main" id="{CBE8BF55-DCB5-4F1B-ADE5-65A38EAA59A8}"/>
+                <a16:creationId xmlns:a16="http://schemas.microsoft.com/office/drawing/2014/main" id="{F7CA4A81-319A-49F1-86B9-0A6608EFAE6D}"/>
               </a:ext>
             </a:extLst>
           </p:cNvPr>
@@ -21882,7 +21639,7 @@
           <p:cNvPr id="82" name="">
             <a:extLst xmlns:a="http://schemas.openxmlformats.org/drawingml/2006/main">
               <a:ext uri="{FF2B5EF4-FFF2-40B4-BE49-F238E27FC236}">
-                <a16:creationId xmlns:a16="http://schemas.microsoft.com/office/drawing/2014/main" id="{BE322D22-4637-4276-894D-D619C6408640}"/>
+                <a16:creationId xmlns:a16="http://schemas.microsoft.com/office/drawing/2014/main" id="{F7C75334-40EF-49A1-A61D-6F4FDC5A6A71}"/>
               </a:ext>
             </a:extLst>
           </p:cNvPr>
@@ -21914,7 +21671,7 @@
           <p:cNvPr id="83" name="">
             <a:extLst xmlns:a="http://schemas.openxmlformats.org/drawingml/2006/main">
               <a:ext uri="{FF2B5EF4-FFF2-40B4-BE49-F238E27FC236}">
-                <a16:creationId xmlns:a16="http://schemas.microsoft.com/office/drawing/2014/main" id="{ABE82131-6EB1-4B40-BCA8-F757AB4864AB}"/>
+                <a16:creationId xmlns:a16="http://schemas.microsoft.com/office/drawing/2014/main" id="{F7FDA710-2430-4123-A7AF-9746CF1BBEE9}"/>
               </a:ext>
             </a:extLst>
           </p:cNvPr>
@@ -21969,7 +21726,7 @@
     </p:spTree>
     <p:extLst>
       <p:ext uri="{BB962C8B-B14F-4D97-AF65-F5344CB8AC3E}">
-        <p14:creationId xmlns:p14="http://schemas.microsoft.com/office/powerpoint/2010/main" val="2038313328"/>
+        <p14:creationId xmlns:p14="http://schemas.microsoft.com/office/powerpoint/2010/main" val="902475923"/>
       </p:ext>
     </p:extLst>
   </p:cSld>
@@ -22000,7 +21757,7 @@
           <p:cNvPr id="8" name="">
             <a:extLst xmlns:a="http://schemas.openxmlformats.org/drawingml/2006/main">
               <a:ext uri="{FF2B5EF4-FFF2-40B4-BE49-F238E27FC236}">
-                <a16:creationId xmlns:a16="http://schemas.microsoft.com/office/drawing/2014/main" id="{A0678CF1-01B8-45BA-8643-42633458776B}"/>
+                <a16:creationId xmlns:a16="http://schemas.microsoft.com/office/drawing/2014/main" id="{C10E53A0-0A31-41EA-AD76-4D92CE591E67}"/>
               </a:ext>
             </a:extLst>
           </p:cNvPr>
@@ -22030,7 +21787,7 @@
           <p:cNvPr id="2" name="">
             <a:extLst xmlns:a="http://schemas.openxmlformats.org/drawingml/2006/main">
               <a:ext uri="{FF2B5EF4-FFF2-40B4-BE49-F238E27FC236}">
-                <a16:creationId xmlns:a16="http://schemas.microsoft.com/office/drawing/2014/main" id="{C846F1C2-0B0F-410A-99DA-54AE46B1F0B1}"/>
+                <a16:creationId xmlns:a16="http://schemas.microsoft.com/office/drawing/2014/main" id="{1A8493FF-AA54-42F7-AB1E-57932BDE6276}"/>
               </a:ext>
             </a:extLst>
           </p:cNvPr>
@@ -22091,7 +21848,7 @@
           <p:cNvPr id="3" name="">
             <a:extLst xmlns:a="http://schemas.openxmlformats.org/drawingml/2006/main">
               <a:ext uri="{FF2B5EF4-FFF2-40B4-BE49-F238E27FC236}">
-                <a16:creationId xmlns:a16="http://schemas.microsoft.com/office/drawing/2014/main" id="{655436BC-AB29-4590-850F-DD04993F8326}"/>
+                <a16:creationId xmlns:a16="http://schemas.microsoft.com/office/drawing/2014/main" id="{E6A459FC-5947-4D4D-96B0-4BB44864EA8A}"/>
               </a:ext>
             </a:extLst>
           </p:cNvPr>
@@ -22148,7 +21905,7 @@
           <p:cNvPr id="4" name="">
             <a:extLst xmlns:a="http://schemas.openxmlformats.org/drawingml/2006/main">
               <a:ext uri="{FF2B5EF4-FFF2-40B4-BE49-F238E27FC236}">
-                <a16:creationId xmlns:a16="http://schemas.microsoft.com/office/drawing/2014/main" id="{1832A418-D0A8-4A89-AC9E-1A98E2180379}"/>
+                <a16:creationId xmlns:a16="http://schemas.microsoft.com/office/drawing/2014/main" id="{96F95CC6-FEBE-4B6B-99AB-D3B5CC02650D}"/>
               </a:ext>
             </a:extLst>
           </p:cNvPr>
@@ -22205,7 +21962,7 @@
           <p:cNvPr id="5" name="">
             <a:extLst xmlns:a="http://schemas.openxmlformats.org/drawingml/2006/main">
               <a:ext uri="{FF2B5EF4-FFF2-40B4-BE49-F238E27FC236}">
-                <a16:creationId xmlns:a16="http://schemas.microsoft.com/office/drawing/2014/main" id="{69408D24-E0D9-4196-8359-C899B140EEA5}"/>
+                <a16:creationId xmlns:a16="http://schemas.microsoft.com/office/drawing/2014/main" id="{CA4DE6DC-91F6-4DD1-87BA-988C968AE961}"/>
               </a:ext>
             </a:extLst>
           </p:cNvPr>
@@ -22262,7 +22019,7 @@
           <p:cNvPr id="6" name="">
             <a:extLst xmlns:a="http://schemas.openxmlformats.org/drawingml/2006/main">
               <a:ext uri="{FF2B5EF4-FFF2-40B4-BE49-F238E27FC236}">
-                <a16:creationId xmlns:a16="http://schemas.microsoft.com/office/drawing/2014/main" id="{B1A06D5B-5ABD-43E8-8661-0941D2EC43DD}"/>
+                <a16:creationId xmlns:a16="http://schemas.microsoft.com/office/drawing/2014/main" id="{9CF4D397-BC1B-4C18-8372-07AD0AB79C46}"/>
               </a:ext>
             </a:extLst>
           </p:cNvPr>
@@ -22323,7 +22080,7 @@
           <p:nvPr/>
         </p:nvPicPr>
         <p:blipFill>
-          <a:blip xmlns:r="http://schemas.openxmlformats.org/officeDocument/2006/relationships" xmlns:a="http://schemas.openxmlformats.org/drawingml/2006/main" r:embed="R11d6585fc58b4582"/>
+          <a:blip xmlns:r="http://schemas.openxmlformats.org/officeDocument/2006/relationships" xmlns:a="http://schemas.openxmlformats.org/drawingml/2006/main" r:embed="R4198758e330f4e2f"/>
           <a:stretch xmlns:a="http://schemas.openxmlformats.org/drawingml/2006/main"/>
         </p:blipFill>
         <p:spPr>
@@ -22339,7 +22096,7 @@
     </p:spTree>
     <p:extLst>
       <p:ext uri="{BB962C8B-B14F-4D97-AF65-F5344CB8AC3E}">
-        <p14:creationId xmlns:p14="http://schemas.microsoft.com/office/powerpoint/2010/main" val="152854022"/>
+        <p14:creationId xmlns:p14="http://schemas.microsoft.com/office/powerpoint/2010/main" val="2050703509"/>
       </p:ext>
     </p:extLst>
   </p:cSld>
@@ -22370,7 +22127,7 @@
           <p:cNvPr id="25" name="">
             <a:extLst xmlns:a="http://schemas.openxmlformats.org/drawingml/2006/main">
               <a:ext uri="{FF2B5EF4-FFF2-40B4-BE49-F238E27FC236}">
-                <a16:creationId xmlns:a16="http://schemas.microsoft.com/office/drawing/2014/main" id="{A6487E11-8F87-4C3D-880F-F1A805F9C74D}"/>
+                <a16:creationId xmlns:a16="http://schemas.microsoft.com/office/drawing/2014/main" id="{092B8B8D-7D39-4BC5-971F-848DEE2CEAA5}"/>
               </a:ext>
             </a:extLst>
           </p:cNvPr>
@@ -22400,7 +22157,7 @@
           <p:cNvPr id="2" name="">
             <a:extLst xmlns:a="http://schemas.openxmlformats.org/drawingml/2006/main">
               <a:ext uri="{FF2B5EF4-FFF2-40B4-BE49-F238E27FC236}">
-                <a16:creationId xmlns:a16="http://schemas.microsoft.com/office/drawing/2014/main" id="{C55216F6-AC74-4216-B9B4-D378C9EA7DE5}"/>
+                <a16:creationId xmlns:a16="http://schemas.microsoft.com/office/drawing/2014/main" id="{BDABBBF5-0E0A-4E59-8A29-378DEE06AE7A}"/>
               </a:ext>
             </a:extLst>
           </p:cNvPr>
@@ -22461,7 +22218,7 @@
           <p:cNvPr id="3" name="">
             <a:extLst xmlns:a="http://schemas.openxmlformats.org/drawingml/2006/main">
               <a:ext uri="{FF2B5EF4-FFF2-40B4-BE49-F238E27FC236}">
-                <a16:creationId xmlns:a16="http://schemas.microsoft.com/office/drawing/2014/main" id="{E6D6956F-2783-4C82-8F37-0A2588B1B66F}"/>
+                <a16:creationId xmlns:a16="http://schemas.microsoft.com/office/drawing/2014/main" id="{AE73D573-1185-4B1F-8166-4D537A0E6BA5}"/>
               </a:ext>
             </a:extLst>
           </p:cNvPr>
@@ -22518,7 +22275,7 @@
           <p:cNvPr id="4" name="">
             <a:extLst xmlns:a="http://schemas.openxmlformats.org/drawingml/2006/main">
               <a:ext uri="{FF2B5EF4-FFF2-40B4-BE49-F238E27FC236}">
-                <a16:creationId xmlns:a16="http://schemas.microsoft.com/office/drawing/2014/main" id="{8485E884-72F1-4AE3-9C54-CF0E81133B2B}"/>
+                <a16:creationId xmlns:a16="http://schemas.microsoft.com/office/drawing/2014/main" id="{3119931C-40BC-4E92-B55C-E441A818BB00}"/>
               </a:ext>
             </a:extLst>
           </p:cNvPr>
@@ -22575,7 +22332,7 @@
           <p:cNvPr id="5" name="">
             <a:extLst xmlns:a="http://schemas.openxmlformats.org/drawingml/2006/main">
               <a:ext uri="{FF2B5EF4-FFF2-40B4-BE49-F238E27FC236}">
-                <a16:creationId xmlns:a16="http://schemas.microsoft.com/office/drawing/2014/main" id="{E456D3DF-B600-4296-A280-9E3ED870249E}"/>
+                <a16:creationId xmlns:a16="http://schemas.microsoft.com/office/drawing/2014/main" id="{9DC1018C-AE27-422B-93A9-79F3741AA6BC}"/>
               </a:ext>
             </a:extLst>
           </p:cNvPr>
@@ -22632,7 +22389,7 @@
           <p:cNvPr id="6" name="">
             <a:extLst xmlns:a="http://schemas.openxmlformats.org/drawingml/2006/main">
               <a:ext uri="{FF2B5EF4-FFF2-40B4-BE49-F238E27FC236}">
-                <a16:creationId xmlns:a16="http://schemas.microsoft.com/office/drawing/2014/main" id="{B640B627-8E69-4516-AA8C-8E233FF772B7}"/>
+                <a16:creationId xmlns:a16="http://schemas.microsoft.com/office/drawing/2014/main" id="{E865A391-9A40-45A6-9539-9176B5B921CF}"/>
               </a:ext>
             </a:extLst>
           </p:cNvPr>
@@ -22689,7 +22446,7 @@
           <p:cNvPr id="7" name="">
             <a:extLst xmlns:a="http://schemas.openxmlformats.org/drawingml/2006/main">
               <a:ext uri="{FF2B5EF4-FFF2-40B4-BE49-F238E27FC236}">
-                <a16:creationId xmlns:a16="http://schemas.microsoft.com/office/drawing/2014/main" id="{03A27848-B82E-4B56-9610-CCB669B1F753}"/>
+                <a16:creationId xmlns:a16="http://schemas.microsoft.com/office/drawing/2014/main" id="{8A0F3B10-2B6F-453D-B077-289A44F4121D}"/>
               </a:ext>
             </a:extLst>
           </p:cNvPr>
@@ -22746,7 +22503,7 @@
           <p:cNvPr id="8" name="">
             <a:extLst xmlns:a="http://schemas.openxmlformats.org/drawingml/2006/main">
               <a:ext uri="{FF2B5EF4-FFF2-40B4-BE49-F238E27FC236}">
-                <a16:creationId xmlns:a16="http://schemas.microsoft.com/office/drawing/2014/main" id="{B3CA446D-A6D8-4B95-B0C1-4EB87106E395}"/>
+                <a16:creationId xmlns:a16="http://schemas.microsoft.com/office/drawing/2014/main" id="{C73A9C72-F778-4765-AEAC-75C4B199FFC8}"/>
               </a:ext>
             </a:extLst>
           </p:cNvPr>
@@ -22826,7 +22583,7 @@
           <p:cNvPr id="9" name="">
             <a:extLst xmlns:a="http://schemas.openxmlformats.org/drawingml/2006/main">
               <a:ext uri="{FF2B5EF4-FFF2-40B4-BE49-F238E27FC236}">
-                <a16:creationId xmlns:a16="http://schemas.microsoft.com/office/drawing/2014/main" id="{0D88967F-8B5E-49DB-9FBA-137BFD0A12F8}"/>
+                <a16:creationId xmlns:a16="http://schemas.microsoft.com/office/drawing/2014/main" id="{6D88B197-36B3-4975-BA88-C02F78682A1C}"/>
               </a:ext>
             </a:extLst>
           </p:cNvPr>
@@ -22860,7 +22617,7 @@
           <p:cNvPr id="10" name="">
             <a:extLst xmlns:a="http://schemas.openxmlformats.org/drawingml/2006/main">
               <a:ext uri="{FF2B5EF4-FFF2-40B4-BE49-F238E27FC236}">
-                <a16:creationId xmlns:a16="http://schemas.microsoft.com/office/drawing/2014/main" id="{397B038B-DA44-4726-9CCD-C65CFF90C982}"/>
+                <a16:creationId xmlns:a16="http://schemas.microsoft.com/office/drawing/2014/main" id="{31F353A1-987C-4064-930D-05F5337C997C}"/>
               </a:ext>
             </a:extLst>
           </p:cNvPr>
@@ -22890,7 +22647,7 @@
           <p:cNvPr id="11" name="">
             <a:extLst xmlns:a="http://schemas.openxmlformats.org/drawingml/2006/main">
               <a:ext uri="{FF2B5EF4-FFF2-40B4-BE49-F238E27FC236}">
-                <a16:creationId xmlns:a16="http://schemas.microsoft.com/office/drawing/2014/main" id="{255DCF96-ABE1-4B79-B5D8-ECAC902D72C5}"/>
+                <a16:creationId xmlns:a16="http://schemas.microsoft.com/office/drawing/2014/main" id="{93AB4D91-CC85-4C24-BD0E-0C1EC3E2D417}"/>
               </a:ext>
             </a:extLst>
           </p:cNvPr>
@@ -22947,7 +22704,7 @@
           <p:cNvPr id="12" name="">
             <a:extLst xmlns:a="http://schemas.openxmlformats.org/drawingml/2006/main">
               <a:ext uri="{FF2B5EF4-FFF2-40B4-BE49-F238E27FC236}">
-                <a16:creationId xmlns:a16="http://schemas.microsoft.com/office/drawing/2014/main" id="{A36C1F9A-EDA1-41F7-A06A-FE4F5FB7D055}"/>
+                <a16:creationId xmlns:a16="http://schemas.microsoft.com/office/drawing/2014/main" id="{FB812AF4-B792-482A-9626-27DCBE8E626B}"/>
               </a:ext>
             </a:extLst>
           </p:cNvPr>
@@ -23004,7 +22761,7 @@
           <p:cNvPr id="13" name="">
             <a:extLst xmlns:a="http://schemas.openxmlformats.org/drawingml/2006/main">
               <a:ext uri="{FF2B5EF4-FFF2-40B4-BE49-F238E27FC236}">
-                <a16:creationId xmlns:a16="http://schemas.microsoft.com/office/drawing/2014/main" id="{498B8B11-8536-4532-A815-80E48FB8ACBA}"/>
+                <a16:creationId xmlns:a16="http://schemas.microsoft.com/office/drawing/2014/main" id="{B5925C9D-7474-422D-9605-1E3B3CA88957}"/>
               </a:ext>
             </a:extLst>
           </p:cNvPr>
@@ -23061,7 +22818,7 @@
           <p:cNvPr id="14" name="">
             <a:extLst xmlns:a="http://schemas.openxmlformats.org/drawingml/2006/main">
               <a:ext uri="{FF2B5EF4-FFF2-40B4-BE49-F238E27FC236}">
-                <a16:creationId xmlns:a16="http://schemas.microsoft.com/office/drawing/2014/main" id="{6FEE2A6E-F957-4223-9423-480892D15028}"/>
+                <a16:creationId xmlns:a16="http://schemas.microsoft.com/office/drawing/2014/main" id="{369DD634-01C2-41D6-8342-BCFF4A079FB8}"/>
               </a:ext>
             </a:extLst>
           </p:cNvPr>
@@ -23095,7 +22852,7 @@
           <p:cNvPr id="15" name="">
             <a:extLst xmlns:a="http://schemas.openxmlformats.org/drawingml/2006/main">
               <a:ext uri="{FF2B5EF4-FFF2-40B4-BE49-F238E27FC236}">
-                <a16:creationId xmlns:a16="http://schemas.microsoft.com/office/drawing/2014/main" id="{04F3A6DE-12CE-4FC4-882C-B2642E1265E1}"/>
+                <a16:creationId xmlns:a16="http://schemas.microsoft.com/office/drawing/2014/main" id="{FAF4C08D-E623-4CBD-B476-280188EAF090}"/>
               </a:ext>
             </a:extLst>
           </p:cNvPr>
@@ -23125,7 +22882,7 @@
           <p:cNvPr id="16" name="">
             <a:extLst xmlns:a="http://schemas.openxmlformats.org/drawingml/2006/main">
               <a:ext uri="{FF2B5EF4-FFF2-40B4-BE49-F238E27FC236}">
-                <a16:creationId xmlns:a16="http://schemas.microsoft.com/office/drawing/2014/main" id="{919AC8CB-3214-4370-AFEF-EBB782959B7E}"/>
+                <a16:creationId xmlns:a16="http://schemas.microsoft.com/office/drawing/2014/main" id="{0CA80E92-CF7F-49B8-A2E9-D758B1330872}"/>
               </a:ext>
             </a:extLst>
           </p:cNvPr>
@@ -23182,7 +22939,7 @@
           <p:cNvPr id="17" name="">
             <a:extLst xmlns:a="http://schemas.openxmlformats.org/drawingml/2006/main">
               <a:ext uri="{FF2B5EF4-FFF2-40B4-BE49-F238E27FC236}">
-                <a16:creationId xmlns:a16="http://schemas.microsoft.com/office/drawing/2014/main" id="{AC75A54A-5C65-4953-8045-75BBE17A2325}"/>
+                <a16:creationId xmlns:a16="http://schemas.microsoft.com/office/drawing/2014/main" id="{69EBBD6E-AD33-49EB-B7AA-DF2FDFDED214}"/>
               </a:ext>
             </a:extLst>
           </p:cNvPr>
@@ -23239,7 +22996,7 @@
           <p:cNvPr id="18" name="">
             <a:extLst xmlns:a="http://schemas.openxmlformats.org/drawingml/2006/main">
               <a:ext uri="{FF2B5EF4-FFF2-40B4-BE49-F238E27FC236}">
-                <a16:creationId xmlns:a16="http://schemas.microsoft.com/office/drawing/2014/main" id="{F127A0B8-9001-4EB0-862F-0CE91BCDCA81}"/>
+                <a16:creationId xmlns:a16="http://schemas.microsoft.com/office/drawing/2014/main" id="{02A15C4C-ABE3-42B5-89B7-4E8C79CB703C}"/>
               </a:ext>
             </a:extLst>
           </p:cNvPr>
@@ -23296,7 +23053,7 @@
           <p:cNvPr id="19" name="">
             <a:extLst xmlns:a="http://schemas.openxmlformats.org/drawingml/2006/main">
               <a:ext uri="{FF2B5EF4-FFF2-40B4-BE49-F238E27FC236}">
-                <a16:creationId xmlns:a16="http://schemas.microsoft.com/office/drawing/2014/main" id="{4511A3ED-932E-4788-8553-F2461629160C}"/>
+                <a16:creationId xmlns:a16="http://schemas.microsoft.com/office/drawing/2014/main" id="{3AA85154-01A0-417C-85FE-878561F9FF77}"/>
               </a:ext>
             </a:extLst>
           </p:cNvPr>
@@ -23330,7 +23087,7 @@
           <p:cNvPr id="20" name="">
             <a:extLst xmlns:a="http://schemas.openxmlformats.org/drawingml/2006/main">
               <a:ext uri="{FF2B5EF4-FFF2-40B4-BE49-F238E27FC236}">
-                <a16:creationId xmlns:a16="http://schemas.microsoft.com/office/drawing/2014/main" id="{128C8BFB-AECB-4306-B816-D8A16878C431}"/>
+                <a16:creationId xmlns:a16="http://schemas.microsoft.com/office/drawing/2014/main" id="{83F2CF3E-C8BC-401F-8FB3-07663A880D35}"/>
               </a:ext>
             </a:extLst>
           </p:cNvPr>
@@ -23360,7 +23117,7 @@
           <p:cNvPr id="21" name="">
             <a:extLst xmlns:a="http://schemas.openxmlformats.org/drawingml/2006/main">
               <a:ext uri="{FF2B5EF4-FFF2-40B4-BE49-F238E27FC236}">
-                <a16:creationId xmlns:a16="http://schemas.microsoft.com/office/drawing/2014/main" id="{CFCDB576-FA35-46C7-BA9C-420674C40CD0}"/>
+                <a16:creationId xmlns:a16="http://schemas.microsoft.com/office/drawing/2014/main" id="{C4B619C0-848D-4A5C-B028-2E73F636BCE0}"/>
               </a:ext>
             </a:extLst>
           </p:cNvPr>
@@ -23417,7 +23174,7 @@
           <p:cNvPr id="22" name="">
             <a:extLst xmlns:a="http://schemas.openxmlformats.org/drawingml/2006/main">
               <a:ext uri="{FF2B5EF4-FFF2-40B4-BE49-F238E27FC236}">
-                <a16:creationId xmlns:a16="http://schemas.microsoft.com/office/drawing/2014/main" id="{67596037-FAA1-49FB-8269-E716AEBC166D}"/>
+                <a16:creationId xmlns:a16="http://schemas.microsoft.com/office/drawing/2014/main" id="{8C14BE9A-88BC-4362-83FD-38085BCD40A3}"/>
               </a:ext>
             </a:extLst>
           </p:cNvPr>
@@ -23474,7 +23231,7 @@
           <p:cNvPr id="23" name="">
             <a:extLst xmlns:a="http://schemas.openxmlformats.org/drawingml/2006/main">
               <a:ext uri="{FF2B5EF4-FFF2-40B4-BE49-F238E27FC236}">
-                <a16:creationId xmlns:a16="http://schemas.microsoft.com/office/drawing/2014/main" id="{8775F394-F83D-499B-B481-6F064C2B28FA}"/>
+                <a16:creationId xmlns:a16="http://schemas.microsoft.com/office/drawing/2014/main" id="{04D7ECA9-E2D3-4A51-9532-44839A05F0D2}"/>
               </a:ext>
             </a:extLst>
           </p:cNvPr>
@@ -23535,7 +23292,7 @@
           <p:nvPr/>
         </p:nvPicPr>
         <p:blipFill>
-          <a:blip xmlns:r="http://schemas.openxmlformats.org/officeDocument/2006/relationships" xmlns:a="http://schemas.openxmlformats.org/drawingml/2006/main" r:embed="R2d1a0beac6034910"/>
+          <a:blip xmlns:r="http://schemas.openxmlformats.org/officeDocument/2006/relationships" xmlns:a="http://schemas.openxmlformats.org/drawingml/2006/main" r:embed="R8a79c0e287eb46b3"/>
           <a:stretch xmlns:a="http://schemas.openxmlformats.org/drawingml/2006/main"/>
         </p:blipFill>
         <p:spPr>
@@ -23553,7 +23310,7 @@
     </p:spTree>
     <p:extLst>
       <p:ext uri="{BB962C8B-B14F-4D97-AF65-F5344CB8AC3E}">
-        <p14:creationId xmlns:p14="http://schemas.microsoft.com/office/powerpoint/2010/main" val="1123079773"/>
+        <p14:creationId xmlns:p14="http://schemas.microsoft.com/office/powerpoint/2010/main" val="1619365842"/>
       </p:ext>
     </p:extLst>
   </p:cSld>
@@ -23584,7 +23341,7 @@
           <p:cNvPr id="18" name="">
             <a:extLst xmlns:a="http://schemas.openxmlformats.org/drawingml/2006/main">
               <a:ext uri="{FF2B5EF4-FFF2-40B4-BE49-F238E27FC236}">
-                <a16:creationId xmlns:a16="http://schemas.microsoft.com/office/drawing/2014/main" id="{C733C0FB-114B-4BA6-8BE5-203723AE95BF}"/>
+                <a16:creationId xmlns:a16="http://schemas.microsoft.com/office/drawing/2014/main" id="{D0A674E6-CC0E-4E54-9D49-25E2D1A0AE56}"/>
               </a:ext>
             </a:extLst>
           </p:cNvPr>
@@ -23614,7 +23371,7 @@
           <p:cNvPr id="2" name="">
             <a:extLst xmlns:a="http://schemas.openxmlformats.org/drawingml/2006/main">
               <a:ext uri="{FF2B5EF4-FFF2-40B4-BE49-F238E27FC236}">
-                <a16:creationId xmlns:a16="http://schemas.microsoft.com/office/drawing/2014/main" id="{3BAD01A6-15DE-4D6B-8AEF-E61488AA6085}"/>
+                <a16:creationId xmlns:a16="http://schemas.microsoft.com/office/drawing/2014/main" id="{357CBC7B-5156-49FD-84DD-B555765F71CB}"/>
               </a:ext>
             </a:extLst>
           </p:cNvPr>
@@ -23675,7 +23432,7 @@
           <p:cNvPr id="3" name="">
             <a:extLst xmlns:a="http://schemas.openxmlformats.org/drawingml/2006/main">
               <a:ext uri="{FF2B5EF4-FFF2-40B4-BE49-F238E27FC236}">
-                <a16:creationId xmlns:a16="http://schemas.microsoft.com/office/drawing/2014/main" id="{7B6E5538-82E4-43C8-B0CE-873E8F6CEED7}"/>
+                <a16:creationId xmlns:a16="http://schemas.microsoft.com/office/drawing/2014/main" id="{7171B4E5-EB6E-43C1-A981-373C216E108A}"/>
               </a:ext>
             </a:extLst>
           </p:cNvPr>
@@ -23732,7 +23489,7 @@
           <p:cNvPr id="4" name="">
             <a:extLst xmlns:a="http://schemas.openxmlformats.org/drawingml/2006/main">
               <a:ext uri="{FF2B5EF4-FFF2-40B4-BE49-F238E27FC236}">
-                <a16:creationId xmlns:a16="http://schemas.microsoft.com/office/drawing/2014/main" id="{581970E1-D09D-4520-B2C2-500A7DB306CF}"/>
+                <a16:creationId xmlns:a16="http://schemas.microsoft.com/office/drawing/2014/main" id="{2189D0EC-6369-469B-848C-58C678438ED7}"/>
               </a:ext>
             </a:extLst>
           </p:cNvPr>
@@ -23789,7 +23546,7 @@
           <p:cNvPr id="5" name="">
             <a:extLst xmlns:a="http://schemas.openxmlformats.org/drawingml/2006/main">
               <a:ext uri="{FF2B5EF4-FFF2-40B4-BE49-F238E27FC236}">
-                <a16:creationId xmlns:a16="http://schemas.microsoft.com/office/drawing/2014/main" id="{B7EC0F22-3AE4-49C8-B41A-08D502D962FF}"/>
+                <a16:creationId xmlns:a16="http://schemas.microsoft.com/office/drawing/2014/main" id="{E9A3C605-F963-4D2E-B456-F24A7C962240}"/>
               </a:ext>
             </a:extLst>
           </p:cNvPr>
@@ -23846,7 +23603,7 @@
           <p:cNvPr id="6" name="">
             <a:extLst xmlns:a="http://schemas.openxmlformats.org/drawingml/2006/main">
               <a:ext uri="{FF2B5EF4-FFF2-40B4-BE49-F238E27FC236}">
-                <a16:creationId xmlns:a16="http://schemas.microsoft.com/office/drawing/2014/main" id="{563AF243-8ECA-4040-B485-A5DD1283B9FA}"/>
+                <a16:creationId xmlns:a16="http://schemas.microsoft.com/office/drawing/2014/main" id="{BCE4982F-A993-4BE6-9D39-4108C57E6AB9}"/>
               </a:ext>
             </a:extLst>
           </p:cNvPr>
@@ -23903,7 +23660,7 @@
           <p:cNvPr id="7" name="">
             <a:extLst xmlns:a="http://schemas.openxmlformats.org/drawingml/2006/main">
               <a:ext uri="{FF2B5EF4-FFF2-40B4-BE49-F238E27FC236}">
-                <a16:creationId xmlns:a16="http://schemas.microsoft.com/office/drawing/2014/main" id="{DF9BF8FC-0D06-4928-8E05-935FC1CA79C1}"/>
+                <a16:creationId xmlns:a16="http://schemas.microsoft.com/office/drawing/2014/main" id="{560E1831-C328-4FDF-92BE-F2E41AD532D3}"/>
               </a:ext>
             </a:extLst>
           </p:cNvPr>
@@ -23960,7 +23717,7 @@
           <p:cNvPr id="8" name="">
             <a:extLst xmlns:a="http://schemas.openxmlformats.org/drawingml/2006/main">
               <a:ext uri="{FF2B5EF4-FFF2-40B4-BE49-F238E27FC236}">
-                <a16:creationId xmlns:a16="http://schemas.microsoft.com/office/drawing/2014/main" id="{A420DDDA-6752-4B25-80DE-877DA09CDE66}"/>
+                <a16:creationId xmlns:a16="http://schemas.microsoft.com/office/drawing/2014/main" id="{22F64AB0-A83B-4490-BB23-2203E11F9BE9}"/>
               </a:ext>
             </a:extLst>
           </p:cNvPr>
@@ -24017,7 +23774,7 @@
           <p:cNvPr id="9" name="">
             <a:extLst xmlns:a="http://schemas.openxmlformats.org/drawingml/2006/main">
               <a:ext uri="{FF2B5EF4-FFF2-40B4-BE49-F238E27FC236}">
-                <a16:creationId xmlns:a16="http://schemas.microsoft.com/office/drawing/2014/main" id="{41049751-51D6-45DF-AE93-2ACA08D1E325}"/>
+                <a16:creationId xmlns:a16="http://schemas.microsoft.com/office/drawing/2014/main" id="{2F90C3A8-2DB9-4615-8F4C-56F7286C6158}"/>
               </a:ext>
             </a:extLst>
           </p:cNvPr>
@@ -24078,7 +23835,7 @@
           <p:nvPr/>
         </p:nvPicPr>
         <p:blipFill>
-          <a:blip xmlns:r="http://schemas.openxmlformats.org/officeDocument/2006/relationships" xmlns:a="http://schemas.openxmlformats.org/drawingml/2006/main" r:embed="Reffd921ef2b64faf"/>
+          <a:blip xmlns:r="http://schemas.openxmlformats.org/officeDocument/2006/relationships" xmlns:a="http://schemas.openxmlformats.org/drawingml/2006/main" r:embed="R36a0dbccb91c4a41"/>
           <a:stretch xmlns:a="http://schemas.openxmlformats.org/drawingml/2006/main"/>
         </p:blipFill>
         <p:spPr>
@@ -24102,7 +23859,7 @@
           <p:nvPr/>
         </p:nvPicPr>
         <p:blipFill>
-          <a:blip xmlns:r="http://schemas.openxmlformats.org/officeDocument/2006/relationships" xmlns:a="http://schemas.openxmlformats.org/drawingml/2006/main" r:embed="Ra78cee2e494f431e"/>
+          <a:blip xmlns:r="http://schemas.openxmlformats.org/officeDocument/2006/relationships" xmlns:a="http://schemas.openxmlformats.org/drawingml/2006/main" r:embed="Rb13a3a91eb934809"/>
           <a:stretch xmlns:a="http://schemas.openxmlformats.org/drawingml/2006/main"/>
         </p:blipFill>
         <p:spPr>
@@ -24122,7 +23879,7 @@
           <p:cNvPr id="12" name="">
             <a:extLst xmlns:a="http://schemas.openxmlformats.org/drawingml/2006/main">
               <a:ext uri="{FF2B5EF4-FFF2-40B4-BE49-F238E27FC236}">
-                <a16:creationId xmlns:a16="http://schemas.microsoft.com/office/drawing/2014/main" id="{F3CCBA15-8B3A-4EEB-95FB-185DCDBAF3E3}"/>
+                <a16:creationId xmlns:a16="http://schemas.microsoft.com/office/drawing/2014/main" id="{5D0C7A03-4014-4FBF-A1C1-F028FE43396D}"/>
               </a:ext>
             </a:extLst>
           </p:cNvPr>
@@ -24156,7 +23913,7 @@
           <p:cNvPr id="13" name="">
             <a:extLst xmlns:a="http://schemas.openxmlformats.org/drawingml/2006/main">
               <a:ext uri="{FF2B5EF4-FFF2-40B4-BE49-F238E27FC236}">
-                <a16:creationId xmlns:a16="http://schemas.microsoft.com/office/drawing/2014/main" id="{0015C411-BAC8-4AC3-809E-E5088A206C5E}"/>
+                <a16:creationId xmlns:a16="http://schemas.microsoft.com/office/drawing/2014/main" id="{3511D0C4-89E0-413D-B750-8948BB23A884}"/>
               </a:ext>
             </a:extLst>
           </p:cNvPr>
@@ -24213,7 +23970,7 @@
           <p:cNvPr id="14" name="">
             <a:extLst xmlns:a="http://schemas.openxmlformats.org/drawingml/2006/main">
               <a:ext uri="{FF2B5EF4-FFF2-40B4-BE49-F238E27FC236}">
-                <a16:creationId xmlns:a16="http://schemas.microsoft.com/office/drawing/2014/main" id="{08D0F548-E94B-49E8-A011-AE4EDAFDF709}"/>
+                <a16:creationId xmlns:a16="http://schemas.microsoft.com/office/drawing/2014/main" id="{9902DA90-CE1F-4810-B1CE-AC55DE2389BE}"/>
               </a:ext>
             </a:extLst>
           </p:cNvPr>
@@ -24270,7 +24027,7 @@
           <p:cNvPr id="15" name="">
             <a:extLst xmlns:a="http://schemas.openxmlformats.org/drawingml/2006/main">
               <a:ext uri="{FF2B5EF4-FFF2-40B4-BE49-F238E27FC236}">
-                <a16:creationId xmlns:a16="http://schemas.microsoft.com/office/drawing/2014/main" id="{0FDACFFC-D67C-4B00-BCF9-DD3DC754CC4B}"/>
+                <a16:creationId xmlns:a16="http://schemas.microsoft.com/office/drawing/2014/main" id="{E4A68E8E-7A64-4D0F-BA02-BACDC6B299CA}"/>
               </a:ext>
             </a:extLst>
           </p:cNvPr>
@@ -24304,7 +24061,7 @@
           <p:cNvPr id="16" name="">
             <a:extLst xmlns:a="http://schemas.openxmlformats.org/drawingml/2006/main">
               <a:ext uri="{FF2B5EF4-FFF2-40B4-BE49-F238E27FC236}">
-                <a16:creationId xmlns:a16="http://schemas.microsoft.com/office/drawing/2014/main" id="{9EAB59C9-C8CD-4024-992C-28B735DE1EE2}"/>
+                <a16:creationId xmlns:a16="http://schemas.microsoft.com/office/drawing/2014/main" id="{FFBC07E9-A258-40D4-98A5-DBF45D0453D9}"/>
               </a:ext>
             </a:extLst>
           </p:cNvPr>
@@ -24361,7 +24118,7 @@
           <p:cNvPr id="17" name="">
             <a:extLst xmlns:a="http://schemas.openxmlformats.org/drawingml/2006/main">
               <a:ext uri="{FF2B5EF4-FFF2-40B4-BE49-F238E27FC236}">
-                <a16:creationId xmlns:a16="http://schemas.microsoft.com/office/drawing/2014/main" id="{E93C9BC3-19B3-4ABC-8A44-DA90244CB44C}"/>
+                <a16:creationId xmlns:a16="http://schemas.microsoft.com/office/drawing/2014/main" id="{4DBD70BB-557E-4C0B-937F-765C8EF75391}"/>
               </a:ext>
             </a:extLst>
           </p:cNvPr>
@@ -24416,7 +24173,7 @@
     </p:spTree>
     <p:extLst>
       <p:ext uri="{BB962C8B-B14F-4D97-AF65-F5344CB8AC3E}">
-        <p14:creationId xmlns:p14="http://schemas.microsoft.com/office/powerpoint/2010/main" val="306405804"/>
+        <p14:creationId xmlns:p14="http://schemas.microsoft.com/office/powerpoint/2010/main" val="1946343485"/>
       </p:ext>
     </p:extLst>
   </p:cSld>
@@ -24447,7 +24204,7 @@
           <p:cNvPr id="36" name="">
             <a:extLst xmlns:a="http://schemas.openxmlformats.org/drawingml/2006/main">
               <a:ext uri="{FF2B5EF4-FFF2-40B4-BE49-F238E27FC236}">
-                <a16:creationId xmlns:a16="http://schemas.microsoft.com/office/drawing/2014/main" id="{B95CC9B3-F26D-429B-B8F2-265439F41259}"/>
+                <a16:creationId xmlns:a16="http://schemas.microsoft.com/office/drawing/2014/main" id="{D1618195-20E3-464F-889D-B00BBBB219CF}"/>
               </a:ext>
             </a:extLst>
           </p:cNvPr>
@@ -24477,7 +24234,7 @@
           <p:cNvPr id="2" name="">
             <a:extLst xmlns:a="http://schemas.openxmlformats.org/drawingml/2006/main">
               <a:ext uri="{FF2B5EF4-FFF2-40B4-BE49-F238E27FC236}">
-                <a16:creationId xmlns:a16="http://schemas.microsoft.com/office/drawing/2014/main" id="{6C2C518A-7A70-400B-B622-9B23CA989EDD}"/>
+                <a16:creationId xmlns:a16="http://schemas.microsoft.com/office/drawing/2014/main" id="{3DDD922A-9AED-4107-865D-FA1E557B8EC3}"/>
               </a:ext>
             </a:extLst>
           </p:cNvPr>
@@ -24538,7 +24295,7 @@
           <p:cNvPr id="3" name="">
             <a:extLst xmlns:a="http://schemas.openxmlformats.org/drawingml/2006/main">
               <a:ext uri="{FF2B5EF4-FFF2-40B4-BE49-F238E27FC236}">
-                <a16:creationId xmlns:a16="http://schemas.microsoft.com/office/drawing/2014/main" id="{3E77A690-8346-4514-A57B-9586E20C16EB}"/>
+                <a16:creationId xmlns:a16="http://schemas.microsoft.com/office/drawing/2014/main" id="{DEF2983C-6CBC-4533-B139-660E7FD24A82}"/>
               </a:ext>
             </a:extLst>
           </p:cNvPr>
@@ -24595,7 +24352,7 @@
           <p:cNvPr id="4" name="">
             <a:extLst xmlns:a="http://schemas.openxmlformats.org/drawingml/2006/main">
               <a:ext uri="{FF2B5EF4-FFF2-40B4-BE49-F238E27FC236}">
-                <a16:creationId xmlns:a16="http://schemas.microsoft.com/office/drawing/2014/main" id="{59029689-F5B9-4B77-811E-E1C5948BDE66}"/>
+                <a16:creationId xmlns:a16="http://schemas.microsoft.com/office/drawing/2014/main" id="{160C5180-6D3D-44FF-BF46-E566CC0D9909}"/>
               </a:ext>
             </a:extLst>
           </p:cNvPr>
@@ -24652,7 +24409,7 @@
           <p:cNvPr id="5" name="">
             <a:extLst xmlns:a="http://schemas.openxmlformats.org/drawingml/2006/main">
               <a:ext uri="{FF2B5EF4-FFF2-40B4-BE49-F238E27FC236}">
-                <a16:creationId xmlns:a16="http://schemas.microsoft.com/office/drawing/2014/main" id="{0B74F5C8-9CB7-44E9-AD1F-9DA1CCF57A3C}"/>
+                <a16:creationId xmlns:a16="http://schemas.microsoft.com/office/drawing/2014/main" id="{D22FA353-8F0D-4D28-93B2-B7CB7FC4C8D8}"/>
               </a:ext>
             </a:extLst>
           </p:cNvPr>
@@ -24709,7 +24466,7 @@
           <p:cNvPr id="6" name="">
             <a:extLst xmlns:a="http://schemas.openxmlformats.org/drawingml/2006/main">
               <a:ext uri="{FF2B5EF4-FFF2-40B4-BE49-F238E27FC236}">
-                <a16:creationId xmlns:a16="http://schemas.microsoft.com/office/drawing/2014/main" id="{399E1C53-CD83-4C19-B05E-DE78358F33C6}"/>
+                <a16:creationId xmlns:a16="http://schemas.microsoft.com/office/drawing/2014/main" id="{CD20D5DC-5B5E-4527-893C-8E222B3404B2}"/>
               </a:ext>
             </a:extLst>
           </p:cNvPr>
@@ -24766,7 +24523,7 @@
           <p:cNvPr id="7" name="">
             <a:extLst xmlns:a="http://schemas.openxmlformats.org/drawingml/2006/main">
               <a:ext uri="{FF2B5EF4-FFF2-40B4-BE49-F238E27FC236}">
-                <a16:creationId xmlns:a16="http://schemas.microsoft.com/office/drawing/2014/main" id="{CD788825-888B-4A63-8F1C-A07335C314FF}"/>
+                <a16:creationId xmlns:a16="http://schemas.microsoft.com/office/drawing/2014/main" id="{49C87E14-FBF8-4F3B-A549-F72D3C24629A}"/>
               </a:ext>
             </a:extLst>
           </p:cNvPr>
@@ -24823,7 +24580,7 @@
           <p:cNvPr id="8" name="">
             <a:extLst xmlns:a="http://schemas.openxmlformats.org/drawingml/2006/main">
               <a:ext uri="{FF2B5EF4-FFF2-40B4-BE49-F238E27FC236}">
-                <a16:creationId xmlns:a16="http://schemas.microsoft.com/office/drawing/2014/main" id="{14F8FF0D-7A08-424F-8B92-EEEA74C8522B}"/>
+                <a16:creationId xmlns:a16="http://schemas.microsoft.com/office/drawing/2014/main" id="{E5B9544D-15B0-4003-A9AE-A0701307450D}"/>
               </a:ext>
             </a:extLst>
           </p:cNvPr>
@@ -24880,7 +24637,7 @@
           <p:cNvPr id="9" name="">
             <a:extLst xmlns:a="http://schemas.openxmlformats.org/drawingml/2006/main">
               <a:ext uri="{FF2B5EF4-FFF2-40B4-BE49-F238E27FC236}">
-                <a16:creationId xmlns:a16="http://schemas.microsoft.com/office/drawing/2014/main" id="{77883351-4D18-4441-9029-2C86F3759DA4}"/>
+                <a16:creationId xmlns:a16="http://schemas.microsoft.com/office/drawing/2014/main" id="{9F1AF2C4-9F04-43E6-BEE2-AF85E0CA2BD3}"/>
               </a:ext>
             </a:extLst>
           </p:cNvPr>
@@ -24937,7 +24694,7 @@
           <p:cNvPr id="10" name="">
             <a:extLst xmlns:a="http://schemas.openxmlformats.org/drawingml/2006/main">
               <a:ext uri="{FF2B5EF4-FFF2-40B4-BE49-F238E27FC236}">
-                <a16:creationId xmlns:a16="http://schemas.microsoft.com/office/drawing/2014/main" id="{D6B81F14-801B-4768-B717-2DA3C9FD387F}"/>
+                <a16:creationId xmlns:a16="http://schemas.microsoft.com/office/drawing/2014/main" id="{88DA7675-D5EE-46C1-A854-7666C9FBF38E}"/>
               </a:ext>
             </a:extLst>
           </p:cNvPr>
@@ -24971,7 +24728,7 @@
           <p:cNvPr id="11" name="">
             <a:extLst xmlns:a="http://schemas.openxmlformats.org/drawingml/2006/main">
               <a:ext uri="{FF2B5EF4-FFF2-40B4-BE49-F238E27FC236}">
-                <a16:creationId xmlns:a16="http://schemas.microsoft.com/office/drawing/2014/main" id="{AD77CF3B-36FF-405C-AA42-DC215F703567}"/>
+                <a16:creationId xmlns:a16="http://schemas.microsoft.com/office/drawing/2014/main" id="{02F0ADD8-BCD4-42C9-B06B-69F4F905C339}"/>
               </a:ext>
             </a:extLst>
           </p:cNvPr>
@@ -25028,7 +24785,7 @@
           <p:cNvPr id="12" name="">
             <a:extLst xmlns:a="http://schemas.openxmlformats.org/drawingml/2006/main">
               <a:ext uri="{FF2B5EF4-FFF2-40B4-BE49-F238E27FC236}">
-                <a16:creationId xmlns:a16="http://schemas.microsoft.com/office/drawing/2014/main" id="{644ADC80-C6EB-4B84-8B35-D5FC71AA5A3E}"/>
+                <a16:creationId xmlns:a16="http://schemas.microsoft.com/office/drawing/2014/main" id="{E43CDED4-A10B-457D-BC56-BBDAF9C75E18}"/>
               </a:ext>
             </a:extLst>
           </p:cNvPr>
@@ -25085,7 +24842,7 @@
           <p:cNvPr id="13" name="">
             <a:extLst xmlns:a="http://schemas.openxmlformats.org/drawingml/2006/main">
               <a:ext uri="{FF2B5EF4-FFF2-40B4-BE49-F238E27FC236}">
-                <a16:creationId xmlns:a16="http://schemas.microsoft.com/office/drawing/2014/main" id="{55B9DCEB-6A4B-4084-8A98-6AF5C95D296B}"/>
+                <a16:creationId xmlns:a16="http://schemas.microsoft.com/office/drawing/2014/main" id="{9A5A222E-2CCC-4007-8D93-2319D347F991}"/>
               </a:ext>
             </a:extLst>
           </p:cNvPr>
@@ -25142,7 +24899,7 @@
           <p:cNvPr id="14" name="">
             <a:extLst xmlns:a="http://schemas.openxmlformats.org/drawingml/2006/main">
               <a:ext uri="{FF2B5EF4-FFF2-40B4-BE49-F238E27FC236}">
-                <a16:creationId xmlns:a16="http://schemas.microsoft.com/office/drawing/2014/main" id="{78C4DF59-AF99-4C30-87E5-F3F37EC8D824}"/>
+                <a16:creationId xmlns:a16="http://schemas.microsoft.com/office/drawing/2014/main" id="{A7925D8C-FBC3-4A4D-AEEE-BD5EE660CC11}"/>
               </a:ext>
             </a:extLst>
           </p:cNvPr>
@@ -25199,7 +24956,7 @@
           <p:cNvPr id="15" name="">
             <a:extLst xmlns:a="http://schemas.openxmlformats.org/drawingml/2006/main">
               <a:ext uri="{FF2B5EF4-FFF2-40B4-BE49-F238E27FC236}">
-                <a16:creationId xmlns:a16="http://schemas.microsoft.com/office/drawing/2014/main" id="{3516476D-F9BD-44A1-A01E-176C1086AD7B}"/>
+                <a16:creationId xmlns:a16="http://schemas.microsoft.com/office/drawing/2014/main" id="{B1FD2396-6F58-4294-A912-AE0F5029388B}"/>
               </a:ext>
             </a:extLst>
           </p:cNvPr>
@@ -25256,7 +25013,7 @@
           <p:cNvPr id="16" name="">
             <a:extLst xmlns:a="http://schemas.openxmlformats.org/drawingml/2006/main">
               <a:ext uri="{FF2B5EF4-FFF2-40B4-BE49-F238E27FC236}">
-                <a16:creationId xmlns:a16="http://schemas.microsoft.com/office/drawing/2014/main" id="{64B0995A-CB2C-480D-8DD6-70EAAFE64B03}"/>
+                <a16:creationId xmlns:a16="http://schemas.microsoft.com/office/drawing/2014/main" id="{DEBCDE78-4D1E-4728-B7B2-91C2CA2D681E}"/>
               </a:ext>
             </a:extLst>
           </p:cNvPr>
@@ -25290,7 +25047,7 @@
           <p:cNvPr id="17" name="">
             <a:extLst xmlns:a="http://schemas.openxmlformats.org/drawingml/2006/main">
               <a:ext uri="{FF2B5EF4-FFF2-40B4-BE49-F238E27FC236}">
-                <a16:creationId xmlns:a16="http://schemas.microsoft.com/office/drawing/2014/main" id="{E633D5FB-7A04-4A38-88D7-7D0B3EB0F684}"/>
+                <a16:creationId xmlns:a16="http://schemas.microsoft.com/office/drawing/2014/main" id="{5480D0BA-EDD6-42D2-BF84-BD5A0A42665D}"/>
               </a:ext>
             </a:extLst>
           </p:cNvPr>
@@ -25347,7 +25104,7 @@
           <p:cNvPr id="18" name="">
             <a:extLst xmlns:a="http://schemas.openxmlformats.org/drawingml/2006/main">
               <a:ext uri="{FF2B5EF4-FFF2-40B4-BE49-F238E27FC236}">
-                <a16:creationId xmlns:a16="http://schemas.microsoft.com/office/drawing/2014/main" id="{D512C916-784B-4997-B5D7-1E2ADC68A9BC}"/>
+                <a16:creationId xmlns:a16="http://schemas.microsoft.com/office/drawing/2014/main" id="{4A87427F-AF23-4602-B7A6-94D29C49BCE0}"/>
               </a:ext>
             </a:extLst>
           </p:cNvPr>
@@ -25404,7 +25161,7 @@
           <p:cNvPr id="19" name="">
             <a:extLst xmlns:a="http://schemas.openxmlformats.org/drawingml/2006/main">
               <a:ext uri="{FF2B5EF4-FFF2-40B4-BE49-F238E27FC236}">
-                <a16:creationId xmlns:a16="http://schemas.microsoft.com/office/drawing/2014/main" id="{74DB8185-CA3E-4CF1-A26D-E885CBD6478B}"/>
+                <a16:creationId xmlns:a16="http://schemas.microsoft.com/office/drawing/2014/main" id="{2B25EBCD-6883-454E-BB9C-D5DC48A07A4C}"/>
               </a:ext>
             </a:extLst>
           </p:cNvPr>
@@ -25461,7 +25218,7 @@
           <p:cNvPr id="20" name="">
             <a:extLst xmlns:a="http://schemas.openxmlformats.org/drawingml/2006/main">
               <a:ext uri="{FF2B5EF4-FFF2-40B4-BE49-F238E27FC236}">
-                <a16:creationId xmlns:a16="http://schemas.microsoft.com/office/drawing/2014/main" id="{B8990D5F-74DF-4FC6-BFD5-566952CFC583}"/>
+                <a16:creationId xmlns:a16="http://schemas.microsoft.com/office/drawing/2014/main" id="{6B28C0E5-6B7D-463F-B61F-F8C4CC4C05E7}"/>
               </a:ext>
             </a:extLst>
           </p:cNvPr>
@@ -25518,7 +25275,7 @@
           <p:cNvPr id="21" name="">
             <a:extLst xmlns:a="http://schemas.openxmlformats.org/drawingml/2006/main">
               <a:ext uri="{FF2B5EF4-FFF2-40B4-BE49-F238E27FC236}">
-                <a16:creationId xmlns:a16="http://schemas.microsoft.com/office/drawing/2014/main" id="{D1DFD6AF-AC18-466D-959E-66D61E3FADCC}"/>
+                <a16:creationId xmlns:a16="http://schemas.microsoft.com/office/drawing/2014/main" id="{05747BEE-240C-4583-8CE0-597C8AF212F7}"/>
               </a:ext>
             </a:extLst>
           </p:cNvPr>
@@ -25575,7 +25332,7 @@
           <p:cNvPr id="22" name="">
             <a:extLst xmlns:a="http://schemas.openxmlformats.org/drawingml/2006/main">
               <a:ext uri="{FF2B5EF4-FFF2-40B4-BE49-F238E27FC236}">
-                <a16:creationId xmlns:a16="http://schemas.microsoft.com/office/drawing/2014/main" id="{91757BF9-D8CA-40B6-8435-9256BAE595E0}"/>
+                <a16:creationId xmlns:a16="http://schemas.microsoft.com/office/drawing/2014/main" id="{E8A99EDC-41FA-4E1F-9C27-4D0647C180A4}"/>
               </a:ext>
             </a:extLst>
           </p:cNvPr>
@@ -25609,7 +25366,7 @@
           <p:cNvPr id="23" name="">
             <a:extLst xmlns:a="http://schemas.openxmlformats.org/drawingml/2006/main">
               <a:ext uri="{FF2B5EF4-FFF2-40B4-BE49-F238E27FC236}">
-                <a16:creationId xmlns:a16="http://schemas.microsoft.com/office/drawing/2014/main" id="{B0D15845-D063-45F5-8309-E04775BA2C1E}"/>
+                <a16:creationId xmlns:a16="http://schemas.microsoft.com/office/drawing/2014/main" id="{AC9ABE13-B12D-4D51-B720-21D3C2B915B7}"/>
               </a:ext>
             </a:extLst>
           </p:cNvPr>
@@ -25666,7 +25423,7 @@
           <p:cNvPr id="24" name="">
             <a:extLst xmlns:a="http://schemas.openxmlformats.org/drawingml/2006/main">
               <a:ext uri="{FF2B5EF4-FFF2-40B4-BE49-F238E27FC236}">
-                <a16:creationId xmlns:a16="http://schemas.microsoft.com/office/drawing/2014/main" id="{FBB4A6D4-77E9-47DE-9950-48B309F4B28C}"/>
+                <a16:creationId xmlns:a16="http://schemas.microsoft.com/office/drawing/2014/main" id="{04DA158F-95F5-496A-AE9C-E47980BC77A2}"/>
               </a:ext>
             </a:extLst>
           </p:cNvPr>
@@ -25723,7 +25480,7 @@
           <p:cNvPr id="25" name="">
             <a:extLst xmlns:a="http://schemas.openxmlformats.org/drawingml/2006/main">
               <a:ext uri="{FF2B5EF4-FFF2-40B4-BE49-F238E27FC236}">
-                <a16:creationId xmlns:a16="http://schemas.microsoft.com/office/drawing/2014/main" id="{F4036D35-F212-4F4B-ADA1-EE2BC4118205}"/>
+                <a16:creationId xmlns:a16="http://schemas.microsoft.com/office/drawing/2014/main" id="{3095D81A-8754-41F1-AB4A-2A684CF86836}"/>
               </a:ext>
             </a:extLst>
           </p:cNvPr>
@@ -25780,7 +25537,7 @@
           <p:cNvPr id="26" name="">
             <a:extLst xmlns:a="http://schemas.openxmlformats.org/drawingml/2006/main">
               <a:ext uri="{FF2B5EF4-FFF2-40B4-BE49-F238E27FC236}">
-                <a16:creationId xmlns:a16="http://schemas.microsoft.com/office/drawing/2014/main" id="{FBBD2551-7931-41B7-99CF-CD1B57B211C8}"/>
+                <a16:creationId xmlns:a16="http://schemas.microsoft.com/office/drawing/2014/main" id="{0865634A-346A-41FC-B192-A9628B77B250}"/>
               </a:ext>
             </a:extLst>
           </p:cNvPr>
@@ -25837,7 +25594,7 @@
           <p:cNvPr id="27" name="">
             <a:extLst xmlns:a="http://schemas.openxmlformats.org/drawingml/2006/main">
               <a:ext uri="{FF2B5EF4-FFF2-40B4-BE49-F238E27FC236}">
-                <a16:creationId xmlns:a16="http://schemas.microsoft.com/office/drawing/2014/main" id="{5A057D0F-14DB-44AB-9A11-840BC16DB6DD}"/>
+                <a16:creationId xmlns:a16="http://schemas.microsoft.com/office/drawing/2014/main" id="{B81AC212-6399-42E4-AD93-CED730E76C87}"/>
               </a:ext>
             </a:extLst>
           </p:cNvPr>
@@ -25894,7 +25651,7 @@
           <p:cNvPr id="28" name="">
             <a:extLst xmlns:a="http://schemas.openxmlformats.org/drawingml/2006/main">
               <a:ext uri="{FF2B5EF4-FFF2-40B4-BE49-F238E27FC236}">
-                <a16:creationId xmlns:a16="http://schemas.microsoft.com/office/drawing/2014/main" id="{C41F3BDA-956A-4C3E-A7A9-C1B3245B67E8}"/>
+                <a16:creationId xmlns:a16="http://schemas.microsoft.com/office/drawing/2014/main" id="{C2192E12-19DC-47CE-AB85-2FD51619E682}"/>
               </a:ext>
             </a:extLst>
           </p:cNvPr>
@@ -25928,7 +25685,7 @@
           <p:cNvPr id="29" name="">
             <a:extLst xmlns:a="http://schemas.openxmlformats.org/drawingml/2006/main">
               <a:ext uri="{FF2B5EF4-FFF2-40B4-BE49-F238E27FC236}">
-                <a16:creationId xmlns:a16="http://schemas.microsoft.com/office/drawing/2014/main" id="{B2C48984-C9AD-41E7-BF6A-2694C08399D3}"/>
+                <a16:creationId xmlns:a16="http://schemas.microsoft.com/office/drawing/2014/main" id="{30248A22-93FE-41F5-837B-4E6ACF63128D}"/>
               </a:ext>
             </a:extLst>
           </p:cNvPr>
@@ -25985,7 +25742,7 @@
           <p:cNvPr id="30" name="">
             <a:extLst xmlns:a="http://schemas.openxmlformats.org/drawingml/2006/main">
               <a:ext uri="{FF2B5EF4-FFF2-40B4-BE49-F238E27FC236}">
-                <a16:creationId xmlns:a16="http://schemas.microsoft.com/office/drawing/2014/main" id="{8C4A565F-306A-4D07-AB21-303576F7628D}"/>
+                <a16:creationId xmlns:a16="http://schemas.microsoft.com/office/drawing/2014/main" id="{20F86DFF-014C-4BCF-8150-C72CD1C251B5}"/>
               </a:ext>
             </a:extLst>
           </p:cNvPr>
@@ -26042,7 +25799,7 @@
           <p:cNvPr id="31" name="">
             <a:extLst xmlns:a="http://schemas.openxmlformats.org/drawingml/2006/main">
               <a:ext uri="{FF2B5EF4-FFF2-40B4-BE49-F238E27FC236}">
-                <a16:creationId xmlns:a16="http://schemas.microsoft.com/office/drawing/2014/main" id="{7C683ADB-C0A0-46EA-9BD7-E8F740937B3A}"/>
+                <a16:creationId xmlns:a16="http://schemas.microsoft.com/office/drawing/2014/main" id="{1527341E-39E1-4A14-AEC7-A4D4C657F030}"/>
               </a:ext>
             </a:extLst>
           </p:cNvPr>
@@ -26099,7 +25856,7 @@
           <p:cNvPr id="32" name="">
             <a:extLst xmlns:a="http://schemas.openxmlformats.org/drawingml/2006/main">
               <a:ext uri="{FF2B5EF4-FFF2-40B4-BE49-F238E27FC236}">
-                <a16:creationId xmlns:a16="http://schemas.microsoft.com/office/drawing/2014/main" id="{F4956BB9-BF15-4A20-8B4D-84F190CB1E06}"/>
+                <a16:creationId xmlns:a16="http://schemas.microsoft.com/office/drawing/2014/main" id="{9A1F8552-E629-4BC7-B375-5A35EB527705}"/>
               </a:ext>
             </a:extLst>
           </p:cNvPr>
@@ -26156,7 +25913,7 @@
           <p:cNvPr id="33" name="">
             <a:extLst xmlns:a="http://schemas.openxmlformats.org/drawingml/2006/main">
               <a:ext uri="{FF2B5EF4-FFF2-40B4-BE49-F238E27FC236}">
-                <a16:creationId xmlns:a16="http://schemas.microsoft.com/office/drawing/2014/main" id="{1349C2FC-45AC-4BC9-8A46-A4C609FE0426}"/>
+                <a16:creationId xmlns:a16="http://schemas.microsoft.com/office/drawing/2014/main" id="{8ED12193-CF3F-4A70-BDF0-CE5060E1CBF9}"/>
               </a:ext>
             </a:extLst>
           </p:cNvPr>
@@ -26213,7 +25970,7 @@
           <p:cNvPr id="34" name="">
             <a:extLst xmlns:a="http://schemas.openxmlformats.org/drawingml/2006/main">
               <a:ext uri="{FF2B5EF4-FFF2-40B4-BE49-F238E27FC236}">
-                <a16:creationId xmlns:a16="http://schemas.microsoft.com/office/drawing/2014/main" id="{82E87F8D-FFB7-490C-8046-89E310AC40A0}"/>
+                <a16:creationId xmlns:a16="http://schemas.microsoft.com/office/drawing/2014/main" id="{183E592C-E8AF-432A-9C76-008B5E0578DA}"/>
               </a:ext>
             </a:extLst>
           </p:cNvPr>
@@ -26245,7 +26002,7 @@
           <p:cNvPr id="35" name="">
             <a:extLst xmlns:a="http://schemas.openxmlformats.org/drawingml/2006/main">
               <a:ext uri="{FF2B5EF4-FFF2-40B4-BE49-F238E27FC236}">
-                <a16:creationId xmlns:a16="http://schemas.microsoft.com/office/drawing/2014/main" id="{4BBE22D7-C93A-4E90-BEFB-DCAA0C3F6B9C}"/>
+                <a16:creationId xmlns:a16="http://schemas.microsoft.com/office/drawing/2014/main" id="{294802A9-8909-443C-8785-43F0649AB092}"/>
               </a:ext>
             </a:extLst>
           </p:cNvPr>
@@ -26300,7 +26057,7 @@
     </p:spTree>
     <p:extLst>
       <p:ext uri="{BB962C8B-B14F-4D97-AF65-F5344CB8AC3E}">
-        <p14:creationId xmlns:p14="http://schemas.microsoft.com/office/powerpoint/2010/main" val="1788883508"/>
+        <p14:creationId xmlns:p14="http://schemas.microsoft.com/office/powerpoint/2010/main" val="45649306"/>
       </p:ext>
     </p:extLst>
   </p:cSld>

</xml_diff>